<commit_message>
Added content to presentation
</commit_message>
<xml_diff>
--- a/Elasticsearch.pptx
+++ b/Elasticsearch.pptx
@@ -5,7 +5,7 @@
     <p:sldMasterId id="2147484165" r:id="rId1"/>
   </p:sldMasterIdLst>
   <p:notesMasterIdLst>
-    <p:notesMasterId r:id="rId15"/>
+    <p:notesMasterId r:id="rId18"/>
   </p:notesMasterIdLst>
   <p:sldIdLst>
     <p:sldId id="256" r:id="rId2"/>
@@ -16,11 +16,14 @@
     <p:sldId id="269" r:id="rId7"/>
     <p:sldId id="261" r:id="rId8"/>
     <p:sldId id="263" r:id="rId9"/>
-    <p:sldId id="262" r:id="rId10"/>
-    <p:sldId id="264" r:id="rId11"/>
+    <p:sldId id="270" r:id="rId10"/>
+    <p:sldId id="271" r:id="rId11"/>
     <p:sldId id="265" r:id="rId12"/>
-    <p:sldId id="266" r:id="rId13"/>
-    <p:sldId id="267" r:id="rId14"/>
+    <p:sldId id="273" r:id="rId13"/>
+    <p:sldId id="262" r:id="rId14"/>
+    <p:sldId id="272" r:id="rId15"/>
+    <p:sldId id="266" r:id="rId16"/>
+    <p:sldId id="267" r:id="rId17"/>
   </p:sldIdLst>
   <p:sldSz cx="12192000" cy="6858000"/>
   <p:notesSz cx="6858000" cy="9144000"/>
@@ -119,6 +122,11 @@
       </a:defRPr>
     </a:lvl9pPr>
   </p:defaultTextStyle>
+  <p:extLst>
+    <p:ext uri="{EFAFB233-063F-42B5-8137-9DF3F51BA10A}">
+      <p15:sldGuideLst xmlns:p15="http://schemas.microsoft.com/office/powerpoint/2012/main"/>
+    </p:ext>
+  </p:extLst>
 </p:presentation>
 </file>
 
@@ -204,7 +212,7 @@
           <a:p>
             <a:fld id="{17C1BCD2-C187-B342-9D66-FD6DDE94747E}" type="datetimeFigureOut">
               <a:rPr lang="en-AT" smtClean="0"/>
-              <a:t>01.05.26</a:t>
+              <a:t>04.05.26</a:t>
             </a:fld>
             <a:endParaRPr lang="en-AT"/>
           </a:p>
@@ -620,6 +628,544 @@
         <p:cNvPr id="1" name="">
           <a:extLst>
             <a:ext uri="{FF2B5EF4-FFF2-40B4-BE49-F238E27FC236}">
+              <a16:creationId xmlns:a16="http://schemas.microsoft.com/office/drawing/2014/main" id="{354ECCA7-4D49-FE9D-9AA0-C3CB76DD1EB5}"/>
+            </a:ext>
+          </a:extLst>
+        </p:cNvPr>
+        <p:cNvGrpSpPr/>
+        <p:nvPr/>
+      </p:nvGrpSpPr>
+      <p:grpSpPr>
+        <a:xfrm>
+          <a:off x="0" y="0"/>
+          <a:ext cx="0" cy="0"/>
+          <a:chOff x="0" y="0"/>
+          <a:chExt cx="0" cy="0"/>
+        </a:xfrm>
+      </p:grpSpPr>
+      <p:sp>
+        <p:nvSpPr>
+          <p:cNvPr id="2" name="Slide Image Placeholder 1">
+            <a:extLst>
+              <a:ext uri="{FF2B5EF4-FFF2-40B4-BE49-F238E27FC236}">
+                <a16:creationId xmlns:a16="http://schemas.microsoft.com/office/drawing/2014/main" id="{85D7BFCF-DEC2-04F1-6C27-42E13108757D}"/>
+              </a:ext>
+            </a:extLst>
+          </p:cNvPr>
+          <p:cNvSpPr>
+            <a:spLocks noGrp="1" noRot="1" noChangeAspect="1"/>
+          </p:cNvSpPr>
+          <p:nvPr>
+            <p:ph type="sldImg"/>
+          </p:nvPr>
+        </p:nvSpPr>
+        <p:spPr/>
+      </p:sp>
+      <p:sp>
+        <p:nvSpPr>
+          <p:cNvPr id="3" name="Notes Placeholder 2">
+            <a:extLst>
+              <a:ext uri="{FF2B5EF4-FFF2-40B4-BE49-F238E27FC236}">
+                <a16:creationId xmlns:a16="http://schemas.microsoft.com/office/drawing/2014/main" id="{D33DC1BF-37AC-E219-C92F-9A486435762D}"/>
+              </a:ext>
+            </a:extLst>
+          </p:cNvPr>
+          <p:cNvSpPr>
+            <a:spLocks noGrp="1"/>
+          </p:cNvSpPr>
+          <p:nvPr>
+            <p:ph type="body" idx="1"/>
+          </p:nvPr>
+        </p:nvSpPr>
+        <p:spPr/>
+        <p:txBody>
+          <a:bodyPr/>
+          <a:lstStyle/>
+          <a:p>
+            <a:pPr lvl="1"/>
+            <a:r>
+              <a:rPr lang="en-AT" dirty="0"/>
+              <a:t>Aggregations over sales figures, user behavior or financial records generate dashboards and reports without requiring a separate BI platform.</a:t>
+            </a:r>
+            <a:br>
+              <a:rPr lang="en-AT" dirty="0"/>
+            </a:br>
+            <a:r>
+              <a:rPr lang="en-GB" dirty="0" err="1"/>
+              <a:t>Aggregationen</a:t>
+            </a:r>
+            <a:r>
+              <a:rPr lang="en-GB" dirty="0"/>
+              <a:t> von </a:t>
+            </a:r>
+            <a:r>
+              <a:rPr lang="en-GB" dirty="0" err="1"/>
+              <a:t>Verkaufszahlen</a:t>
+            </a:r>
+            <a:r>
+              <a:rPr lang="en-GB" dirty="0"/>
+              <a:t>, </a:t>
+            </a:r>
+            <a:r>
+              <a:rPr lang="en-GB" dirty="0" err="1"/>
+              <a:t>Nutzerverhalten</a:t>
+            </a:r>
+            <a:r>
+              <a:rPr lang="en-GB" dirty="0"/>
+              <a:t> </a:t>
+            </a:r>
+            <a:r>
+              <a:rPr lang="en-GB" dirty="0" err="1"/>
+              <a:t>oder</a:t>
+            </a:r>
+            <a:r>
+              <a:rPr lang="en-GB" dirty="0"/>
+              <a:t> </a:t>
+            </a:r>
+            <a:r>
+              <a:rPr lang="en-GB" dirty="0" err="1"/>
+              <a:t>Finanzdaten</a:t>
+            </a:r>
+            <a:r>
+              <a:rPr lang="en-GB" dirty="0"/>
+              <a:t> </a:t>
+            </a:r>
+            <a:r>
+              <a:rPr lang="en-GB" dirty="0" err="1"/>
+              <a:t>ermöglichen</a:t>
+            </a:r>
+            <a:r>
+              <a:rPr lang="en-GB" dirty="0"/>
+              <a:t> die </a:t>
+            </a:r>
+            <a:r>
+              <a:rPr lang="en-GB" dirty="0" err="1"/>
+              <a:t>Erstellung</a:t>
+            </a:r>
+            <a:r>
+              <a:rPr lang="en-GB" dirty="0"/>
+              <a:t> von Dashboards und </a:t>
+            </a:r>
+            <a:r>
+              <a:rPr lang="en-GB" dirty="0" err="1"/>
+              <a:t>Berichten</a:t>
+            </a:r>
+            <a:r>
+              <a:rPr lang="en-GB" dirty="0"/>
+              <a:t>, </a:t>
+            </a:r>
+            <a:r>
+              <a:rPr lang="en-GB" dirty="0" err="1"/>
+              <a:t>ohne</a:t>
+            </a:r>
+            <a:r>
+              <a:rPr lang="en-GB" dirty="0"/>
+              <a:t> </a:t>
+            </a:r>
+            <a:r>
+              <a:rPr lang="en-GB" dirty="0" err="1"/>
+              <a:t>dass</a:t>
+            </a:r>
+            <a:r>
+              <a:rPr lang="en-GB" dirty="0"/>
+              <a:t> </a:t>
+            </a:r>
+            <a:r>
+              <a:rPr lang="en-GB" dirty="0" err="1"/>
+              <a:t>eine</a:t>
+            </a:r>
+            <a:r>
+              <a:rPr lang="en-GB" dirty="0"/>
+              <a:t> separate BI-</a:t>
+            </a:r>
+            <a:r>
+              <a:rPr lang="en-GB" dirty="0" err="1"/>
+              <a:t>Plattform</a:t>
+            </a:r>
+            <a:r>
+              <a:rPr lang="en-GB" dirty="0"/>
+              <a:t> </a:t>
+            </a:r>
+            <a:r>
+              <a:rPr lang="en-GB" dirty="0" err="1"/>
+              <a:t>erforderlich</a:t>
+            </a:r>
+            <a:r>
+              <a:rPr lang="en-GB" dirty="0"/>
+              <a:t> </a:t>
+            </a:r>
+            <a:r>
+              <a:rPr lang="en-GB" dirty="0" err="1"/>
+              <a:t>ist</a:t>
+            </a:r>
+            <a:r>
+              <a:rPr lang="en-GB" dirty="0"/>
+              <a:t>.</a:t>
+            </a:r>
+            <a:endParaRPr lang="en-AT" dirty="0"/>
+          </a:p>
+          <a:p>
+            <a:pPr lvl="1"/>
+            <a:r>
+              <a:rPr lang="en-AT" dirty="0"/>
+              <a:t>geo_point fields allow proximity queries, radius filters and map-based visualizations — used in booking platforms, logistics and asset tracking</a:t>
+            </a:r>
+          </a:p>
+        </p:txBody>
+      </p:sp>
+      <p:sp>
+        <p:nvSpPr>
+          <p:cNvPr id="4" name="Slide Number Placeholder 3">
+            <a:extLst>
+              <a:ext uri="{FF2B5EF4-FFF2-40B4-BE49-F238E27FC236}">
+                <a16:creationId xmlns:a16="http://schemas.microsoft.com/office/drawing/2014/main" id="{A56098C9-5013-0958-709C-AFD18D7C1F2C}"/>
+              </a:ext>
+            </a:extLst>
+          </p:cNvPr>
+          <p:cNvSpPr>
+            <a:spLocks noGrp="1"/>
+          </p:cNvSpPr>
+          <p:nvPr>
+            <p:ph type="sldNum" sz="quarter" idx="5"/>
+          </p:nvPr>
+        </p:nvSpPr>
+        <p:spPr/>
+        <p:txBody>
+          <a:bodyPr/>
+          <a:lstStyle/>
+          <a:p>
+            <a:fld id="{C9565C50-69E9-8E49-A3AB-C69605F3BCD6}" type="slidenum">
+              <a:rPr lang="en-AT" smtClean="0"/>
+              <a:t>13</a:t>
+            </a:fld>
+            <a:endParaRPr lang="en-AT"/>
+          </a:p>
+        </p:txBody>
+      </p:sp>
+    </p:spTree>
+    <p:extLst>
+      <p:ext uri="{BB962C8B-B14F-4D97-AF65-F5344CB8AC3E}">
+        <p14:creationId xmlns:p14="http://schemas.microsoft.com/office/powerpoint/2010/main" val="2356324315"/>
+      </p:ext>
+    </p:extLst>
+  </p:cSld>
+  <p:clrMapOvr>
+    <a:masterClrMapping/>
+  </p:clrMapOvr>
+</p:notes>
+</file>
+
+<file path=ppt/notesSlides/notesSlide11.xml><?xml version="1.0" encoding="utf-8"?>
+<p:notes xmlns:a="http://schemas.openxmlformats.org/drawingml/2006/main" xmlns:r="http://schemas.openxmlformats.org/officeDocument/2006/relationships" xmlns:p="http://schemas.openxmlformats.org/presentationml/2006/main">
+  <p:cSld>
+    <p:spTree>
+      <p:nvGrpSpPr>
+        <p:cNvPr id="1" name=""/>
+        <p:cNvGrpSpPr/>
+        <p:nvPr/>
+      </p:nvGrpSpPr>
+      <p:grpSpPr>
+        <a:xfrm>
+          <a:off x="0" y="0"/>
+          <a:ext cx="0" cy="0"/>
+          <a:chOff x="0" y="0"/>
+          <a:chExt cx="0" cy="0"/>
+        </a:xfrm>
+      </p:grpSpPr>
+      <p:sp>
+        <p:nvSpPr>
+          <p:cNvPr id="2" name="Slide Image Placeholder 1"/>
+          <p:cNvSpPr>
+            <a:spLocks noGrp="1" noRot="1" noChangeAspect="1"/>
+          </p:cNvSpPr>
+          <p:nvPr>
+            <p:ph type="sldImg"/>
+          </p:nvPr>
+        </p:nvSpPr>
+        <p:spPr/>
+      </p:sp>
+      <p:sp>
+        <p:nvSpPr>
+          <p:cNvPr id="3" name="Notes Placeholder 2"/>
+          <p:cNvSpPr>
+            <a:spLocks noGrp="1"/>
+          </p:cNvSpPr>
+          <p:nvPr>
+            <p:ph type="body" idx="1"/>
+          </p:nvPr>
+        </p:nvSpPr>
+        <p:spPr/>
+        <p:txBody>
+          <a:bodyPr/>
+          <a:lstStyle/>
+          <a:p>
+            <a:pPr lvl="1"/>
+            <a:r>
+              <a:rPr lang="en-AT" dirty="0"/>
+              <a:t>Horizontal scalability — new nodes can be added to a cluster at any time to absorb growing data volumes and query loads.</a:t>
+            </a:r>
+          </a:p>
+          <a:p>
+            <a:pPr lvl="1"/>
+            <a:r>
+              <a:rPr lang="en-AT" dirty="0"/>
+              <a:t>Near real-time search and analytics — the inverted index delivers results across terabytes of data in milliseconds.</a:t>
+            </a:r>
+          </a:p>
+          <a:p>
+            <a:pPr lvl="1"/>
+            <a:r>
+              <a:rPr lang="en-AT" dirty="0"/>
+              <a:t>Flexible Query DSL — supports full-text, fuzzy, geo, bool, range and aggregation queries all in one system.</a:t>
+            </a:r>
+          </a:p>
+          <a:p>
+            <a:pPr lvl="1"/>
+            <a:r>
+              <a:rPr lang="en-AT" dirty="0"/>
+              <a:t>Rich ecosystem — Kibana, Logstash and Beats cover visualization, ingestion and data shipping out of the box.</a:t>
+            </a:r>
+          </a:p>
+          <a:p>
+            <a:pPr lvl="1"/>
+            <a:br>
+              <a:rPr lang="en-AT" dirty="0"/>
+            </a:br>
+            <a:br>
+              <a:rPr lang="en-AT" dirty="0"/>
+            </a:br>
+            <a:r>
+              <a:rPr lang="en-AT" dirty="0"/>
+              <a:t>Complex setup — cluster sizing, JVM tuning, shard allocation and security configuration demand significant expertise.</a:t>
+            </a:r>
+          </a:p>
+          <a:p>
+            <a:pPr lvl="1"/>
+            <a:r>
+              <a:rPr lang="en-AT" dirty="0"/>
+              <a:t>Resource intensive — even moderate deployments require substantial CPU, memory and disk; under-provisioning causes instability.</a:t>
+            </a:r>
+          </a:p>
+          <a:p>
+            <a:pPr lvl="1"/>
+            <a:r>
+              <a:rPr lang="en-AT" dirty="0"/>
+              <a:t>No ACID transactions — only eventual consistency, making it unsuitable for use cases that require strict data integrity.</a:t>
+            </a:r>
+          </a:p>
+          <a:p>
+            <a:endParaRPr lang="en-AT" dirty="0"/>
+          </a:p>
+        </p:txBody>
+      </p:sp>
+      <p:sp>
+        <p:nvSpPr>
+          <p:cNvPr id="4" name="Slide Number Placeholder 3"/>
+          <p:cNvSpPr>
+            <a:spLocks noGrp="1"/>
+          </p:cNvSpPr>
+          <p:nvPr>
+            <p:ph type="sldNum" sz="quarter" idx="5"/>
+          </p:nvPr>
+        </p:nvSpPr>
+        <p:spPr/>
+        <p:txBody>
+          <a:bodyPr/>
+          <a:lstStyle/>
+          <a:p>
+            <a:fld id="{C9565C50-69E9-8E49-A3AB-C69605F3BCD6}" type="slidenum">
+              <a:rPr lang="en-AT" smtClean="0"/>
+              <a:t>14</a:t>
+            </a:fld>
+            <a:endParaRPr lang="en-AT"/>
+          </a:p>
+        </p:txBody>
+      </p:sp>
+    </p:spTree>
+    <p:extLst>
+      <p:ext uri="{BB962C8B-B14F-4D97-AF65-F5344CB8AC3E}">
+        <p14:creationId xmlns:p14="http://schemas.microsoft.com/office/powerpoint/2010/main" val="1577341775"/>
+      </p:ext>
+    </p:extLst>
+  </p:cSld>
+  <p:clrMapOvr>
+    <a:masterClrMapping/>
+  </p:clrMapOvr>
+</p:notes>
+</file>
+
+<file path=ppt/notesSlides/notesSlide12.xml><?xml version="1.0" encoding="utf-8"?>
+<p:notes xmlns:a="http://schemas.openxmlformats.org/drawingml/2006/main" xmlns:r="http://schemas.openxmlformats.org/officeDocument/2006/relationships" xmlns:p="http://schemas.openxmlformats.org/presentationml/2006/main">
+  <p:cSld>
+    <p:spTree>
+      <p:nvGrpSpPr>
+        <p:cNvPr id="1" name="">
+          <a:extLst>
+            <a:ext uri="{FF2B5EF4-FFF2-40B4-BE49-F238E27FC236}">
+              <a16:creationId xmlns:a16="http://schemas.microsoft.com/office/drawing/2014/main" id="{DBFE9B7A-2047-D6D3-11BC-54F37C4C8A71}"/>
+            </a:ext>
+          </a:extLst>
+        </p:cNvPr>
+        <p:cNvGrpSpPr/>
+        <p:nvPr/>
+      </p:nvGrpSpPr>
+      <p:grpSpPr>
+        <a:xfrm>
+          <a:off x="0" y="0"/>
+          <a:ext cx="0" cy="0"/>
+          <a:chOff x="0" y="0"/>
+          <a:chExt cx="0" cy="0"/>
+        </a:xfrm>
+      </p:grpSpPr>
+      <p:sp>
+        <p:nvSpPr>
+          <p:cNvPr id="2" name="Slide Image Placeholder 1">
+            <a:extLst>
+              <a:ext uri="{FF2B5EF4-FFF2-40B4-BE49-F238E27FC236}">
+                <a16:creationId xmlns:a16="http://schemas.microsoft.com/office/drawing/2014/main" id="{B4360CA5-BEB2-E327-F211-9F8D85CBA393}"/>
+              </a:ext>
+            </a:extLst>
+          </p:cNvPr>
+          <p:cNvSpPr>
+            <a:spLocks noGrp="1" noRot="1" noChangeAspect="1"/>
+          </p:cNvSpPr>
+          <p:nvPr>
+            <p:ph type="sldImg"/>
+          </p:nvPr>
+        </p:nvSpPr>
+        <p:spPr/>
+      </p:sp>
+      <p:sp>
+        <p:nvSpPr>
+          <p:cNvPr id="3" name="Notes Placeholder 2">
+            <a:extLst>
+              <a:ext uri="{FF2B5EF4-FFF2-40B4-BE49-F238E27FC236}">
+                <a16:creationId xmlns:a16="http://schemas.microsoft.com/office/drawing/2014/main" id="{CFDA3D05-C486-3039-BE33-C040DA900A14}"/>
+              </a:ext>
+            </a:extLst>
+          </p:cNvPr>
+          <p:cNvSpPr>
+            <a:spLocks noGrp="1"/>
+          </p:cNvSpPr>
+          <p:nvPr>
+            <p:ph type="body" idx="1"/>
+          </p:nvPr>
+        </p:nvSpPr>
+        <p:spPr/>
+        <p:txBody>
+          <a:bodyPr/>
+          <a:lstStyle/>
+          <a:p>
+            <a:pPr marL="0" marR="0" lvl="0" indent="0" algn="l" defTabSz="914400" rtl="0" eaLnBrk="1" fontAlgn="auto" latinLnBrk="0" hangingPunct="1">
+              <a:lnSpc>
+                <a:spcPct val="100000"/>
+              </a:lnSpc>
+              <a:spcBef>
+                <a:spcPts val="0"/>
+              </a:spcBef>
+              <a:spcAft>
+                <a:spcPts val="0"/>
+              </a:spcAft>
+              <a:buClrTx/>
+              <a:buSzTx/>
+              <a:buFontTx/>
+              <a:buNone/>
+              <a:tabLst/>
+              <a:defRPr/>
+            </a:pPr>
+            <a:r>
+              <a:rPr lang="en-GB" sz="1200" b="0" i="0" kern="1200" dirty="0">
+                <a:solidFill>
+                  <a:schemeClr val="tx1"/>
+                </a:solidFill>
+                <a:effectLst/>
+                <a:latin typeface="+mn-lt"/>
+                <a:ea typeface="+mn-ea"/>
+                <a:cs typeface="+mn-cs"/>
+              </a:rPr>
+              <a:t>Elasticsearch stores data in </a:t>
+            </a:r>
+            <a:r>
+              <a:rPr lang="en-GB" sz="1200" b="0" i="0" u="sng" kern="1200" dirty="0">
+                <a:solidFill>
+                  <a:schemeClr val="tx1"/>
+                </a:solidFill>
+                <a:effectLst/>
+                <a:latin typeface="+mn-lt"/>
+                <a:ea typeface="+mn-ea"/>
+                <a:cs typeface="+mn-cs"/>
+                <a:hlinkClick r:id="rId3"/>
+              </a:rPr>
+              <a:t>JSON </a:t>
+            </a:r>
+            <a:r>
+              <a:rPr lang="en-GB" sz="1200" b="0" i="0" kern="1200" dirty="0">
+                <a:solidFill>
+                  <a:schemeClr val="tx1"/>
+                </a:solidFill>
+                <a:effectLst/>
+                <a:latin typeface="+mn-lt"/>
+                <a:ea typeface="+mn-ea"/>
+                <a:cs typeface="+mn-cs"/>
+              </a:rPr>
+              <a:t>format and making it easy to index and search structured and unstructured data.</a:t>
+            </a:r>
+          </a:p>
+          <a:p>
+            <a:endParaRPr lang="en-AT" dirty="0"/>
+          </a:p>
+        </p:txBody>
+      </p:sp>
+      <p:sp>
+        <p:nvSpPr>
+          <p:cNvPr id="4" name="Slide Number Placeholder 3">
+            <a:extLst>
+              <a:ext uri="{FF2B5EF4-FFF2-40B4-BE49-F238E27FC236}">
+                <a16:creationId xmlns:a16="http://schemas.microsoft.com/office/drawing/2014/main" id="{17360B0D-1C08-4B2A-A34B-73A56EE7BA80}"/>
+              </a:ext>
+            </a:extLst>
+          </p:cNvPr>
+          <p:cNvSpPr>
+            <a:spLocks noGrp="1"/>
+          </p:cNvSpPr>
+          <p:nvPr>
+            <p:ph type="sldNum" sz="quarter" idx="5"/>
+          </p:nvPr>
+        </p:nvSpPr>
+        <p:spPr/>
+        <p:txBody>
+          <a:bodyPr/>
+          <a:lstStyle/>
+          <a:p>
+            <a:fld id="{C9565C50-69E9-8E49-A3AB-C69605F3BCD6}" type="slidenum">
+              <a:rPr lang="en-AT" smtClean="0"/>
+              <a:t>15</a:t>
+            </a:fld>
+            <a:endParaRPr lang="en-AT"/>
+          </a:p>
+        </p:txBody>
+      </p:sp>
+    </p:spTree>
+    <p:extLst>
+      <p:ext uri="{BB962C8B-B14F-4D97-AF65-F5344CB8AC3E}">
+        <p14:creationId xmlns:p14="http://schemas.microsoft.com/office/powerpoint/2010/main" val="2434815636"/>
+      </p:ext>
+    </p:extLst>
+  </p:cSld>
+  <p:clrMapOvr>
+    <a:masterClrMapping/>
+  </p:clrMapOvr>
+</p:notes>
+</file>
+
+<file path=ppt/notesSlides/notesSlide13.xml><?xml version="1.0" encoding="utf-8"?>
+<p:notes xmlns:a="http://schemas.openxmlformats.org/drawingml/2006/main" xmlns:r="http://schemas.openxmlformats.org/officeDocument/2006/relationships" xmlns:p="http://schemas.openxmlformats.org/presentationml/2006/main">
+  <p:cSld>
+    <p:spTree>
+      <p:nvGrpSpPr>
+        <p:cNvPr id="1" name="">
+          <a:extLst>
+            <a:ext uri="{FF2B5EF4-FFF2-40B4-BE49-F238E27FC236}">
               <a16:creationId xmlns:a16="http://schemas.microsoft.com/office/drawing/2014/main" id="{94A48B5A-D00A-4259-F4BF-FE60949CF96C}"/>
             </a:ext>
           </a:extLst>
@@ -701,7 +1247,7 @@
           <a:p>
             <a:fld id="{C9565C50-69E9-8E49-A3AB-C69605F3BCD6}" type="slidenum">
               <a:rPr lang="en-AT" smtClean="0"/>
-              <a:t>13</a:t>
+              <a:t>16</a:t>
             </a:fld>
             <a:endParaRPr lang="en-AT"/>
           </a:p>
@@ -1138,7 +1684,7 @@
           <a:bodyPr/>
           <a:lstStyle/>
           <a:p>
-            <a:pPr marL="0" marR="0" lvl="0" indent="0" algn="l" defTabSz="914400" rtl="0" eaLnBrk="1" fontAlgn="auto" latinLnBrk="0" hangingPunct="1">
+            <a:pPr marL="171450" marR="0" lvl="0" indent="-171450" algn="l" defTabSz="914400" rtl="0" eaLnBrk="1" fontAlgn="auto" latinLnBrk="0" hangingPunct="1">
               <a:lnSpc>
                 <a:spcPct val="100000"/>
               </a:lnSpc>
@@ -1150,13 +1696,13 @@
               </a:spcAft>
               <a:buClrTx/>
               <a:buSzTx/>
-              <a:buFontTx/>
-              <a:buNone/>
+              <a:buFont typeface="Arial" panose="020B0604020202020204" pitchFamily="34" charset="0"/>
+              <a:buChar char="•"/>
               <a:tabLst/>
               <a:defRPr/>
             </a:pPr>
             <a:r>
-              <a:rPr lang="en-GB" sz="1200" b="0" i="0" kern="1200" dirty="0">
+              <a:rPr lang="en-GB" sz="1200" b="0" i="0" u="none" strike="noStrike" kern="1200" dirty="0">
                 <a:solidFill>
                   <a:schemeClr val="tx1"/>
                 </a:solidFill>
@@ -1165,23 +1711,10 @@
                 <a:ea typeface="+mn-ea"/>
                 <a:cs typeface="+mn-cs"/>
               </a:rPr>
-              <a:t>Elasticsearch stores data in </a:t>
-            </a:r>
-            <a:r>
-              <a:rPr lang="en-GB" sz="1200" b="0" i="0" u="sng" kern="1200" dirty="0">
-                <a:solidFill>
-                  <a:schemeClr val="tx1"/>
-                </a:solidFill>
-                <a:effectLst/>
-                <a:latin typeface="+mn-lt"/>
-                <a:ea typeface="+mn-ea"/>
-                <a:cs typeface="+mn-cs"/>
-                <a:hlinkClick r:id="rId3"/>
-              </a:rPr>
-              <a:t>JSON </a:t>
-            </a:r>
-            <a:r>
-              <a:rPr lang="en-GB" sz="1200" b="0" i="0" kern="1200" dirty="0">
+              <a:t>Elasticsearch is because of its architecture distributed by nature. This allows it to scale horizontally  across </a:t>
+            </a:r>
+            <a:r>
+              <a:rPr lang="en-GB" sz="1200" b="0" i="0" u="none" strike="noStrike" kern="1200" dirty="0" err="1">
                 <a:solidFill>
                   <a:schemeClr val="tx1"/>
                 </a:solidFill>
@@ -1190,8 +1723,300 @@
                 <a:ea typeface="+mn-ea"/>
                 <a:cs typeface="+mn-cs"/>
               </a:rPr>
-              <a:t>format and making it easy to index and search structured and unstructured data.</a:t>
-            </a:r>
+              <a:t>multible</a:t>
+            </a:r>
+            <a:r>
+              <a:rPr lang="en-GB" sz="1200" b="0" i="0" u="none" strike="noStrike" kern="1200" dirty="0">
+                <a:solidFill>
+                  <a:schemeClr val="tx1"/>
+                </a:solidFill>
+                <a:effectLst/>
+                <a:latin typeface="+mn-lt"/>
+                <a:ea typeface="+mn-ea"/>
+                <a:cs typeface="+mn-cs"/>
+              </a:rPr>
+              <a:t> nodes to handle large datasets and high query volumes</a:t>
+            </a:r>
+          </a:p>
+          <a:p>
+            <a:pPr marL="171450" marR="0" lvl="0" indent="-171450" algn="l" defTabSz="914400" rtl="0" eaLnBrk="1" fontAlgn="auto" latinLnBrk="0" hangingPunct="1">
+              <a:lnSpc>
+                <a:spcPct val="100000"/>
+              </a:lnSpc>
+              <a:spcBef>
+                <a:spcPts val="0"/>
+              </a:spcBef>
+              <a:spcAft>
+                <a:spcPts val="0"/>
+              </a:spcAft>
+              <a:buClrTx/>
+              <a:buSzTx/>
+              <a:buFont typeface="Arial" panose="020B0604020202020204" pitchFamily="34" charset="0"/>
+              <a:buChar char="•"/>
+              <a:tabLst/>
+              <a:defRPr/>
+            </a:pPr>
+            <a:r>
+              <a:rPr lang="en-GB" sz="1200" b="0" i="0" u="none" strike="noStrike" kern="1200" dirty="0">
+                <a:solidFill>
+                  <a:schemeClr val="tx1"/>
+                </a:solidFill>
+                <a:effectLst/>
+                <a:latin typeface="+mn-lt"/>
+                <a:ea typeface="+mn-ea"/>
+                <a:cs typeface="+mn-cs"/>
+              </a:rPr>
+              <a:t>It provides powerful full-text-search capabilities, enabling users to search for documents based on their content and relevance</a:t>
+            </a:r>
+          </a:p>
+          <a:p>
+            <a:pPr marL="171450" marR="0" lvl="0" indent="-171450" algn="l" defTabSz="914400" rtl="0" eaLnBrk="1" fontAlgn="auto" latinLnBrk="0" hangingPunct="1">
+              <a:lnSpc>
+                <a:spcPct val="100000"/>
+              </a:lnSpc>
+              <a:spcBef>
+                <a:spcPts val="0"/>
+              </a:spcBef>
+              <a:spcAft>
+                <a:spcPts val="0"/>
+              </a:spcAft>
+              <a:buClrTx/>
+              <a:buSzTx/>
+              <a:buFont typeface="Arial" panose="020B0604020202020204" pitchFamily="34" charset="0"/>
+              <a:buChar char="•"/>
+              <a:tabLst/>
+              <a:defRPr/>
+            </a:pPr>
+            <a:r>
+              <a:rPr lang="en-GB" sz="1200" b="0" i="0" u="none" strike="noStrike" kern="1200" dirty="0">
+                <a:solidFill>
+                  <a:schemeClr val="tx1"/>
+                </a:solidFill>
+                <a:effectLst/>
+                <a:latin typeface="+mn-lt"/>
+                <a:ea typeface="+mn-ea"/>
+                <a:cs typeface="+mn-cs"/>
+              </a:rPr>
+              <a:t>Support real time indexing and </a:t>
+            </a:r>
+            <a:r>
+              <a:rPr lang="en-GB" sz="1200" b="0" i="0" u="none" strike="noStrike" kern="1200" dirty="0" err="1">
+                <a:solidFill>
+                  <a:schemeClr val="tx1"/>
+                </a:solidFill>
+                <a:effectLst/>
+                <a:latin typeface="+mn-lt"/>
+                <a:ea typeface="+mn-ea"/>
+                <a:cs typeface="+mn-cs"/>
+              </a:rPr>
+              <a:t>quering</a:t>
+            </a:r>
+            <a:r>
+              <a:rPr lang="en-GB" sz="1200" b="0" i="0" u="none" strike="noStrike" kern="1200" dirty="0">
+                <a:solidFill>
+                  <a:schemeClr val="tx1"/>
+                </a:solidFill>
+                <a:effectLst/>
+                <a:latin typeface="+mn-lt"/>
+                <a:ea typeface="+mn-ea"/>
+                <a:cs typeface="+mn-cs"/>
+              </a:rPr>
+              <a:t>, making it suitable for use cases that require up-to-date insights from continuously changing data</a:t>
+            </a:r>
+          </a:p>
+          <a:p>
+            <a:pPr marL="171450" marR="0" lvl="0" indent="-171450" algn="l" defTabSz="914400" rtl="0" eaLnBrk="1" fontAlgn="auto" latinLnBrk="0" hangingPunct="1">
+              <a:lnSpc>
+                <a:spcPct val="100000"/>
+              </a:lnSpc>
+              <a:spcBef>
+                <a:spcPts val="0"/>
+              </a:spcBef>
+              <a:spcAft>
+                <a:spcPts val="0"/>
+              </a:spcAft>
+              <a:buClrTx/>
+              <a:buSzTx/>
+              <a:buFont typeface="Arial" panose="020B0604020202020204" pitchFamily="34" charset="0"/>
+              <a:buChar char="•"/>
+              <a:tabLst/>
+              <a:defRPr/>
+            </a:pPr>
+            <a:r>
+              <a:rPr lang="en-GB" sz="1200" b="0" i="0" u="none" strike="noStrike" kern="1200" dirty="0">
+                <a:solidFill>
+                  <a:schemeClr val="tx1"/>
+                </a:solidFill>
+                <a:effectLst/>
+                <a:latin typeface="+mn-lt"/>
+                <a:ea typeface="+mn-ea"/>
+                <a:cs typeface="+mn-cs"/>
+              </a:rPr>
+              <a:t>Offers a RESTful API, making it easy to interact with the system using simple http requests</a:t>
+            </a:r>
+          </a:p>
+          <a:p>
+            <a:pPr marL="171450" marR="0" lvl="0" indent="-171450" algn="l" defTabSz="914400" rtl="0" eaLnBrk="1" fontAlgn="auto" latinLnBrk="0" hangingPunct="1">
+              <a:lnSpc>
+                <a:spcPct val="100000"/>
+              </a:lnSpc>
+              <a:spcBef>
+                <a:spcPts val="0"/>
+              </a:spcBef>
+              <a:spcAft>
+                <a:spcPts val="0"/>
+              </a:spcAft>
+              <a:buClrTx/>
+              <a:buSzTx/>
+              <a:buFont typeface="Arial" panose="020B0604020202020204" pitchFamily="34" charset="0"/>
+              <a:buChar char="•"/>
+              <a:tabLst/>
+              <a:defRPr/>
+            </a:pPr>
+            <a:r>
+              <a:rPr lang="en-GB" sz="1200" b="0" i="0" u="none" strike="noStrike" kern="1200" dirty="0">
+                <a:solidFill>
+                  <a:schemeClr val="tx1"/>
+                </a:solidFill>
+                <a:effectLst/>
+                <a:latin typeface="+mn-lt"/>
+                <a:ea typeface="+mn-ea"/>
+                <a:cs typeface="+mn-cs"/>
+              </a:rPr>
+              <a:t>Is </a:t>
+            </a:r>
+            <a:r>
+              <a:rPr lang="en-GB" sz="1200" b="0" i="0" u="none" strike="noStrike" kern="1200" dirty="0" err="1">
+                <a:solidFill>
+                  <a:schemeClr val="tx1"/>
+                </a:solidFill>
+                <a:effectLst/>
+                <a:latin typeface="+mn-lt"/>
+                <a:ea typeface="+mn-ea"/>
+                <a:cs typeface="+mn-cs"/>
+              </a:rPr>
+              <a:t>schemaless</a:t>
+            </a:r>
+            <a:r>
+              <a:rPr lang="en-GB" sz="1200" b="0" i="0" u="none" strike="noStrike" kern="1200" dirty="0">
+                <a:solidFill>
+                  <a:schemeClr val="tx1"/>
+                </a:solidFill>
+                <a:effectLst/>
+                <a:latin typeface="+mn-lt"/>
+                <a:ea typeface="+mn-ea"/>
+                <a:cs typeface="+mn-cs"/>
+              </a:rPr>
+              <a:t>, meaning we can index and search data without having to define a </a:t>
+            </a:r>
+            <a:r>
+              <a:rPr lang="en-GB" sz="1200" b="0" i="0" u="none" strike="noStrike" kern="1200" dirty="0" err="1">
+                <a:solidFill>
+                  <a:schemeClr val="tx1"/>
+                </a:solidFill>
+                <a:effectLst/>
+                <a:latin typeface="+mn-lt"/>
+                <a:ea typeface="+mn-ea"/>
+                <a:cs typeface="+mn-cs"/>
+              </a:rPr>
+              <a:t>rigit</a:t>
+            </a:r>
+            <a:r>
+              <a:rPr lang="en-GB" sz="1200" b="0" i="0" u="none" strike="noStrike" kern="1200" dirty="0">
+                <a:solidFill>
+                  <a:schemeClr val="tx1"/>
+                </a:solidFill>
+                <a:effectLst/>
+                <a:latin typeface="+mn-lt"/>
+                <a:ea typeface="+mn-ea"/>
+                <a:cs typeface="+mn-cs"/>
+              </a:rPr>
+              <a:t> schema already</a:t>
+            </a:r>
+          </a:p>
+          <a:p>
+            <a:pPr marL="171450" marR="0" lvl="0" indent="-171450" algn="l" defTabSz="914400" rtl="0" eaLnBrk="1" fontAlgn="auto" latinLnBrk="0" hangingPunct="1">
+              <a:lnSpc>
+                <a:spcPct val="100000"/>
+              </a:lnSpc>
+              <a:spcBef>
+                <a:spcPts val="0"/>
+              </a:spcBef>
+              <a:spcAft>
+                <a:spcPts val="0"/>
+              </a:spcAft>
+              <a:buClrTx/>
+              <a:buSzTx/>
+              <a:buFont typeface="Arial" panose="020B0604020202020204" pitchFamily="34" charset="0"/>
+              <a:buChar char="•"/>
+              <a:tabLst/>
+              <a:defRPr/>
+            </a:pPr>
+            <a:endParaRPr lang="en-GB" sz="1200" b="0" i="0" u="none" strike="noStrike" kern="1200" dirty="0">
+              <a:solidFill>
+                <a:schemeClr val="tx1"/>
+              </a:solidFill>
+              <a:effectLst/>
+              <a:latin typeface="+mn-lt"/>
+              <a:ea typeface="+mn-ea"/>
+              <a:cs typeface="+mn-cs"/>
+            </a:endParaRPr>
+          </a:p>
+          <a:p>
+            <a:pPr marL="171450" marR="0" lvl="0" indent="-171450" algn="l" defTabSz="914400" rtl="0" eaLnBrk="1" fontAlgn="auto" latinLnBrk="0" hangingPunct="1">
+              <a:lnSpc>
+                <a:spcPct val="100000"/>
+              </a:lnSpc>
+              <a:spcBef>
+                <a:spcPts val="0"/>
+              </a:spcBef>
+              <a:spcAft>
+                <a:spcPts val="0"/>
+              </a:spcAft>
+              <a:buClrTx/>
+              <a:buSzTx/>
+              <a:buFont typeface="Arial" panose="020B0604020202020204" pitchFamily="34" charset="0"/>
+              <a:buChar char="•"/>
+              <a:tabLst/>
+              <a:defRPr/>
+            </a:pPr>
+            <a:endParaRPr lang="en-GB" sz="1200" b="0" i="0" kern="1200" dirty="0">
+              <a:solidFill>
+                <a:schemeClr val="tx1"/>
+              </a:solidFill>
+              <a:effectLst/>
+              <a:latin typeface="+mn-lt"/>
+              <a:ea typeface="+mn-ea"/>
+              <a:cs typeface="+mn-cs"/>
+            </a:endParaRPr>
+          </a:p>
+          <a:p>
+            <a:pPr marL="171450" marR="0" lvl="0" indent="-171450" algn="l" defTabSz="914400" rtl="0" eaLnBrk="1" fontAlgn="auto" latinLnBrk="0" hangingPunct="1">
+              <a:lnSpc>
+                <a:spcPct val="100000"/>
+              </a:lnSpc>
+              <a:spcBef>
+                <a:spcPts val="0"/>
+              </a:spcBef>
+              <a:spcAft>
+                <a:spcPts val="0"/>
+              </a:spcAft>
+              <a:buClrTx/>
+              <a:buSzTx/>
+              <a:buFont typeface="Arial" panose="020B0604020202020204" pitchFamily="34" charset="0"/>
+              <a:buChar char="•"/>
+              <a:tabLst/>
+              <a:defRPr/>
+            </a:pPr>
+            <a:endParaRPr lang="en-GB" sz="1200" b="0" i="0" kern="1200" dirty="0">
+              <a:solidFill>
+                <a:schemeClr val="tx1"/>
+              </a:solidFill>
+              <a:effectLst/>
+              <a:latin typeface="+mn-lt"/>
+              <a:ea typeface="+mn-ea"/>
+              <a:cs typeface="+mn-cs"/>
+            </a:endParaRPr>
           </a:p>
           <a:p>
             <a:endParaRPr lang="en-AT" dirty="0"/>
@@ -1329,10 +2154,10 @@
                 <a:ea typeface="+mn-ea"/>
                 <a:cs typeface="+mn-cs"/>
               </a:rPr>
-              <a:t>Elasticsearch stores data in </a:t>
-            </a:r>
-            <a:r>
-              <a:rPr lang="en-GB" sz="1200" b="0" i="0" u="sng" kern="1200" dirty="0">
+              <a:t>Analyse then tokenize and </a:t>
+            </a:r>
+            <a:r>
+              <a:rPr lang="en-GB" sz="1200" b="0" i="0" kern="1200" dirty="0" err="1">
                 <a:solidFill>
                   <a:schemeClr val="tx1"/>
                 </a:solidFill>
@@ -1340,9 +2165,8 @@
                 <a:latin typeface="+mn-lt"/>
                 <a:ea typeface="+mn-ea"/>
                 <a:cs typeface="+mn-cs"/>
-                <a:hlinkClick r:id="rId3"/>
               </a:rPr>
-              <a:t>JSON </a:t>
+              <a:t>thte</a:t>
             </a:r>
             <a:r>
               <a:rPr lang="en-GB" sz="1200" b="0" i="0" kern="1200" dirty="0">
@@ -1354,7 +2178,74 @@
                 <a:ea typeface="+mn-ea"/>
                 <a:cs typeface="+mn-cs"/>
               </a:rPr>
-              <a:t>format and making it easy to index and search structured and unstructured data.</a:t>
+              <a:t> inverted index</a:t>
+            </a:r>
+          </a:p>
+          <a:p>
+            <a:pPr marL="0" marR="0" lvl="0" indent="0" algn="l" defTabSz="914400" rtl="0" eaLnBrk="1" fontAlgn="auto" latinLnBrk="0" hangingPunct="1">
+              <a:lnSpc>
+                <a:spcPct val="100000"/>
+              </a:lnSpc>
+              <a:spcBef>
+                <a:spcPts val="0"/>
+              </a:spcBef>
+              <a:spcAft>
+                <a:spcPts val="0"/>
+              </a:spcAft>
+              <a:buClrTx/>
+              <a:buSzTx/>
+              <a:buFontTx/>
+              <a:buNone/>
+              <a:tabLst/>
+              <a:defRPr/>
+            </a:pPr>
+            <a:r>
+              <a:rPr lang="en-GB" sz="1200" b="0" i="0" kern="1200" dirty="0" err="1">
+                <a:solidFill>
+                  <a:schemeClr val="tx1"/>
+                </a:solidFill>
+                <a:effectLst/>
+                <a:latin typeface="+mn-lt"/>
+                <a:ea typeface="+mn-ea"/>
+                <a:cs typeface="+mn-cs"/>
+              </a:rPr>
+              <a:t>Tonkenized</a:t>
+            </a:r>
+            <a:r>
+              <a:rPr lang="en-GB" sz="1200" b="0" i="0" kern="1200" dirty="0">
+                <a:solidFill>
+                  <a:schemeClr val="tx1"/>
+                </a:solidFill>
+                <a:effectLst/>
+                <a:latin typeface="+mn-lt"/>
+                <a:ea typeface="+mn-ea"/>
+                <a:cs typeface="+mn-cs"/>
+              </a:rPr>
+              <a:t> are some steps more – that what you can see here </a:t>
+            </a:r>
+            <a:r>
+              <a:rPr lang="en-GB" sz="1200" b="0" i="0" kern="1200" dirty="0" err="1">
+                <a:solidFill>
+                  <a:schemeClr val="tx1"/>
+                </a:solidFill>
+                <a:effectLst/>
+                <a:latin typeface="+mn-lt"/>
+                <a:ea typeface="+mn-ea"/>
+                <a:cs typeface="+mn-cs"/>
+              </a:rPr>
+              <a:t>ande</a:t>
+            </a:r>
+            <a:r>
+              <a:rPr lang="en-GB" sz="1200" b="0" i="0" kern="1200" dirty="0">
+                <a:solidFill>
+                  <a:schemeClr val="tx1"/>
+                </a:solidFill>
+                <a:effectLst/>
+                <a:latin typeface="+mn-lt"/>
+                <a:ea typeface="+mn-ea"/>
+                <a:cs typeface="+mn-cs"/>
+              </a:rPr>
+              <a:t> then all is lowercased and the the is never stored because it would be useless for searching</a:t>
             </a:r>
           </a:p>
           <a:p>
@@ -1412,7 +2303,7 @@
         <p:cNvPr id="1" name="">
           <a:extLst>
             <a:ext uri="{FF2B5EF4-FFF2-40B4-BE49-F238E27FC236}">
-              <a16:creationId xmlns:a16="http://schemas.microsoft.com/office/drawing/2014/main" id="{354ECCA7-4D49-FE9D-9AA0-C3CB76DD1EB5}"/>
+              <a16:creationId xmlns:a16="http://schemas.microsoft.com/office/drawing/2014/main" id="{6F2BF4A2-A0C2-D748-5AA1-641F229B03EA}"/>
             </a:ext>
           </a:extLst>
         </p:cNvPr>
@@ -1432,7 +2323,7 @@
           <p:cNvPr id="2" name="Slide Image Placeholder 1">
             <a:extLst>
               <a:ext uri="{FF2B5EF4-FFF2-40B4-BE49-F238E27FC236}">
-                <a16:creationId xmlns:a16="http://schemas.microsoft.com/office/drawing/2014/main" id="{85D7BFCF-DEC2-04F1-6C27-42E13108757D}"/>
+                <a16:creationId xmlns:a16="http://schemas.microsoft.com/office/drawing/2014/main" id="{828063A5-4A57-CBFC-4F24-248456D039B5}"/>
               </a:ext>
             </a:extLst>
           </p:cNvPr>
@@ -1450,7 +2341,7 @@
           <p:cNvPr id="3" name="Notes Placeholder 2">
             <a:extLst>
               <a:ext uri="{FF2B5EF4-FFF2-40B4-BE49-F238E27FC236}">
-                <a16:creationId xmlns:a16="http://schemas.microsoft.com/office/drawing/2014/main" id="{D33DC1BF-37AC-E219-C92F-9A486435762D}"/>
+                <a16:creationId xmlns:a16="http://schemas.microsoft.com/office/drawing/2014/main" id="{50514AAA-2FC3-4207-37F5-0753D567A7FC}"/>
               </a:ext>
             </a:extLst>
           </p:cNvPr>
@@ -1484,7 +2375,7 @@
               <a:defRPr/>
             </a:pPr>
             <a:r>
-              <a:rPr lang="en-GB" sz="1200" b="0" i="0" kern="1200" dirty="0">
+              <a:rPr lang="en-GB" sz="1200" b="1" i="0" kern="1200" dirty="0">
                 <a:solidFill>
                   <a:schemeClr val="tx1"/>
                 </a:solidFill>
@@ -1493,23 +2384,10 @@
                 <a:ea typeface="+mn-ea"/>
                 <a:cs typeface="+mn-cs"/>
               </a:rPr>
-              <a:t>Elasticsearch stores data in </a:t>
-            </a:r>
-            <a:r>
-              <a:rPr lang="en-GB" sz="1200" b="0" i="0" u="sng" kern="1200" dirty="0">
-                <a:solidFill>
-                  <a:schemeClr val="tx1"/>
-                </a:solidFill>
-                <a:effectLst/>
-                <a:latin typeface="+mn-lt"/>
-                <a:ea typeface="+mn-ea"/>
-                <a:cs typeface="+mn-cs"/>
-                <a:hlinkClick r:id="rId3"/>
-              </a:rPr>
-              <a:t>JSON </a:t>
-            </a:r>
-            <a:r>
-              <a:rPr lang="en-GB" sz="1200" b="0" i="0" kern="1200" dirty="0">
+              <a:t>Match</a:t>
+            </a:r>
+            <a:r>
+              <a:rPr lang="en-GB" sz="1200" b="0" i="0" u="none" strike="noStrike" kern="1200" dirty="0">
                 <a:solidFill>
                   <a:schemeClr val="tx1"/>
                 </a:solidFill>
@@ -1518,10 +2396,232 @@
                 <a:ea typeface="+mn-ea"/>
                 <a:cs typeface="+mn-cs"/>
               </a:rPr>
-              <a:t>format and making it easy to index and search structured and unstructured data.</a:t>
-            </a:r>
-          </a:p>
-          <a:p>
+              <a:t> - full-text search, finds "Monaco Grand Prix" by typing "</a:t>
+            </a:r>
+            <a:r>
+              <a:rPr lang="en-GB" sz="1200" b="0" i="0" u="none" strike="noStrike" kern="1200" dirty="0" err="1">
+                <a:solidFill>
+                  <a:schemeClr val="tx1"/>
+                </a:solidFill>
+                <a:effectLst/>
+                <a:latin typeface="+mn-lt"/>
+                <a:ea typeface="+mn-ea"/>
+                <a:cs typeface="+mn-cs"/>
+              </a:rPr>
+              <a:t>monaco</a:t>
+            </a:r>
+            <a:r>
+              <a:rPr lang="en-GB" sz="1200" b="0" i="0" u="none" strike="noStrike" kern="1200" dirty="0">
+                <a:solidFill>
+                  <a:schemeClr val="tx1"/>
+                </a:solidFill>
+                <a:effectLst/>
+                <a:latin typeface="+mn-lt"/>
+                <a:ea typeface="+mn-ea"/>
+                <a:cs typeface="+mn-cs"/>
+              </a:rPr>
+              <a:t>”</a:t>
+            </a:r>
+          </a:p>
+          <a:p>
+            <a:pPr marL="0" marR="0" lvl="0" indent="0" algn="l" defTabSz="914400" rtl="0" eaLnBrk="1" fontAlgn="auto" latinLnBrk="0" hangingPunct="1">
+              <a:lnSpc>
+                <a:spcPct val="100000"/>
+              </a:lnSpc>
+              <a:spcBef>
+                <a:spcPts val="0"/>
+              </a:spcBef>
+              <a:spcAft>
+                <a:spcPts val="0"/>
+              </a:spcAft>
+              <a:buClrTx/>
+              <a:buSzTx/>
+              <a:buFontTx/>
+              <a:buNone/>
+              <a:tabLst/>
+              <a:defRPr/>
+            </a:pPr>
+            <a:r>
+              <a:rPr lang="en-GB" sz="1200" b="1" i="0" kern="1200" dirty="0">
+                <a:solidFill>
+                  <a:schemeClr val="tx1"/>
+                </a:solidFill>
+                <a:effectLst/>
+                <a:latin typeface="+mn-lt"/>
+                <a:ea typeface="+mn-ea"/>
+                <a:cs typeface="+mn-cs"/>
+              </a:rPr>
+              <a:t>Fuzzy</a:t>
+            </a:r>
+            <a:r>
+              <a:rPr lang="en-GB" sz="1200" b="0" i="0" u="none" strike="noStrike" kern="1200" dirty="0">
+                <a:solidFill>
+                  <a:schemeClr val="tx1"/>
+                </a:solidFill>
+                <a:effectLst/>
+                <a:latin typeface="+mn-lt"/>
+                <a:ea typeface="+mn-ea"/>
+                <a:cs typeface="+mn-cs"/>
+              </a:rPr>
+              <a:t> - tolerates typos, "</a:t>
+            </a:r>
+            <a:r>
+              <a:rPr lang="en-GB" sz="1200" b="0" i="0" u="none" strike="noStrike" kern="1200" dirty="0" err="1">
+                <a:solidFill>
+                  <a:schemeClr val="tx1"/>
+                </a:solidFill>
+                <a:effectLst/>
+                <a:latin typeface="+mn-lt"/>
+                <a:ea typeface="+mn-ea"/>
+                <a:cs typeface="+mn-cs"/>
+              </a:rPr>
+              <a:t>Hamilten</a:t>
+            </a:r>
+            <a:r>
+              <a:rPr lang="en-GB" sz="1200" b="0" i="0" u="none" strike="noStrike" kern="1200" dirty="0">
+                <a:solidFill>
+                  <a:schemeClr val="tx1"/>
+                </a:solidFill>
+                <a:effectLst/>
+                <a:latin typeface="+mn-lt"/>
+                <a:ea typeface="+mn-ea"/>
+                <a:cs typeface="+mn-cs"/>
+              </a:rPr>
+              <a:t>" still finds "Hamilton”</a:t>
+            </a:r>
+          </a:p>
+          <a:p>
+            <a:pPr marL="0" marR="0" lvl="0" indent="0" algn="l" defTabSz="914400" rtl="0" eaLnBrk="1" fontAlgn="auto" latinLnBrk="0" hangingPunct="1">
+              <a:lnSpc>
+                <a:spcPct val="100000"/>
+              </a:lnSpc>
+              <a:spcBef>
+                <a:spcPts val="0"/>
+              </a:spcBef>
+              <a:spcAft>
+                <a:spcPts val="0"/>
+              </a:spcAft>
+              <a:buClrTx/>
+              <a:buSzTx/>
+              <a:buFontTx/>
+              <a:buNone/>
+              <a:tabLst/>
+              <a:defRPr/>
+            </a:pPr>
+            <a:r>
+              <a:rPr lang="en-GB" sz="1200" b="1" i="0" kern="1200" dirty="0">
+                <a:solidFill>
+                  <a:schemeClr val="tx1"/>
+                </a:solidFill>
+                <a:effectLst/>
+                <a:latin typeface="+mn-lt"/>
+                <a:ea typeface="+mn-ea"/>
+                <a:cs typeface="+mn-cs"/>
+              </a:rPr>
+              <a:t>Bool</a:t>
+            </a:r>
+            <a:r>
+              <a:rPr lang="en-GB" sz="1200" b="0" i="0" u="none" strike="noStrike" kern="1200" dirty="0">
+                <a:solidFill>
+                  <a:schemeClr val="tx1"/>
+                </a:solidFill>
+                <a:effectLst/>
+                <a:latin typeface="+mn-lt"/>
+                <a:ea typeface="+mn-ea"/>
+                <a:cs typeface="+mn-cs"/>
+              </a:rPr>
+              <a:t> - combines conditions, like SQL WHERE with AND/OR</a:t>
+            </a:r>
+          </a:p>
+          <a:p>
+            <a:pPr marL="0" marR="0" lvl="0" indent="0" algn="l" defTabSz="914400" rtl="0" eaLnBrk="1" fontAlgn="auto" latinLnBrk="0" hangingPunct="1">
+              <a:lnSpc>
+                <a:spcPct val="100000"/>
+              </a:lnSpc>
+              <a:spcBef>
+                <a:spcPts val="0"/>
+              </a:spcBef>
+              <a:spcAft>
+                <a:spcPts val="0"/>
+              </a:spcAft>
+              <a:buClrTx/>
+              <a:buSzTx/>
+              <a:buFontTx/>
+              <a:buNone/>
+              <a:tabLst/>
+              <a:defRPr/>
+            </a:pPr>
+            <a:r>
+              <a:rPr lang="en-GB" sz="1200" b="1" i="0" kern="1200" dirty="0">
+                <a:solidFill>
+                  <a:schemeClr val="tx1"/>
+                </a:solidFill>
+                <a:effectLst/>
+                <a:latin typeface="+mn-lt"/>
+                <a:ea typeface="+mn-ea"/>
+                <a:cs typeface="+mn-cs"/>
+              </a:rPr>
+              <a:t>Aggregation</a:t>
+            </a:r>
+            <a:r>
+              <a:rPr lang="en-GB" sz="1200" b="0" i="0" u="none" strike="noStrike" kern="1200" dirty="0">
+                <a:solidFill>
+                  <a:schemeClr val="tx1"/>
+                </a:solidFill>
+                <a:effectLst/>
+                <a:latin typeface="+mn-lt"/>
+                <a:ea typeface="+mn-ea"/>
+                <a:cs typeface="+mn-cs"/>
+              </a:rPr>
+              <a:t> - group and count, like SQL GROUP BY</a:t>
+            </a:r>
+          </a:p>
+          <a:p>
+            <a:pPr marL="0" marR="0" lvl="0" indent="0" algn="l" defTabSz="914400" rtl="0" eaLnBrk="1" fontAlgn="auto" latinLnBrk="0" hangingPunct="1">
+              <a:lnSpc>
+                <a:spcPct val="100000"/>
+              </a:lnSpc>
+              <a:spcBef>
+                <a:spcPts val="0"/>
+              </a:spcBef>
+              <a:spcAft>
+                <a:spcPts val="0"/>
+              </a:spcAft>
+              <a:buClrTx/>
+              <a:buSzTx/>
+              <a:buFontTx/>
+              <a:buNone/>
+              <a:tabLst/>
+              <a:defRPr/>
+            </a:pPr>
+            <a:endParaRPr lang="en-GB" sz="1200" b="0" i="0" u="none" strike="noStrike" kern="1200" dirty="0">
+              <a:solidFill>
+                <a:schemeClr val="tx1"/>
+              </a:solidFill>
+              <a:effectLst/>
+              <a:latin typeface="+mn-lt"/>
+              <a:ea typeface="+mn-ea"/>
+              <a:cs typeface="+mn-cs"/>
+            </a:endParaRPr>
+          </a:p>
+          <a:p>
+            <a:pPr marL="0" marR="0" lvl="0" indent="0" algn="l" defTabSz="914400" rtl="0" eaLnBrk="1" fontAlgn="auto" latinLnBrk="0" hangingPunct="1">
+              <a:lnSpc>
+                <a:spcPct val="100000"/>
+              </a:lnSpc>
+              <a:spcBef>
+                <a:spcPts val="0"/>
+              </a:spcBef>
+              <a:spcAft>
+                <a:spcPts val="0"/>
+              </a:spcAft>
+              <a:buClrTx/>
+              <a:buSzTx/>
+              <a:buFontTx/>
+              <a:buNone/>
+              <a:tabLst/>
+              <a:defRPr/>
+            </a:pPr>
             <a:endParaRPr lang="en-AT" dirty="0"/>
           </a:p>
         </p:txBody>
@@ -1531,7 +2631,7 @@
           <p:cNvPr id="4" name="Slide Number Placeholder 3">
             <a:extLst>
               <a:ext uri="{FF2B5EF4-FFF2-40B4-BE49-F238E27FC236}">
-                <a16:creationId xmlns:a16="http://schemas.microsoft.com/office/drawing/2014/main" id="{A56098C9-5013-0958-709C-AFD18D7C1F2C}"/>
+                <a16:creationId xmlns:a16="http://schemas.microsoft.com/office/drawing/2014/main" id="{1631C7C2-3E5C-FED8-BB29-29E466420FDA}"/>
               </a:ext>
             </a:extLst>
           </p:cNvPr>
@@ -1558,7 +2658,7 @@
     </p:spTree>
     <p:extLst>
       <p:ext uri="{BB962C8B-B14F-4D97-AF65-F5344CB8AC3E}">
-        <p14:creationId xmlns:p14="http://schemas.microsoft.com/office/powerpoint/2010/main" val="2356324315"/>
+        <p14:creationId xmlns:p14="http://schemas.microsoft.com/office/powerpoint/2010/main" val="585270328"/>
       </p:ext>
     </p:extLst>
   </p:cSld>
@@ -1576,7 +2676,7 @@
         <p:cNvPr id="1" name="">
           <a:extLst>
             <a:ext uri="{FF2B5EF4-FFF2-40B4-BE49-F238E27FC236}">
-              <a16:creationId xmlns:a16="http://schemas.microsoft.com/office/drawing/2014/main" id="{5BF8D0DE-142E-2B45-1A56-3BD6AEBDEC83}"/>
+              <a16:creationId xmlns:a16="http://schemas.microsoft.com/office/drawing/2014/main" id="{0DF11BDA-9E86-9C4D-9747-99837790081C}"/>
             </a:ext>
           </a:extLst>
         </p:cNvPr>
@@ -1596,7 +2696,7 @@
           <p:cNvPr id="2" name="Slide Image Placeholder 1">
             <a:extLst>
               <a:ext uri="{FF2B5EF4-FFF2-40B4-BE49-F238E27FC236}">
-                <a16:creationId xmlns:a16="http://schemas.microsoft.com/office/drawing/2014/main" id="{101D435F-0DDD-8174-22FD-1C38ACE85925}"/>
+                <a16:creationId xmlns:a16="http://schemas.microsoft.com/office/drawing/2014/main" id="{33D95772-CBAF-FCAB-672E-C8CA0580892D}"/>
               </a:ext>
             </a:extLst>
           </p:cNvPr>
@@ -1614,7 +2714,7 @@
           <p:cNvPr id="3" name="Notes Placeholder 2">
             <a:extLst>
               <a:ext uri="{FF2B5EF4-FFF2-40B4-BE49-F238E27FC236}">
-                <a16:creationId xmlns:a16="http://schemas.microsoft.com/office/drawing/2014/main" id="{973C4831-9BD9-6CF8-06CD-AF61D0997D12}"/>
+                <a16:creationId xmlns:a16="http://schemas.microsoft.com/office/drawing/2014/main" id="{292B7496-8800-3FAE-0A83-786D3CB1C217}"/>
               </a:ext>
             </a:extLst>
           </p:cNvPr>
@@ -1657,35 +2757,36 @@
                 <a:ea typeface="+mn-ea"/>
                 <a:cs typeface="+mn-cs"/>
               </a:rPr>
-              <a:t>Elasticsearch stores data in </a:t>
-            </a:r>
-            <a:r>
-              <a:rPr lang="en-GB" sz="1200" b="0" i="0" u="sng" kern="1200" dirty="0">
-                <a:solidFill>
-                  <a:schemeClr val="tx1"/>
-                </a:solidFill>
-                <a:effectLst/>
-                <a:latin typeface="+mn-lt"/>
-                <a:ea typeface="+mn-ea"/>
-                <a:cs typeface="+mn-cs"/>
-                <a:hlinkClick r:id="rId3"/>
-              </a:rPr>
-              <a:t>JSON </a:t>
-            </a:r>
-            <a:r>
-              <a:rPr lang="en-GB" sz="1200" b="0" i="0" kern="1200" dirty="0">
-                <a:solidFill>
-                  <a:schemeClr val="tx1"/>
-                </a:solidFill>
-                <a:effectLst/>
-                <a:latin typeface="+mn-lt"/>
-                <a:ea typeface="+mn-ea"/>
-                <a:cs typeface="+mn-cs"/>
-              </a:rPr>
-              <a:t>format and making it easy to index and search structured and unstructured data.</a:t>
-            </a:r>
-          </a:p>
-          <a:p>
+              <a:t>It employs distributed search and aggregation strategies to parallelize computation and merge results from multiple shards.</a:t>
+            </a:r>
+            <a:endParaRPr lang="en-GB" sz="1200" b="0" i="0" u="none" strike="noStrike" kern="1200" dirty="0">
+              <a:solidFill>
+                <a:schemeClr val="tx1"/>
+              </a:solidFill>
+              <a:effectLst/>
+              <a:latin typeface="+mn-lt"/>
+              <a:ea typeface="+mn-ea"/>
+              <a:cs typeface="+mn-cs"/>
+            </a:endParaRPr>
+          </a:p>
+          <a:p>
+            <a:pPr marL="0" marR="0" lvl="0" indent="0" algn="l" defTabSz="914400" rtl="0" eaLnBrk="1" fontAlgn="auto" latinLnBrk="0" hangingPunct="1">
+              <a:lnSpc>
+                <a:spcPct val="100000"/>
+              </a:lnSpc>
+              <a:spcBef>
+                <a:spcPts val="0"/>
+              </a:spcBef>
+              <a:spcAft>
+                <a:spcPts val="0"/>
+              </a:spcAft>
+              <a:buClrTx/>
+              <a:buSzTx/>
+              <a:buFontTx/>
+              <a:buNone/>
+              <a:tabLst/>
+              <a:defRPr/>
+            </a:pPr>
             <a:endParaRPr lang="en-AT" dirty="0"/>
           </a:p>
         </p:txBody>
@@ -1695,7 +2796,7 @@
           <p:cNvPr id="4" name="Slide Number Placeholder 3">
             <a:extLst>
               <a:ext uri="{FF2B5EF4-FFF2-40B4-BE49-F238E27FC236}">
-                <a16:creationId xmlns:a16="http://schemas.microsoft.com/office/drawing/2014/main" id="{ED0D11DD-C6D3-46F2-EBED-0D4027BB110E}"/>
+                <a16:creationId xmlns:a16="http://schemas.microsoft.com/office/drawing/2014/main" id="{B078E320-A4BE-7B8D-DD66-5A8B2E7872BC}"/>
               </a:ext>
             </a:extLst>
           </p:cNvPr>
@@ -1722,7 +2823,7 @@
     </p:spTree>
     <p:extLst>
       <p:ext uri="{BB962C8B-B14F-4D97-AF65-F5344CB8AC3E}">
-        <p14:creationId xmlns:p14="http://schemas.microsoft.com/office/powerpoint/2010/main" val="12436100"/>
+        <p14:creationId xmlns:p14="http://schemas.microsoft.com/office/powerpoint/2010/main" val="3738663906"/>
       </p:ext>
     </p:extLst>
   </p:cSld>
@@ -1821,21 +2922,27 @@
                 <a:ea typeface="+mn-ea"/>
                 <a:cs typeface="+mn-cs"/>
               </a:rPr>
-              <a:t>Elasticsearch stores data in </a:t>
-            </a:r>
-            <a:r>
-              <a:rPr lang="en-GB" sz="1200" b="0" i="0" u="sng" kern="1200" dirty="0">
-                <a:solidFill>
-                  <a:schemeClr val="tx1"/>
-                </a:solidFill>
-                <a:effectLst/>
-                <a:latin typeface="+mn-lt"/>
-                <a:ea typeface="+mn-ea"/>
-                <a:cs typeface="+mn-cs"/>
-                <a:hlinkClick r:id="rId3"/>
-              </a:rPr>
-              <a:t>JSON </a:t>
-            </a:r>
+              <a:t>GET -&gt; HTTP Methode +index name + endpoint</a:t>
+            </a:r>
+          </a:p>
+          <a:p>
+            <a:pPr marL="0" marR="0" lvl="0" indent="0" algn="l" defTabSz="914400" rtl="0" eaLnBrk="1" fontAlgn="auto" latinLnBrk="0" hangingPunct="1">
+              <a:lnSpc>
+                <a:spcPct val="100000"/>
+              </a:lnSpc>
+              <a:spcBef>
+                <a:spcPts val="0"/>
+              </a:spcBef>
+              <a:spcAft>
+                <a:spcPts val="0"/>
+              </a:spcAft>
+              <a:buClrTx/>
+              <a:buSzTx/>
+              <a:buFontTx/>
+              <a:buNone/>
+              <a:tabLst/>
+              <a:defRPr/>
+            </a:pPr>
             <a:r>
               <a:rPr lang="en-GB" sz="1200" b="0" i="0" kern="1200" dirty="0">
                 <a:solidFill>
@@ -1846,10 +2953,188 @@
                 <a:ea typeface="+mn-ea"/>
                 <a:cs typeface="+mn-cs"/>
               </a:rPr>
-              <a:t>format and making it easy to index and search structured and unstructured data.</a:t>
-            </a:r>
-          </a:p>
-          <a:p>
+              <a:t>Query -&gt; </a:t>
+            </a:r>
+            <a:r>
+              <a:rPr lang="en-GB" sz="1200" b="0" i="0" kern="1200" dirty="0" err="1">
+                <a:solidFill>
+                  <a:schemeClr val="tx1"/>
+                </a:solidFill>
+                <a:effectLst/>
+                <a:latin typeface="+mn-lt"/>
+                <a:ea typeface="+mn-ea"/>
+                <a:cs typeface="+mn-cs"/>
+              </a:rPr>
+              <a:t>QueryDSL</a:t>
+            </a:r>
+            <a:r>
+              <a:rPr lang="en-GB" sz="1200" b="0" i="0" kern="1200" dirty="0">
+                <a:solidFill>
+                  <a:schemeClr val="tx1"/>
+                </a:solidFill>
+                <a:effectLst/>
+                <a:latin typeface="+mn-lt"/>
+                <a:ea typeface="+mn-ea"/>
+                <a:cs typeface="+mn-cs"/>
+              </a:rPr>
+              <a:t> Body</a:t>
+            </a:r>
+          </a:p>
+          <a:p>
+            <a:pPr marL="0" marR="0" lvl="0" indent="0" algn="l" defTabSz="914400" rtl="0" eaLnBrk="1" fontAlgn="auto" latinLnBrk="0" hangingPunct="1">
+              <a:lnSpc>
+                <a:spcPct val="100000"/>
+              </a:lnSpc>
+              <a:spcBef>
+                <a:spcPts val="0"/>
+              </a:spcBef>
+              <a:spcAft>
+                <a:spcPts val="0"/>
+              </a:spcAft>
+              <a:buClrTx/>
+              <a:buSzTx/>
+              <a:buFontTx/>
+              <a:buNone/>
+              <a:tabLst/>
+              <a:defRPr/>
+            </a:pPr>
+            <a:r>
+              <a:rPr lang="en-GB" sz="1200" b="0" i="0" kern="1200" dirty="0">
+                <a:solidFill>
+                  <a:schemeClr val="tx1"/>
+                </a:solidFill>
+                <a:effectLst/>
+                <a:latin typeface="+mn-lt"/>
+                <a:ea typeface="+mn-ea"/>
+                <a:cs typeface="+mn-cs"/>
+              </a:rPr>
+              <a:t>Match-&gt; </a:t>
+            </a:r>
+            <a:r>
+              <a:rPr lang="en-GB" sz="1200" b="0" i="0" u="none" strike="noStrike" kern="1200" dirty="0">
+                <a:solidFill>
+                  <a:schemeClr val="tx1"/>
+                </a:solidFill>
+                <a:effectLst/>
+                <a:latin typeface="+mn-lt"/>
+                <a:ea typeface="+mn-ea"/>
+                <a:cs typeface="+mn-cs"/>
+              </a:rPr>
+              <a:t>Query type: full-text search</a:t>
+            </a:r>
+          </a:p>
+          <a:p>
+            <a:pPr marL="0" marR="0" lvl="0" indent="0" algn="l" defTabSz="914400" rtl="0" eaLnBrk="1" fontAlgn="auto" latinLnBrk="0" hangingPunct="1">
+              <a:lnSpc>
+                <a:spcPct val="100000"/>
+              </a:lnSpc>
+              <a:spcBef>
+                <a:spcPts val="0"/>
+              </a:spcBef>
+              <a:spcAft>
+                <a:spcPts val="0"/>
+              </a:spcAft>
+              <a:buClrTx/>
+              <a:buSzTx/>
+              <a:buFontTx/>
+              <a:buNone/>
+              <a:tabLst/>
+              <a:defRPr/>
+            </a:pPr>
+            <a:r>
+              <a:rPr lang="en-GB" sz="1200" b="0" i="0" u="none" strike="noStrike" kern="1200" dirty="0">
+                <a:solidFill>
+                  <a:schemeClr val="tx1"/>
+                </a:solidFill>
+                <a:effectLst/>
+                <a:latin typeface="+mn-lt"/>
+                <a:ea typeface="+mn-ea"/>
+                <a:cs typeface="+mn-cs"/>
+              </a:rPr>
+              <a:t>field: search value</a:t>
+            </a:r>
+            <a:br>
+              <a:rPr lang="en-GB" sz="1200" b="0" i="0" u="none" strike="noStrike" kern="1200" dirty="0">
+                <a:solidFill>
+                  <a:schemeClr val="tx1"/>
+                </a:solidFill>
+                <a:effectLst/>
+                <a:latin typeface="+mn-lt"/>
+                <a:ea typeface="+mn-ea"/>
+                <a:cs typeface="+mn-cs"/>
+              </a:rPr>
+            </a:br>
+            <a:br>
+              <a:rPr lang="en-GB" sz="1200" b="0" i="0" u="none" strike="noStrike" kern="1200" dirty="0">
+                <a:solidFill>
+                  <a:schemeClr val="tx1"/>
+                </a:solidFill>
+                <a:effectLst/>
+                <a:latin typeface="+mn-lt"/>
+                <a:ea typeface="+mn-ea"/>
+                <a:cs typeface="+mn-cs"/>
+              </a:rPr>
+            </a:br>
+            <a:r>
+              <a:rPr lang="en-GB" sz="1200" b="0" i="0" u="none" strike="noStrike" kern="1200" dirty="0">
+                <a:solidFill>
+                  <a:schemeClr val="tx1"/>
+                </a:solidFill>
+                <a:effectLst/>
+                <a:latin typeface="+mn-lt"/>
+                <a:ea typeface="+mn-ea"/>
+                <a:cs typeface="+mn-cs"/>
+              </a:rPr>
+              <a:t>Query get all documents of driver results where the </a:t>
+            </a:r>
+            <a:r>
+              <a:rPr lang="en-GB" sz="1200" b="0" i="0" u="none" strike="noStrike" kern="1200" dirty="0" err="1">
+                <a:solidFill>
+                  <a:schemeClr val="tx1"/>
+                </a:solidFill>
+                <a:effectLst/>
+                <a:latin typeface="+mn-lt"/>
+                <a:ea typeface="+mn-ea"/>
+                <a:cs typeface="+mn-cs"/>
+              </a:rPr>
+              <a:t>race_name</a:t>
+            </a:r>
+            <a:r>
+              <a:rPr lang="en-GB" sz="1200" b="0" i="0" u="none" strike="noStrike" kern="1200" dirty="0">
+                <a:solidFill>
+                  <a:schemeClr val="tx1"/>
+                </a:solidFill>
+                <a:effectLst/>
+                <a:latin typeface="+mn-lt"/>
+                <a:ea typeface="+mn-ea"/>
+                <a:cs typeface="+mn-cs"/>
+              </a:rPr>
+              <a:t> is </a:t>
+            </a:r>
+            <a:r>
+              <a:rPr lang="en-GB" sz="1200" b="0" i="0" u="none" strike="noStrike" kern="1200" dirty="0" err="1">
+                <a:solidFill>
+                  <a:schemeClr val="tx1"/>
+                </a:solidFill>
+                <a:effectLst/>
+                <a:latin typeface="+mn-lt"/>
+                <a:ea typeface="+mn-ea"/>
+                <a:cs typeface="+mn-cs"/>
+              </a:rPr>
+              <a:t>monaco</a:t>
+            </a:r>
+            <a:r>
+              <a:rPr lang="en-GB" sz="1200" b="0" i="0" u="none" strike="noStrike" kern="1200" dirty="0">
+                <a:solidFill>
+                  <a:schemeClr val="tx1"/>
+                </a:solidFill>
+                <a:effectLst/>
+                <a:latin typeface="+mn-lt"/>
+                <a:ea typeface="+mn-ea"/>
+                <a:cs typeface="+mn-cs"/>
+              </a:rPr>
+              <a:t> </a:t>
+            </a:r>
             <a:endParaRPr lang="en-AT" dirty="0"/>
           </a:p>
         </p:txBody>
@@ -1904,7 +3189,7 @@
         <p:cNvPr id="1" name="">
           <a:extLst>
             <a:ext uri="{FF2B5EF4-FFF2-40B4-BE49-F238E27FC236}">
-              <a16:creationId xmlns:a16="http://schemas.microsoft.com/office/drawing/2014/main" id="{DBFE9B7A-2047-D6D3-11BC-54F37C4C8A71}"/>
+              <a16:creationId xmlns:a16="http://schemas.microsoft.com/office/drawing/2014/main" id="{C2ECB3E3-77D4-EA37-7D52-31157EED6DF7}"/>
             </a:ext>
           </a:extLst>
         </p:cNvPr>
@@ -1924,7 +3209,7 @@
           <p:cNvPr id="2" name="Slide Image Placeholder 1">
             <a:extLst>
               <a:ext uri="{FF2B5EF4-FFF2-40B4-BE49-F238E27FC236}">
-                <a16:creationId xmlns:a16="http://schemas.microsoft.com/office/drawing/2014/main" id="{B4360CA5-BEB2-E327-F211-9F8D85CBA393}"/>
+                <a16:creationId xmlns:a16="http://schemas.microsoft.com/office/drawing/2014/main" id="{1BC4FFE6-81C1-3B4A-1883-C1B13612892B}"/>
               </a:ext>
             </a:extLst>
           </p:cNvPr>
@@ -1942,7 +3227,7 @@
           <p:cNvPr id="3" name="Notes Placeholder 2">
             <a:extLst>
               <a:ext uri="{FF2B5EF4-FFF2-40B4-BE49-F238E27FC236}">
-                <a16:creationId xmlns:a16="http://schemas.microsoft.com/office/drawing/2014/main" id="{CFDA3D05-C486-3039-BE33-C040DA900A14}"/>
+                <a16:creationId xmlns:a16="http://schemas.microsoft.com/office/drawing/2014/main" id="{4D93512F-B1FA-EB6F-32A1-33E9BE6AB437}"/>
               </a:ext>
             </a:extLst>
           </p:cNvPr>
@@ -1958,23 +3243,6 @@
           <a:bodyPr/>
           <a:lstStyle/>
           <a:p>
-            <a:pPr marL="0" marR="0" lvl="0" indent="0" algn="l" defTabSz="914400" rtl="0" eaLnBrk="1" fontAlgn="auto" latinLnBrk="0" hangingPunct="1">
-              <a:lnSpc>
-                <a:spcPct val="100000"/>
-              </a:lnSpc>
-              <a:spcBef>
-                <a:spcPts val="0"/>
-              </a:spcBef>
-              <a:spcAft>
-                <a:spcPts val="0"/>
-              </a:spcAft>
-              <a:buClrTx/>
-              <a:buSzTx/>
-              <a:buFontTx/>
-              <a:buNone/>
-              <a:tabLst/>
-              <a:defRPr/>
-            </a:pPr>
             <a:r>
               <a:rPr lang="en-GB" sz="1200" b="0" i="0" kern="1200" dirty="0">
                 <a:solidFill>
@@ -1985,10 +3253,12 @@
                 <a:ea typeface="+mn-ea"/>
                 <a:cs typeface="+mn-cs"/>
               </a:rPr>
-              <a:t>Elasticsearch stores data in </a:t>
-            </a:r>
-            <a:r>
-              <a:rPr lang="en-GB" sz="1200" b="0" i="0" u="sng" kern="1200" dirty="0">
+              <a:t>The key fields worth pointing out on your slide:</a:t>
+            </a:r>
+          </a:p>
+          <a:p>
+            <a:r>
+              <a:rPr lang="en-GB" sz="1200" b="1" i="0" kern="1200" dirty="0">
                 <a:solidFill>
                   <a:schemeClr val="tx1"/>
                 </a:solidFill>
@@ -1996,9 +3266,8 @@
                 <a:latin typeface="+mn-lt"/>
                 <a:ea typeface="+mn-ea"/>
                 <a:cs typeface="+mn-cs"/>
-                <a:hlinkClick r:id="rId3"/>
               </a:rPr>
-              <a:t>JSON </a:t>
+              <a:t>took</a:t>
             </a:r>
             <a:r>
               <a:rPr lang="en-GB" sz="1200" b="0" i="0" kern="1200" dirty="0">
@@ -2010,11 +3279,86 @@
                 <a:ea typeface="+mn-ea"/>
                 <a:cs typeface="+mn-cs"/>
               </a:rPr>
-              <a:t>format and making it easy to index and search structured and unstructured data.</a:t>
-            </a:r>
-          </a:p>
-          <a:p>
-            <a:endParaRPr lang="en-AT" dirty="0"/>
+              <a:t> — how many milliseconds the query took (3ms!)</a:t>
+            </a:r>
+          </a:p>
+          <a:p>
+            <a:r>
+              <a:rPr lang="en-GB" sz="1200" b="1" i="0" kern="1200" dirty="0" err="1">
+                <a:solidFill>
+                  <a:schemeClr val="tx1"/>
+                </a:solidFill>
+                <a:effectLst/>
+                <a:latin typeface="+mn-lt"/>
+                <a:ea typeface="+mn-ea"/>
+                <a:cs typeface="+mn-cs"/>
+              </a:rPr>
+              <a:t>total.value</a:t>
+            </a:r>
+            <a:r>
+              <a:rPr lang="en-GB" sz="1200" b="0" i="0" kern="1200" dirty="0">
+                <a:solidFill>
+                  <a:schemeClr val="tx1"/>
+                </a:solidFill>
+                <a:effectLst/>
+                <a:latin typeface="+mn-lt"/>
+                <a:ea typeface="+mn-ea"/>
+                <a:cs typeface="+mn-cs"/>
+              </a:rPr>
+              <a:t> — total number of matching documents (418 — remember, one per driver result)</a:t>
+            </a:r>
+          </a:p>
+          <a:p>
+            <a:r>
+              <a:rPr lang="en-GB" sz="1200" b="1" i="0" kern="1200" dirty="0">
+                <a:solidFill>
+                  <a:schemeClr val="tx1"/>
+                </a:solidFill>
+                <a:effectLst/>
+                <a:latin typeface="+mn-lt"/>
+                <a:ea typeface="+mn-ea"/>
+                <a:cs typeface="+mn-cs"/>
+              </a:rPr>
+              <a:t>_score</a:t>
+            </a:r>
+            <a:r>
+              <a:rPr lang="en-GB" sz="1200" b="0" i="0" kern="1200" dirty="0">
+                <a:solidFill>
+                  <a:schemeClr val="tx1"/>
+                </a:solidFill>
+                <a:effectLst/>
+                <a:latin typeface="+mn-lt"/>
+                <a:ea typeface="+mn-ea"/>
+                <a:cs typeface="+mn-cs"/>
+              </a:rPr>
+              <a:t> — the relevance score, higher = better match</a:t>
+            </a:r>
+          </a:p>
+          <a:p>
+            <a:r>
+              <a:rPr lang="en-GB" sz="1200" b="1" i="0" kern="1200" dirty="0">
+                <a:solidFill>
+                  <a:schemeClr val="tx1"/>
+                </a:solidFill>
+                <a:effectLst/>
+                <a:latin typeface="+mn-lt"/>
+                <a:ea typeface="+mn-ea"/>
+                <a:cs typeface="+mn-cs"/>
+              </a:rPr>
+              <a:t>_source</a:t>
+            </a:r>
+            <a:r>
+              <a:rPr lang="en-GB" sz="1200" b="0" i="0" kern="1200" dirty="0">
+                <a:solidFill>
+                  <a:schemeClr val="tx1"/>
+                </a:solidFill>
+                <a:effectLst/>
+                <a:latin typeface="+mn-lt"/>
+                <a:ea typeface="+mn-ea"/>
+                <a:cs typeface="+mn-cs"/>
+              </a:rPr>
+              <a:t> — the actual document data you indexed</a:t>
+            </a:r>
           </a:p>
         </p:txBody>
       </p:sp>
@@ -2023,7 +3367,7 @@
           <p:cNvPr id="4" name="Slide Number Placeholder 3">
             <a:extLst>
               <a:ext uri="{FF2B5EF4-FFF2-40B4-BE49-F238E27FC236}">
-                <a16:creationId xmlns:a16="http://schemas.microsoft.com/office/drawing/2014/main" id="{17360B0D-1C08-4B2A-A34B-73A56EE7BA80}"/>
+                <a16:creationId xmlns:a16="http://schemas.microsoft.com/office/drawing/2014/main" id="{5CDAC94C-B877-45B7-4B8B-77D1C4B27D31}"/>
               </a:ext>
             </a:extLst>
           </p:cNvPr>
@@ -2050,7 +3394,7 @@
     </p:spTree>
     <p:extLst>
       <p:ext uri="{BB962C8B-B14F-4D97-AF65-F5344CB8AC3E}">
-        <p14:creationId xmlns:p14="http://schemas.microsoft.com/office/powerpoint/2010/main" val="2434815636"/>
+        <p14:creationId xmlns:p14="http://schemas.microsoft.com/office/powerpoint/2010/main" val="3243757127"/>
       </p:ext>
     </p:extLst>
   </p:cSld>
@@ -2209,7 +3553,7 @@
           <a:p>
             <a:fld id="{A591BDEC-81C3-DB48-92B3-4E74693DD55D}" type="datetimeFigureOut">
               <a:rPr lang="en-AT" smtClean="0"/>
-              <a:t>01.05.26</a:t>
+              <a:t>04.05.26</a:t>
             </a:fld>
             <a:endParaRPr lang="en-AT"/>
           </a:p>
@@ -2409,7 +3753,7 @@
           <a:p>
             <a:fld id="{A591BDEC-81C3-DB48-92B3-4E74693DD55D}" type="datetimeFigureOut">
               <a:rPr lang="en-AT" smtClean="0"/>
-              <a:t>01.05.26</a:t>
+              <a:t>04.05.26</a:t>
             </a:fld>
             <a:endParaRPr lang="en-AT"/>
           </a:p>
@@ -2619,7 +3963,7 @@
           <a:p>
             <a:fld id="{A591BDEC-81C3-DB48-92B3-4E74693DD55D}" type="datetimeFigureOut">
               <a:rPr lang="en-AT" smtClean="0"/>
-              <a:t>01.05.26</a:t>
+              <a:t>04.05.26</a:t>
             </a:fld>
             <a:endParaRPr lang="en-AT"/>
           </a:p>
@@ -2820,7 +4164,7 @@
             <a:fld id="{2C923EFC-C784-AC46-AE3C-8E1B6BCAD649}" type="datetime1">
               <a:rPr lang="en-US" smtClean="0"/>
               <a:pPr/>
-              <a:t>5/1/26</a:t>
+              <a:t>5/4/26</a:t>
             </a:fld>
             <a:endParaRPr lang="en-AT" dirty="0"/>
           </a:p>
@@ -3828,7 +5172,7 @@
           <a:p>
             <a:fld id="{A591BDEC-81C3-DB48-92B3-4E74693DD55D}" type="datetimeFigureOut">
               <a:rPr lang="en-AT" smtClean="0"/>
-              <a:t>01.05.26</a:t>
+              <a:t>04.05.26</a:t>
             </a:fld>
             <a:endParaRPr lang="en-AT"/>
           </a:p>
@@ -4525,7 +5869,7 @@
           <a:p>
             <a:fld id="{A591BDEC-81C3-DB48-92B3-4E74693DD55D}" type="datetimeFigureOut">
               <a:rPr lang="en-AT" smtClean="0"/>
-              <a:t>01.05.26</a:t>
+              <a:t>04.05.26</a:t>
             </a:fld>
             <a:endParaRPr lang="en-AT"/>
           </a:p>
@@ -5636,7 +6980,7 @@
           <a:p>
             <a:fld id="{A591BDEC-81C3-DB48-92B3-4E74693DD55D}" type="datetimeFigureOut">
               <a:rPr lang="en-AT" smtClean="0"/>
-              <a:t>01.05.26</a:t>
+              <a:t>04.05.26</a:t>
             </a:fld>
             <a:endParaRPr lang="en-AT"/>
           </a:p>
@@ -6474,7 +7818,7 @@
           <a:p>
             <a:fld id="{A591BDEC-81C3-DB48-92B3-4E74693DD55D}" type="datetimeFigureOut">
               <a:rPr lang="en-AT" smtClean="0"/>
-              <a:t>01.05.26</a:t>
+              <a:t>04.05.26</a:t>
             </a:fld>
             <a:endParaRPr lang="en-AT"/>
           </a:p>
@@ -7283,7 +8627,7 @@
           <a:p>
             <a:fld id="{A591BDEC-81C3-DB48-92B3-4E74693DD55D}" type="datetimeFigureOut">
               <a:rPr lang="en-AT" smtClean="0"/>
-              <a:t>01.05.26</a:t>
+              <a:t>04.05.26</a:t>
             </a:fld>
             <a:endParaRPr lang="en-AT"/>
           </a:p>
@@ -8292,7 +9636,7 @@
           <a:p>
             <a:fld id="{A591BDEC-81C3-DB48-92B3-4E74693DD55D}" type="datetimeFigureOut">
               <a:rPr lang="en-AT" smtClean="0"/>
-              <a:t>01.05.26</a:t>
+              <a:t>04.05.26</a:t>
             </a:fld>
             <a:endParaRPr lang="en-AT"/>
           </a:p>
@@ -9010,7 +10354,7 @@
           <a:p>
             <a:fld id="{A591BDEC-81C3-DB48-92B3-4E74693DD55D}" type="datetimeFigureOut">
               <a:rPr lang="en-AT" smtClean="0"/>
-              <a:t>01.05.26</a:t>
+              <a:t>04.05.26</a:t>
             </a:fld>
             <a:endParaRPr lang="en-AT"/>
           </a:p>
@@ -9682,7 +11026,7 @@
           <a:p>
             <a:fld id="{A591BDEC-81C3-DB48-92B3-4E74693DD55D}" type="datetimeFigureOut">
               <a:rPr lang="en-AT" smtClean="0"/>
-              <a:t>01.05.26</a:t>
+              <a:t>04.05.26</a:t>
             </a:fld>
             <a:endParaRPr lang="en-AT"/>
           </a:p>
@@ -10223,7 +11567,7 @@
           <a:p>
             <a:fld id="{343E18A4-A905-2445-944B-CEA2A38DE8BE}" type="datetime4">
               <a:rPr lang="en-AT" sz="1600"/>
-              <a:t>May 1, 2026</a:t>
+              <a:t>4. May 2026</a:t>
             </a:fld>
             <a:endParaRPr lang="en-AT" sz="1600" dirty="0"/>
           </a:p>
@@ -10317,7 +11661,7 @@
         <p:cNvPr id="1" name="">
           <a:extLst>
             <a:ext uri="{FF2B5EF4-FFF2-40B4-BE49-F238E27FC236}">
-              <a16:creationId xmlns:a16="http://schemas.microsoft.com/office/drawing/2014/main" id="{69F198E3-B852-25C3-C070-66A39EDB23EF}"/>
+              <a16:creationId xmlns:a16="http://schemas.microsoft.com/office/drawing/2014/main" id="{24B2B20B-3DEC-9217-4354-AA82BA6C2828}"/>
             </a:ext>
           </a:extLst>
         </p:cNvPr>
@@ -10337,7 +11681,7 @@
           <p:cNvPr id="2" name="Title 1">
             <a:extLst>
               <a:ext uri="{FF2B5EF4-FFF2-40B4-BE49-F238E27FC236}">
-                <a16:creationId xmlns:a16="http://schemas.microsoft.com/office/drawing/2014/main" id="{1830B527-C770-2AA9-2642-4B4FECAF9D73}"/>
+                <a16:creationId xmlns:a16="http://schemas.microsoft.com/office/drawing/2014/main" id="{4993BFEF-7E89-0A91-5B6B-F228A46DB0DC}"/>
               </a:ext>
             </a:extLst>
           </p:cNvPr>
@@ -10355,7 +11699,7 @@
           <a:p>
             <a:r>
               <a:rPr lang="en-AT" dirty="0"/>
-              <a:t>Advanteges &amp; Disadvanteges</a:t>
+              <a:t>How does it work</a:t>
             </a:r>
           </a:p>
         </p:txBody>
@@ -10365,7 +11709,7 @@
           <p:cNvPr id="3" name="Content Placeholder 2">
             <a:extLst>
               <a:ext uri="{FF2B5EF4-FFF2-40B4-BE49-F238E27FC236}">
-                <a16:creationId xmlns:a16="http://schemas.microsoft.com/office/drawing/2014/main" id="{5A09DB83-1D22-7B61-FBE3-0CD9EB2B7BBB}"/>
+                <a16:creationId xmlns:a16="http://schemas.microsoft.com/office/drawing/2014/main" id="{910646B5-1CC7-DEFE-48BF-9E01221E6336}"/>
               </a:ext>
             </a:extLst>
           </p:cNvPr>
@@ -10381,20 +11725,51 @@
           <a:bodyPr/>
           <a:lstStyle/>
           <a:p>
-            <a:pPr marL="0" indent="0">
-              <a:buNone/>
-            </a:pPr>
-            <a:endParaRPr lang="en-AT" dirty="0"/>
-          </a:p>
-          <a:p>
-            <a:endParaRPr lang="en-AT" dirty="0"/>
+            <a:r>
+              <a:rPr lang="en-AT" b="1" dirty="0"/>
+              <a:t>Sharding and Replication</a:t>
+            </a:r>
+          </a:p>
+          <a:p>
+            <a:pPr lvl="1"/>
+            <a:r>
+              <a:rPr lang="en-AT" dirty="0"/>
+              <a:t>An Index split into shards distributed across nodes</a:t>
+            </a:r>
+          </a:p>
+          <a:p>
+            <a:pPr lvl="1"/>
+            <a:r>
+              <a:rPr lang="en-AT" dirty="0"/>
+              <a:t>Replicas of shard as backup</a:t>
+            </a:r>
+          </a:p>
+          <a:p>
+            <a:r>
+              <a:rPr lang="en-AT" b="1" dirty="0"/>
+              <a:t>Distributed Search</a:t>
+            </a:r>
+          </a:p>
+          <a:p>
+            <a:pPr lvl="1"/>
+            <a:r>
+              <a:rPr lang="en-AT" dirty="0"/>
+              <a:t>ES communicates with all nodes in the cluster to fetch all relevant data</a:t>
+            </a:r>
+          </a:p>
+          <a:p>
+            <a:pPr lvl="1"/>
+            <a:r>
+              <a:rPr lang="en-AT" dirty="0"/>
+              <a:t>Node requests are parrallel and the results are merged together</a:t>
+            </a:r>
           </a:p>
         </p:txBody>
       </p:sp>
     </p:spTree>
     <p:extLst>
       <p:ext uri="{BB962C8B-B14F-4D97-AF65-F5344CB8AC3E}">
-        <p14:creationId xmlns:p14="http://schemas.microsoft.com/office/powerpoint/2010/main" val="3808658081"/>
+        <p14:creationId xmlns:p14="http://schemas.microsoft.com/office/powerpoint/2010/main" val="544173334"/>
       </p:ext>
     </p:extLst>
   </p:cSld>
@@ -10476,16 +11851,122 @@
           <a:bodyPr/>
           <a:lstStyle/>
           <a:p>
-            <a:pPr marL="0" indent="0">
-              <a:buNone/>
-            </a:pPr>
+            <a:r>
+              <a:rPr lang="en-AT" b="1" dirty="0"/>
+              <a:t>RESTful API</a:t>
+            </a:r>
+          </a:p>
+          <a:p>
+            <a:pPr lvl="1"/>
+            <a:r>
+              <a:rPr lang="en-AT" dirty="0"/>
+              <a:t>Operation carried out via HTTP Request (GET, POST, PUT, DELETE)</a:t>
+            </a:r>
+          </a:p>
+          <a:p>
+            <a:r>
+              <a:rPr lang="en-AT" b="1" dirty="0"/>
+              <a:t>Query DSL</a:t>
+            </a:r>
+          </a:p>
+          <a:p>
+            <a:pPr lvl="1"/>
+            <a:r>
+              <a:rPr lang="en-AT" dirty="0"/>
+              <a:t>JSON domain-specific language for building queries</a:t>
+            </a:r>
+          </a:p>
+          <a:p>
+            <a:pPr lvl="1"/>
+            <a:r>
+              <a:rPr lang="en-AT" dirty="0"/>
+              <a:t>Types: </a:t>
+            </a:r>
+            <a:r>
+              <a:rPr lang="en-AT" b="1" dirty="0"/>
+              <a:t>match</a:t>
+            </a:r>
+            <a:r>
+              <a:rPr lang="en-AT" dirty="0"/>
+              <a:t> (full-text), </a:t>
+            </a:r>
+            <a:r>
+              <a:rPr lang="en-AT" b="1" dirty="0"/>
+              <a:t>term</a:t>
+            </a:r>
+            <a:r>
+              <a:rPr lang="en-AT" dirty="0"/>
+              <a:t> (exact), </a:t>
+            </a:r>
+            <a:r>
+              <a:rPr lang="en-AT" b="1" dirty="0"/>
+              <a:t>bool</a:t>
+            </a:r>
+            <a:r>
+              <a:rPr lang="en-AT" dirty="0"/>
+              <a:t> ( compound), </a:t>
+            </a:r>
+            <a:r>
+              <a:rPr lang="en-AT" b="1" dirty="0"/>
+              <a:t>range</a:t>
+            </a:r>
+            <a:r>
+              <a:rPr lang="en-AT" dirty="0"/>
+              <a:t> (numeric, date), </a:t>
+            </a:r>
+            <a:r>
+              <a:rPr lang="en-AT" b="1" dirty="0"/>
+              <a:t>fuzzy</a:t>
+            </a:r>
+            <a:r>
+              <a:rPr lang="en-AT" dirty="0"/>
+              <a:t> and </a:t>
+            </a:r>
+            <a:r>
+              <a:rPr lang="en-AT" b="1" dirty="0"/>
+              <a:t>aggs </a:t>
+            </a:r>
+            <a:r>
+              <a:rPr lang="en-AT" dirty="0"/>
+              <a:t>(aggreagation)</a:t>
+            </a:r>
+            <a:endParaRPr lang="en-AT" b="1" dirty="0"/>
+          </a:p>
+          <a:p>
             <a:endParaRPr lang="en-AT" dirty="0"/>
           </a:p>
-          <a:p>
-            <a:endParaRPr lang="en-AT" dirty="0"/>
-          </a:p>
         </p:txBody>
       </p:sp>
+      <p:pic>
+        <p:nvPicPr>
+          <p:cNvPr id="6" name="Picture 5">
+            <a:extLst>
+              <a:ext uri="{FF2B5EF4-FFF2-40B4-BE49-F238E27FC236}">
+                <a16:creationId xmlns:a16="http://schemas.microsoft.com/office/drawing/2014/main" id="{7AE6EA4D-8EFC-6B0A-7623-0882F103D034}"/>
+              </a:ext>
+            </a:extLst>
+          </p:cNvPr>
+          <p:cNvPicPr>
+            <a:picLocks noChangeAspect="1"/>
+          </p:cNvPicPr>
+          <p:nvPr/>
+        </p:nvPicPr>
+        <p:blipFill>
+          <a:blip r:embed="rId3"/>
+          <a:stretch>
+            <a:fillRect/>
+          </a:stretch>
+        </p:blipFill>
+        <p:spPr>
+          <a:xfrm>
+            <a:off x="1010388" y="4267051"/>
+            <a:ext cx="3221369" cy="2400832"/>
+          </a:xfrm>
+          <a:prstGeom prst="rect">
+            <a:avLst/>
+          </a:prstGeom>
+        </p:spPr>
+      </p:pic>
     </p:spTree>
     <p:extLst>
       <p:ext uri="{BB962C8B-B14F-4D97-AF65-F5344CB8AC3E}">
@@ -10500,6 +11981,448 @@
 </file>
 
 <file path=ppt/slides/slide12.xml><?xml version="1.0" encoding="utf-8"?>
+<p:sld xmlns:a="http://schemas.openxmlformats.org/drawingml/2006/main" xmlns:r="http://schemas.openxmlformats.org/officeDocument/2006/relationships" xmlns:p="http://schemas.openxmlformats.org/presentationml/2006/main">
+  <p:cSld>
+    <p:spTree>
+      <p:nvGrpSpPr>
+        <p:cNvPr id="1" name="">
+          <a:extLst>
+            <a:ext uri="{FF2B5EF4-FFF2-40B4-BE49-F238E27FC236}">
+              <a16:creationId xmlns:a16="http://schemas.microsoft.com/office/drawing/2014/main" id="{45C6A573-1AC3-D042-0B50-81529EE27422}"/>
+            </a:ext>
+          </a:extLst>
+        </p:cNvPr>
+        <p:cNvGrpSpPr/>
+        <p:nvPr/>
+      </p:nvGrpSpPr>
+      <p:grpSpPr>
+        <a:xfrm>
+          <a:off x="0" y="0"/>
+          <a:ext cx="0" cy="0"/>
+          <a:chOff x="0" y="0"/>
+          <a:chExt cx="0" cy="0"/>
+        </a:xfrm>
+      </p:grpSpPr>
+      <p:sp>
+        <p:nvSpPr>
+          <p:cNvPr id="2" name="Title 1">
+            <a:extLst>
+              <a:ext uri="{FF2B5EF4-FFF2-40B4-BE49-F238E27FC236}">
+                <a16:creationId xmlns:a16="http://schemas.microsoft.com/office/drawing/2014/main" id="{FEED723F-C4A8-951A-187D-4B4CE4CC4A71}"/>
+              </a:ext>
+            </a:extLst>
+          </p:cNvPr>
+          <p:cNvSpPr>
+            <a:spLocks noGrp="1"/>
+          </p:cNvSpPr>
+          <p:nvPr>
+            <p:ph type="title"/>
+          </p:nvPr>
+        </p:nvSpPr>
+        <p:spPr/>
+        <p:txBody>
+          <a:bodyPr/>
+          <a:lstStyle/>
+          <a:p>
+            <a:r>
+              <a:rPr lang="en-AT" dirty="0"/>
+              <a:t>Query Language &amp; API</a:t>
+            </a:r>
+          </a:p>
+        </p:txBody>
+      </p:sp>
+      <p:pic>
+        <p:nvPicPr>
+          <p:cNvPr id="4" name="Content Placeholder 3">
+            <a:extLst>
+              <a:ext uri="{FF2B5EF4-FFF2-40B4-BE49-F238E27FC236}">
+                <a16:creationId xmlns:a16="http://schemas.microsoft.com/office/drawing/2014/main" id="{4AEF158B-5C4E-5939-D936-A8218FEB23BD}"/>
+              </a:ext>
+            </a:extLst>
+          </p:cNvPr>
+          <p:cNvPicPr>
+            <a:picLocks noGrp="1" noChangeAspect="1"/>
+          </p:cNvPicPr>
+          <p:nvPr>
+            <p:ph idx="1"/>
+          </p:nvPr>
+        </p:nvPicPr>
+        <p:blipFill>
+          <a:blip r:embed="rId3"/>
+          <a:stretch>
+            <a:fillRect/>
+          </a:stretch>
+        </p:blipFill>
+        <p:spPr>
+          <a:xfrm>
+            <a:off x="3970079" y="1690688"/>
+            <a:ext cx="2675269" cy="5073224"/>
+          </a:xfrm>
+          <a:prstGeom prst="rect">
+            <a:avLst/>
+          </a:prstGeom>
+        </p:spPr>
+      </p:pic>
+    </p:spTree>
+    <p:extLst>
+      <p:ext uri="{BB962C8B-B14F-4D97-AF65-F5344CB8AC3E}">
+        <p14:creationId xmlns:p14="http://schemas.microsoft.com/office/powerpoint/2010/main" val="3900156171"/>
+      </p:ext>
+    </p:extLst>
+  </p:cSld>
+  <p:clrMapOvr>
+    <a:masterClrMapping/>
+  </p:clrMapOvr>
+</p:sld>
+</file>
+
+<file path=ppt/slides/slide13.xml><?xml version="1.0" encoding="utf-8"?>
+<p:sld xmlns:a="http://schemas.openxmlformats.org/drawingml/2006/main" xmlns:r="http://schemas.openxmlformats.org/officeDocument/2006/relationships" xmlns:p="http://schemas.openxmlformats.org/presentationml/2006/main">
+  <p:cSld>
+    <p:spTree>
+      <p:nvGrpSpPr>
+        <p:cNvPr id="1" name="">
+          <a:extLst>
+            <a:ext uri="{FF2B5EF4-FFF2-40B4-BE49-F238E27FC236}">
+              <a16:creationId xmlns:a16="http://schemas.microsoft.com/office/drawing/2014/main" id="{E975DA51-6F69-6DCC-3408-D8DE54DFF945}"/>
+            </a:ext>
+          </a:extLst>
+        </p:cNvPr>
+        <p:cNvGrpSpPr/>
+        <p:nvPr/>
+      </p:nvGrpSpPr>
+      <p:grpSpPr>
+        <a:xfrm>
+          <a:off x="0" y="0"/>
+          <a:ext cx="0" cy="0"/>
+          <a:chOff x="0" y="0"/>
+          <a:chExt cx="0" cy="0"/>
+        </a:xfrm>
+      </p:grpSpPr>
+      <p:sp>
+        <p:nvSpPr>
+          <p:cNvPr id="2" name="Title 1">
+            <a:extLst>
+              <a:ext uri="{FF2B5EF4-FFF2-40B4-BE49-F238E27FC236}">
+                <a16:creationId xmlns:a16="http://schemas.microsoft.com/office/drawing/2014/main" id="{E6CD2EA0-789F-CFA0-2CD6-178F567FFBDA}"/>
+              </a:ext>
+            </a:extLst>
+          </p:cNvPr>
+          <p:cNvSpPr>
+            <a:spLocks noGrp="1"/>
+          </p:cNvSpPr>
+          <p:nvPr>
+            <p:ph type="title"/>
+          </p:nvPr>
+        </p:nvSpPr>
+        <p:spPr/>
+        <p:txBody>
+          <a:bodyPr/>
+          <a:lstStyle/>
+          <a:p>
+            <a:r>
+              <a:rPr lang="en-AT" dirty="0"/>
+              <a:t>Usecases</a:t>
+            </a:r>
+          </a:p>
+        </p:txBody>
+      </p:sp>
+      <p:sp>
+        <p:nvSpPr>
+          <p:cNvPr id="3" name="Content Placeholder 2">
+            <a:extLst>
+              <a:ext uri="{FF2B5EF4-FFF2-40B4-BE49-F238E27FC236}">
+                <a16:creationId xmlns:a16="http://schemas.microsoft.com/office/drawing/2014/main" id="{FC178D33-E7F1-F23A-7FC9-24A90C432238}"/>
+              </a:ext>
+            </a:extLst>
+          </p:cNvPr>
+          <p:cNvSpPr>
+            <a:spLocks noGrp="1"/>
+          </p:cNvSpPr>
+          <p:nvPr>
+            <p:ph idx="1"/>
+          </p:nvPr>
+        </p:nvSpPr>
+        <p:spPr/>
+        <p:txBody>
+          <a:bodyPr/>
+          <a:lstStyle/>
+          <a:p>
+            <a:r>
+              <a:rPr lang="en-AT" dirty="0"/>
+              <a:t>Application with search functionality</a:t>
+            </a:r>
+          </a:p>
+          <a:p>
+            <a:pPr lvl="1"/>
+            <a:r>
+              <a:rPr lang="en-AT" dirty="0"/>
+              <a:t>Blog posts, Product catalogs, log files, …</a:t>
+            </a:r>
+          </a:p>
+          <a:p>
+            <a:r>
+              <a:rPr lang="en-AT" dirty="0"/>
+              <a:t>Log and Event Data Analysis</a:t>
+            </a:r>
+          </a:p>
+          <a:p>
+            <a:pPr lvl="1"/>
+            <a:r>
+              <a:rPr lang="en-GB" dirty="0"/>
+              <a:t>R</a:t>
+            </a:r>
+            <a:r>
+              <a:rPr lang="en-AT" dirty="0"/>
+              <a:t>eal-time analysis</a:t>
+            </a:r>
+          </a:p>
+          <a:p>
+            <a:pPr lvl="1"/>
+            <a:r>
+              <a:rPr lang="en-AT" dirty="0"/>
+              <a:t>Detect anomalies</a:t>
+            </a:r>
+          </a:p>
+          <a:p>
+            <a:r>
+              <a:rPr lang="en-AT" dirty="0"/>
+              <a:t>Business Analytics</a:t>
+            </a:r>
+          </a:p>
+          <a:p>
+            <a:r>
+              <a:rPr lang="en-AT" dirty="0"/>
+              <a:t>Geospatial Search</a:t>
+            </a:r>
+          </a:p>
+        </p:txBody>
+      </p:sp>
+      <p:sp>
+        <p:nvSpPr>
+          <p:cNvPr id="4" name="TextBox 3">
+            <a:extLst>
+              <a:ext uri="{FF2B5EF4-FFF2-40B4-BE49-F238E27FC236}">
+                <a16:creationId xmlns:a16="http://schemas.microsoft.com/office/drawing/2014/main" id="{6DAE37E7-D276-B9B4-2E2B-5569C1D71806}"/>
+              </a:ext>
+            </a:extLst>
+          </p:cNvPr>
+          <p:cNvSpPr txBox="1"/>
+          <p:nvPr/>
+        </p:nvSpPr>
+        <p:spPr>
+          <a:xfrm>
+            <a:off x="1786270" y="2743200"/>
+            <a:ext cx="184731" cy="369332"/>
+          </a:xfrm>
+          <a:prstGeom prst="rect">
+            <a:avLst/>
+          </a:prstGeom>
+          <a:noFill/>
+        </p:spPr>
+        <p:txBody>
+          <a:bodyPr wrap="none" rtlCol="0">
+            <a:spAutoFit/>
+          </a:bodyPr>
+          <a:lstStyle/>
+          <a:p>
+            <a:endParaRPr lang="en-AT" dirty="0"/>
+          </a:p>
+        </p:txBody>
+      </p:sp>
+    </p:spTree>
+    <p:extLst>
+      <p:ext uri="{BB962C8B-B14F-4D97-AF65-F5344CB8AC3E}">
+        <p14:creationId xmlns:p14="http://schemas.microsoft.com/office/powerpoint/2010/main" val="1120557849"/>
+      </p:ext>
+    </p:extLst>
+  </p:cSld>
+  <p:clrMapOvr>
+    <a:masterClrMapping/>
+  </p:clrMapOvr>
+</p:sld>
+</file>
+
+<file path=ppt/slides/slide14.xml><?xml version="1.0" encoding="utf-8"?>
+<p:sld xmlns:a="http://schemas.openxmlformats.org/drawingml/2006/main" xmlns:r="http://schemas.openxmlformats.org/officeDocument/2006/relationships" xmlns:p="http://schemas.openxmlformats.org/presentationml/2006/main">
+  <p:cSld>
+    <p:spTree>
+      <p:nvGrpSpPr>
+        <p:cNvPr id="1" name=""/>
+        <p:cNvGrpSpPr/>
+        <p:nvPr/>
+      </p:nvGrpSpPr>
+      <p:grpSpPr>
+        <a:xfrm>
+          <a:off x="0" y="0"/>
+          <a:ext cx="0" cy="0"/>
+          <a:chOff x="0" y="0"/>
+          <a:chExt cx="0" cy="0"/>
+        </a:xfrm>
+      </p:grpSpPr>
+      <p:sp>
+        <p:nvSpPr>
+          <p:cNvPr id="2" name="Title 1">
+            <a:extLst>
+              <a:ext uri="{FF2B5EF4-FFF2-40B4-BE49-F238E27FC236}">
+                <a16:creationId xmlns:a16="http://schemas.microsoft.com/office/drawing/2014/main" id="{385532FC-0F7F-FC65-BE78-DF618C2E3F98}"/>
+              </a:ext>
+            </a:extLst>
+          </p:cNvPr>
+          <p:cNvSpPr>
+            <a:spLocks noGrp="1"/>
+          </p:cNvSpPr>
+          <p:nvPr>
+            <p:ph type="title"/>
+          </p:nvPr>
+        </p:nvSpPr>
+        <p:spPr/>
+        <p:txBody>
+          <a:bodyPr/>
+          <a:lstStyle/>
+          <a:p>
+            <a:r>
+              <a:rPr lang="en-AT" dirty="0"/>
+              <a:t>Advanteges &amp; Disadvanteges</a:t>
+            </a:r>
+          </a:p>
+        </p:txBody>
+      </p:sp>
+      <p:sp>
+        <p:nvSpPr>
+          <p:cNvPr id="3" name="Content Placeholder 2">
+            <a:extLst>
+              <a:ext uri="{FF2B5EF4-FFF2-40B4-BE49-F238E27FC236}">
+                <a16:creationId xmlns:a16="http://schemas.microsoft.com/office/drawing/2014/main" id="{D18ED2D2-F5EB-D9EA-33EE-C825247E4685}"/>
+              </a:ext>
+            </a:extLst>
+          </p:cNvPr>
+          <p:cNvSpPr>
+            <a:spLocks noGrp="1"/>
+          </p:cNvSpPr>
+          <p:nvPr>
+            <p:ph sz="half" idx="1"/>
+          </p:nvPr>
+        </p:nvSpPr>
+        <p:spPr/>
+        <p:txBody>
+          <a:bodyPr/>
+          <a:lstStyle/>
+          <a:p>
+            <a:pPr>
+              <a:buFont typeface="Wingdings" pitchFamily="2" charset="2"/>
+              <a:buChar char="ü"/>
+            </a:pPr>
+            <a:r>
+              <a:rPr lang="en-AT" dirty="0"/>
+              <a:t>Horizontal scalability</a:t>
+            </a:r>
+          </a:p>
+          <a:p>
+            <a:pPr>
+              <a:buFont typeface="Wingdings" pitchFamily="2" charset="2"/>
+              <a:buChar char="ü"/>
+            </a:pPr>
+            <a:r>
+              <a:rPr lang="en-AT" dirty="0"/>
+              <a:t>Real-time search and analytics</a:t>
+            </a:r>
+          </a:p>
+          <a:p>
+            <a:pPr>
+              <a:buFont typeface="Wingdings" pitchFamily="2" charset="2"/>
+              <a:buChar char="ü"/>
+            </a:pPr>
+            <a:r>
+              <a:rPr lang="en-AT" dirty="0"/>
+              <a:t>Different Methods to query data (with Query DSL)</a:t>
+            </a:r>
+          </a:p>
+          <a:p>
+            <a:pPr>
+              <a:buFont typeface="Wingdings" pitchFamily="2" charset="2"/>
+              <a:buChar char="ü"/>
+            </a:pPr>
+            <a:r>
+              <a:rPr lang="en-AT" dirty="0"/>
+              <a:t>Ecosystem (Kibana)</a:t>
+            </a:r>
+          </a:p>
+        </p:txBody>
+      </p:sp>
+      <p:sp>
+        <p:nvSpPr>
+          <p:cNvPr id="4" name="Content Placeholder 3">
+            <a:extLst>
+              <a:ext uri="{FF2B5EF4-FFF2-40B4-BE49-F238E27FC236}">
+                <a16:creationId xmlns:a16="http://schemas.microsoft.com/office/drawing/2014/main" id="{5FA68D11-8F21-7B87-C6B9-D9027C83F746}"/>
+              </a:ext>
+            </a:extLst>
+          </p:cNvPr>
+          <p:cNvSpPr>
+            <a:spLocks noGrp="1"/>
+          </p:cNvSpPr>
+          <p:nvPr>
+            <p:ph sz="half" idx="2"/>
+          </p:nvPr>
+        </p:nvSpPr>
+        <p:spPr/>
+        <p:txBody>
+          <a:bodyPr/>
+          <a:lstStyle/>
+          <a:p>
+            <a:pPr>
+              <a:buFont typeface="System Font Regular"/>
+              <a:buChar char="-"/>
+            </a:pPr>
+            <a:r>
+              <a:rPr lang="en-AT" dirty="0"/>
+              <a:t>Complexe Setup</a:t>
+            </a:r>
+          </a:p>
+          <a:p>
+            <a:pPr>
+              <a:buFont typeface="System Font Regular"/>
+              <a:buChar char="-"/>
+            </a:pPr>
+            <a:r>
+              <a:rPr lang="en-AT" dirty="0"/>
+              <a:t>Resource intensive</a:t>
+            </a:r>
+          </a:p>
+          <a:p>
+            <a:pPr>
+              <a:buFont typeface="System Font Regular"/>
+              <a:buChar char="-"/>
+            </a:pPr>
+            <a:r>
+              <a:rPr lang="en-AT" dirty="0"/>
+              <a:t>No ACID transactions</a:t>
+            </a:r>
+          </a:p>
+          <a:p>
+            <a:pPr>
+              <a:buFont typeface="System Font Regular"/>
+              <a:buChar char="-"/>
+            </a:pPr>
+            <a:endParaRPr lang="en-AT" dirty="0"/>
+          </a:p>
+        </p:txBody>
+      </p:sp>
+    </p:spTree>
+    <p:extLst>
+      <p:ext uri="{BB962C8B-B14F-4D97-AF65-F5344CB8AC3E}">
+        <p14:creationId xmlns:p14="http://schemas.microsoft.com/office/powerpoint/2010/main" val="1086762499"/>
+      </p:ext>
+    </p:extLst>
+  </p:cSld>
+  <p:clrMapOvr>
+    <a:masterClrMapping/>
+  </p:clrMapOvr>
+</p:sld>
+</file>
+
+<file path=ppt/slides/slide15.xml><?xml version="1.0" encoding="utf-8"?>
 <p:sld xmlns:a="http://schemas.openxmlformats.org/drawingml/2006/main" xmlns:r="http://schemas.openxmlformats.org/officeDocument/2006/relationships" xmlns:p="http://schemas.openxmlformats.org/presentationml/2006/main">
   <p:cSld>
     <p:spTree>
@@ -10594,7 +12517,7 @@
 </p:sld>
 </file>
 
-<file path=ppt/slides/slide13.xml><?xml version="1.0" encoding="utf-8"?>
+<file path=ppt/slides/slide16.xml><?xml version="1.0" encoding="utf-8"?>
 <p:sld xmlns:a="http://schemas.openxmlformats.org/drawingml/2006/main" xmlns:r="http://schemas.openxmlformats.org/officeDocument/2006/relationships" xmlns:p="http://schemas.openxmlformats.org/presentationml/2006/main">
   <p:cSld>
     <p:spTree>
@@ -10667,29 +12590,41 @@
           <a:lstStyle/>
           <a:p>
             <a:r>
-              <a:rPr lang="en-GB" dirty="0">
+              <a:rPr lang="en-GB" sz="1800" dirty="0">
                 <a:hlinkClick r:id="rId3"/>
               </a:rPr>
               <a:t>https://www.purestorage.com/knowledge/elasticsearch-architecture.html</a:t>
             </a:r>
-            <a:endParaRPr lang="en-GB" dirty="0"/>
-          </a:p>
-          <a:p>
-            <a:r>
-              <a:rPr lang="en-GB" dirty="0">
+            <a:endParaRPr lang="en-GB" sz="1800" dirty="0"/>
+          </a:p>
+          <a:p>
+            <a:r>
+              <a:rPr lang="en-GB" sz="1800" dirty="0">
                 <a:hlinkClick r:id="rId4"/>
               </a:rPr>
               <a:t>https://www.geeksforgeeks.org/elasticsearch/elasticsearch-architecture/</a:t>
             </a:r>
-            <a:endParaRPr lang="en-AT" dirty="0"/>
-          </a:p>
-          <a:p>
-            <a:r>
-              <a:rPr lang="en-GB" dirty="0">
+            <a:endParaRPr lang="en-AT" sz="1800" dirty="0"/>
+          </a:p>
+          <a:p>
+            <a:r>
+              <a:rPr lang="en-GB" sz="1800" dirty="0">
                 <a:hlinkClick r:id="rId5"/>
               </a:rPr>
               <a:t>https://www.geeksforgeeks.org/elasticsearch/what-is-elastic-search-and-why-is-it-used/</a:t>
             </a:r>
+            <a:endParaRPr lang="en-GB" sz="1800" dirty="0"/>
+          </a:p>
+          <a:p>
+            <a:r>
+              <a:rPr lang="en-GB" sz="1800" dirty="0">
+                <a:hlinkClick r:id="rId6"/>
+              </a:rPr>
+              <a:t>https://www.elastic.co/elasticsearch/features</a:t>
+            </a:r>
+            <a:endParaRPr lang="en-GB" sz="1800" dirty="0"/>
+          </a:p>
+          <a:p>
             <a:endParaRPr lang="en-GB" dirty="0"/>
           </a:p>
           <a:p>
@@ -12523,10 +14458,34 @@
           <a:bodyPr/>
           <a:lstStyle/>
           <a:p>
-            <a:pPr marL="0" indent="0">
-              <a:buNone/>
-            </a:pPr>
-            <a:endParaRPr lang="en-AT" dirty="0"/>
+            <a:r>
+              <a:rPr lang="en-AT" dirty="0"/>
+              <a:t>Distributed and Scalable</a:t>
+            </a:r>
+          </a:p>
+          <a:p>
+            <a:r>
+              <a:rPr lang="en-AT" dirty="0"/>
+              <a:t>Real-Time Data Analysis</a:t>
+            </a:r>
+          </a:p>
+          <a:p>
+            <a:r>
+              <a:rPr lang="en-AT" dirty="0"/>
+              <a:t>Full-Text Search</a:t>
+            </a:r>
+          </a:p>
+          <a:p>
+            <a:r>
+              <a:rPr lang="en-AT" dirty="0"/>
+              <a:t>RESTful API</a:t>
+            </a:r>
+          </a:p>
+          <a:p>
+            <a:r>
+              <a:rPr lang="en-AT" dirty="0"/>
+              <a:t>Schemaless</a:t>
+            </a:r>
           </a:p>
           <a:p>
             <a:endParaRPr lang="en-AT" dirty="0"/>
@@ -12618,9 +14577,62 @@
           <a:bodyPr/>
           <a:lstStyle/>
           <a:p>
-            <a:pPr marL="0" indent="0">
-              <a:buNone/>
-            </a:pPr>
+            <a:r>
+              <a:rPr lang="en-AT" b="1" dirty="0"/>
+              <a:t>Indexing</a:t>
+            </a:r>
+          </a:p>
+          <a:p>
+            <a:pPr lvl="1"/>
+            <a:r>
+              <a:rPr lang="en-AT" dirty="0"/>
+              <a:t>Data is analysed </a:t>
+            </a:r>
+            <a:r>
+              <a:rPr lang="en-AT" dirty="0">
+                <a:sym typeface="Wingdings" pitchFamily="2" charset="2"/>
+              </a:rPr>
+              <a:t> tokenized  stored in inverted index</a:t>
+            </a:r>
+          </a:p>
+          <a:p>
+            <a:pPr lvl="1"/>
+            <a:endParaRPr lang="en-AT" dirty="0">
+              <a:sym typeface="Wingdings" pitchFamily="2" charset="2"/>
+            </a:endParaRPr>
+          </a:p>
+          <a:p>
+            <a:pPr lvl="1"/>
+            <a:endParaRPr lang="en-AT" dirty="0">
+              <a:sym typeface="Wingdings" pitchFamily="2" charset="2"/>
+            </a:endParaRPr>
+          </a:p>
+          <a:p>
+            <a:pPr lvl="1"/>
+            <a:endParaRPr lang="en-AT" dirty="0">
+              <a:sym typeface="Wingdings" pitchFamily="2" charset="2"/>
+            </a:endParaRPr>
+          </a:p>
+          <a:p>
+            <a:pPr lvl="1"/>
+            <a:endParaRPr lang="en-AT" dirty="0">
+              <a:sym typeface="Wingdings" pitchFamily="2" charset="2"/>
+            </a:endParaRPr>
+          </a:p>
+          <a:p>
+            <a:pPr lvl="1"/>
+            <a:endParaRPr lang="en-AT" dirty="0">
+              <a:sym typeface="Wingdings" pitchFamily="2" charset="2"/>
+            </a:endParaRPr>
+          </a:p>
+          <a:p>
+            <a:pPr lvl="1"/>
+            <a:r>
+              <a:rPr lang="en-AT" dirty="0">
+                <a:sym typeface="Wingdings" pitchFamily="2" charset="2"/>
+              </a:rPr>
+              <a:t>Instant lookups without scanning every record</a:t>
+            </a:r>
             <a:endParaRPr lang="en-AT" dirty="0"/>
           </a:p>
           <a:p>
@@ -12628,6 +14640,315 @@
           </a:p>
         </p:txBody>
       </p:sp>
+      <p:grpSp>
+        <p:nvGrpSpPr>
+          <p:cNvPr id="11" name="Group 10">
+            <a:extLst>
+              <a:ext uri="{FF2B5EF4-FFF2-40B4-BE49-F238E27FC236}">
+                <a16:creationId xmlns:a16="http://schemas.microsoft.com/office/drawing/2014/main" id="{C2472689-7A41-A70C-5E9C-CDCB03381588}"/>
+              </a:ext>
+            </a:extLst>
+          </p:cNvPr>
+          <p:cNvGrpSpPr/>
+          <p:nvPr/>
+        </p:nvGrpSpPr>
+        <p:grpSpPr>
+          <a:xfrm>
+            <a:off x="251150" y="3072809"/>
+            <a:ext cx="3013046" cy="712381"/>
+            <a:chOff x="251149" y="3306726"/>
+            <a:chExt cx="3461657" cy="826735"/>
+          </a:xfrm>
+        </p:grpSpPr>
+        <p:sp>
+          <p:nvSpPr>
+            <p:cNvPr id="10" name="Rectangle 9">
+              <a:extLst>
+                <a:ext uri="{FF2B5EF4-FFF2-40B4-BE49-F238E27FC236}">
+                  <a16:creationId xmlns:a16="http://schemas.microsoft.com/office/drawing/2014/main" id="{7CDBC851-880E-EACC-7E51-2912EACCF5E0}"/>
+                </a:ext>
+              </a:extLst>
+            </p:cNvPr>
+            <p:cNvSpPr/>
+            <p:nvPr/>
+          </p:nvSpPr>
+          <p:spPr>
+            <a:xfrm>
+              <a:off x="251149" y="3306726"/>
+              <a:ext cx="3461657" cy="826735"/>
+            </a:xfrm>
+            <a:prstGeom prst="rect">
+              <a:avLst/>
+            </a:prstGeom>
+            <a:solidFill>
+              <a:srgbClr val="00BFB3"/>
+            </a:solidFill>
+            <a:ln>
+              <a:noFill/>
+            </a:ln>
+          </p:spPr>
+          <p:style>
+            <a:lnRef idx="2">
+              <a:schemeClr val="accent1">
+                <a:shade val="15000"/>
+              </a:schemeClr>
+            </a:lnRef>
+            <a:fillRef idx="1">
+              <a:schemeClr val="accent1"/>
+            </a:fillRef>
+            <a:effectRef idx="0">
+              <a:schemeClr val="accent1"/>
+            </a:effectRef>
+            <a:fontRef idx="minor">
+              <a:schemeClr val="lt1"/>
+            </a:fontRef>
+          </p:style>
+          <p:txBody>
+            <a:bodyPr rtlCol="0" anchor="ctr"/>
+            <a:lstStyle/>
+            <a:p>
+              <a:pPr algn="ctr"/>
+              <a:endParaRPr lang="en-AT"/>
+            </a:p>
+          </p:txBody>
+        </p:sp>
+        <p:pic>
+          <p:nvPicPr>
+            <p:cNvPr id="7" name="Picture 6">
+              <a:extLst>
+                <a:ext uri="{FF2B5EF4-FFF2-40B4-BE49-F238E27FC236}">
+                  <a16:creationId xmlns:a16="http://schemas.microsoft.com/office/drawing/2014/main" id="{E1D9A5AF-BA1F-16E8-8A10-17FCC7E07E7B}"/>
+                </a:ext>
+              </a:extLst>
+            </p:cNvPr>
+            <p:cNvPicPr>
+              <a:picLocks noChangeAspect="1"/>
+            </p:cNvPicPr>
+            <p:nvPr/>
+          </p:nvPicPr>
+          <p:blipFill>
+            <a:blip r:embed="rId3"/>
+            <a:stretch>
+              <a:fillRect/>
+            </a:stretch>
+          </p:blipFill>
+          <p:spPr>
+            <a:xfrm>
+              <a:off x="334347" y="3387308"/>
+              <a:ext cx="3295260" cy="647945"/>
+            </a:xfrm>
+            <a:prstGeom prst="rect">
+              <a:avLst/>
+            </a:prstGeom>
+          </p:spPr>
+        </p:pic>
+      </p:grpSp>
+      <p:grpSp>
+        <p:nvGrpSpPr>
+          <p:cNvPr id="14" name="Group 13">
+            <a:extLst>
+              <a:ext uri="{FF2B5EF4-FFF2-40B4-BE49-F238E27FC236}">
+                <a16:creationId xmlns:a16="http://schemas.microsoft.com/office/drawing/2014/main" id="{0148D32B-4A90-32FA-64A2-C4B15016D615}"/>
+              </a:ext>
+            </a:extLst>
+          </p:cNvPr>
+          <p:cNvGrpSpPr/>
+          <p:nvPr/>
+        </p:nvGrpSpPr>
+        <p:grpSpPr>
+          <a:xfrm>
+            <a:off x="3582685" y="3072809"/>
+            <a:ext cx="3013046" cy="712381"/>
+            <a:chOff x="3540155" y="3065214"/>
+            <a:chExt cx="3013046" cy="712381"/>
+          </a:xfrm>
+        </p:grpSpPr>
+        <p:sp>
+          <p:nvSpPr>
+            <p:cNvPr id="12" name="Rectangle 11">
+              <a:extLst>
+                <a:ext uri="{FF2B5EF4-FFF2-40B4-BE49-F238E27FC236}">
+                  <a16:creationId xmlns:a16="http://schemas.microsoft.com/office/drawing/2014/main" id="{5704C072-59A8-AEFE-45B6-284B7BBD56D5}"/>
+                </a:ext>
+              </a:extLst>
+            </p:cNvPr>
+            <p:cNvSpPr/>
+            <p:nvPr/>
+          </p:nvSpPr>
+          <p:spPr>
+            <a:xfrm>
+              <a:off x="3540155" y="3065214"/>
+              <a:ext cx="3013046" cy="712381"/>
+            </a:xfrm>
+            <a:prstGeom prst="rect">
+              <a:avLst/>
+            </a:prstGeom>
+            <a:solidFill>
+              <a:srgbClr val="00BFB3"/>
+            </a:solidFill>
+            <a:ln>
+              <a:noFill/>
+            </a:ln>
+          </p:spPr>
+          <p:style>
+            <a:lnRef idx="2">
+              <a:schemeClr val="accent1">
+                <a:shade val="15000"/>
+              </a:schemeClr>
+            </a:lnRef>
+            <a:fillRef idx="1">
+              <a:schemeClr val="accent1"/>
+            </a:fillRef>
+            <a:effectRef idx="0">
+              <a:schemeClr val="accent1"/>
+            </a:effectRef>
+            <a:fontRef idx="minor">
+              <a:schemeClr val="lt1"/>
+            </a:fontRef>
+          </p:style>
+          <p:txBody>
+            <a:bodyPr rtlCol="0" anchor="ctr"/>
+            <a:lstStyle/>
+            <a:p>
+              <a:pPr algn="ctr"/>
+              <a:endParaRPr lang="en-AT" dirty="0"/>
+            </a:p>
+          </p:txBody>
+        </p:sp>
+        <p:pic>
+          <p:nvPicPr>
+            <p:cNvPr id="13" name="Picture 12">
+              <a:extLst>
+                <a:ext uri="{FF2B5EF4-FFF2-40B4-BE49-F238E27FC236}">
+                  <a16:creationId xmlns:a16="http://schemas.microsoft.com/office/drawing/2014/main" id="{71152164-2EF5-EDD1-4262-7014902D7BD5}"/>
+                </a:ext>
+              </a:extLst>
+            </p:cNvPr>
+            <p:cNvPicPr>
+              <a:picLocks noChangeAspect="1"/>
+            </p:cNvPicPr>
+            <p:nvPr/>
+          </p:nvPicPr>
+          <p:blipFill>
+            <a:blip r:embed="rId4"/>
+            <a:stretch>
+              <a:fillRect/>
+            </a:stretch>
+          </p:blipFill>
+          <p:spPr>
+            <a:xfrm>
+              <a:off x="3616355" y="3160180"/>
+              <a:ext cx="2860645" cy="513805"/>
+            </a:xfrm>
+            <a:prstGeom prst="rect">
+              <a:avLst/>
+            </a:prstGeom>
+          </p:spPr>
+        </p:pic>
+      </p:grpSp>
+      <p:grpSp>
+        <p:nvGrpSpPr>
+          <p:cNvPr id="25" name="Group 24">
+            <a:extLst>
+              <a:ext uri="{FF2B5EF4-FFF2-40B4-BE49-F238E27FC236}">
+                <a16:creationId xmlns:a16="http://schemas.microsoft.com/office/drawing/2014/main" id="{A92F3C1E-8B2D-79AD-95FA-84F25EBD56AD}"/>
+              </a:ext>
+            </a:extLst>
+          </p:cNvPr>
+          <p:cNvGrpSpPr/>
+          <p:nvPr/>
+        </p:nvGrpSpPr>
+        <p:grpSpPr>
+          <a:xfrm>
+            <a:off x="7034164" y="2771844"/>
+            <a:ext cx="2645879" cy="1522638"/>
+            <a:chOff x="6964959" y="3994588"/>
+            <a:chExt cx="2645879" cy="1522638"/>
+          </a:xfrm>
+        </p:grpSpPr>
+        <p:sp>
+          <p:nvSpPr>
+            <p:cNvPr id="23" name="Rectangle 22">
+              <a:extLst>
+                <a:ext uri="{FF2B5EF4-FFF2-40B4-BE49-F238E27FC236}">
+                  <a16:creationId xmlns:a16="http://schemas.microsoft.com/office/drawing/2014/main" id="{AD736C13-2413-9561-0668-08F3D0D24DEE}"/>
+                </a:ext>
+              </a:extLst>
+            </p:cNvPr>
+            <p:cNvSpPr/>
+            <p:nvPr/>
+          </p:nvSpPr>
+          <p:spPr>
+            <a:xfrm>
+              <a:off x="6964959" y="3994588"/>
+              <a:ext cx="2645879" cy="1522638"/>
+            </a:xfrm>
+            <a:prstGeom prst="rect">
+              <a:avLst/>
+            </a:prstGeom>
+            <a:solidFill>
+              <a:srgbClr val="00BFB3"/>
+            </a:solidFill>
+            <a:ln>
+              <a:noFill/>
+            </a:ln>
+          </p:spPr>
+          <p:style>
+            <a:lnRef idx="2">
+              <a:schemeClr val="accent1">
+                <a:shade val="15000"/>
+              </a:schemeClr>
+            </a:lnRef>
+            <a:fillRef idx="1">
+              <a:schemeClr val="accent1"/>
+            </a:fillRef>
+            <a:effectRef idx="0">
+              <a:schemeClr val="accent1"/>
+            </a:effectRef>
+            <a:fontRef idx="minor">
+              <a:schemeClr val="lt1"/>
+            </a:fontRef>
+          </p:style>
+          <p:txBody>
+            <a:bodyPr rtlCol="0" anchor="ctr"/>
+            <a:lstStyle/>
+            <a:p>
+              <a:pPr algn="ctr"/>
+              <a:endParaRPr lang="en-AT" dirty="0"/>
+            </a:p>
+          </p:txBody>
+        </p:sp>
+        <p:pic>
+          <p:nvPicPr>
+            <p:cNvPr id="24" name="Picture 23">
+              <a:extLst>
+                <a:ext uri="{FF2B5EF4-FFF2-40B4-BE49-F238E27FC236}">
+                  <a16:creationId xmlns:a16="http://schemas.microsoft.com/office/drawing/2014/main" id="{A0677A90-797C-7C1F-2BF1-82B5EEFFA5AA}"/>
+                </a:ext>
+              </a:extLst>
+            </p:cNvPr>
+            <p:cNvPicPr>
+              <a:picLocks noChangeAspect="1"/>
+            </p:cNvPicPr>
+            <p:nvPr/>
+          </p:nvPicPr>
+          <p:blipFill>
+            <a:blip r:embed="rId5"/>
+            <a:stretch>
+              <a:fillRect/>
+            </a:stretch>
+          </p:blipFill>
+          <p:spPr>
+            <a:xfrm>
+              <a:off x="7011321" y="4099888"/>
+              <a:ext cx="2553153" cy="1312037"/>
+            </a:xfrm>
+            <a:prstGeom prst="rect">
+              <a:avLst/>
+            </a:prstGeom>
+          </p:spPr>
+        </p:pic>
+      </p:grpSp>
     </p:spTree>
     <p:extLst>
       <p:ext uri="{BB962C8B-B14F-4D97-AF65-F5344CB8AC3E}">
@@ -12638,6 +14959,453 @@
   <p:clrMapOvr>
     <a:masterClrMapping/>
   </p:clrMapOvr>
+  <p:timing>
+    <p:tnLst>
+      <p:par>
+        <p:cTn id="1" dur="indefinite" restart="never" nodeType="tmRoot">
+          <p:childTnLst>
+            <p:seq concurrent="1" nextAc="seek">
+              <p:cTn id="2" dur="indefinite" nodeType="mainSeq">
+                <p:childTnLst>
+                  <p:par>
+                    <p:cTn id="3" fill="hold">
+                      <p:stCondLst>
+                        <p:cond delay="indefinite"/>
+                      </p:stCondLst>
+                      <p:childTnLst>
+                        <p:par>
+                          <p:cTn id="4" fill="hold">
+                            <p:stCondLst>
+                              <p:cond delay="0"/>
+                            </p:stCondLst>
+                            <p:childTnLst>
+                              <p:par>
+                                <p:cTn id="5" presetID="10" presetClass="entr" presetSubtype="0" fill="hold" nodeType="clickEffect">
+                                  <p:stCondLst>
+                                    <p:cond delay="0"/>
+                                  </p:stCondLst>
+                                  <p:childTnLst>
+                                    <p:set>
+                                      <p:cBhvr>
+                                        <p:cTn id="6" dur="1" fill="hold">
+                                          <p:stCondLst>
+                                            <p:cond delay="0"/>
+                                          </p:stCondLst>
+                                        </p:cTn>
+                                        <p:tgtEl>
+                                          <p:spTgt spid="3">
+                                            <p:txEl>
+                                              <p:pRg st="0" end="0"/>
+                                            </p:txEl>
+                                          </p:spTgt>
+                                        </p:tgtEl>
+                                        <p:attrNameLst>
+                                          <p:attrName>style.visibility</p:attrName>
+                                        </p:attrNameLst>
+                                      </p:cBhvr>
+                                      <p:to>
+                                        <p:strVal val="visible"/>
+                                      </p:to>
+                                    </p:set>
+                                    <p:animEffect transition="in" filter="fade">
+                                      <p:cBhvr>
+                                        <p:cTn id="7" dur="500"/>
+                                        <p:tgtEl>
+                                          <p:spTgt spid="3">
+                                            <p:txEl>
+                                              <p:pRg st="0" end="0"/>
+                                            </p:txEl>
+                                          </p:spTgt>
+                                        </p:tgtEl>
+                                      </p:cBhvr>
+                                    </p:animEffect>
+                                  </p:childTnLst>
+                                </p:cTn>
+                              </p:par>
+                            </p:childTnLst>
+                          </p:cTn>
+                        </p:par>
+                      </p:childTnLst>
+                    </p:cTn>
+                  </p:par>
+                  <p:par>
+                    <p:cTn id="8" fill="hold">
+                      <p:stCondLst>
+                        <p:cond delay="indefinite"/>
+                      </p:stCondLst>
+                      <p:childTnLst>
+                        <p:par>
+                          <p:cTn id="9" fill="hold">
+                            <p:stCondLst>
+                              <p:cond delay="0"/>
+                            </p:stCondLst>
+                            <p:childTnLst>
+                              <p:par>
+                                <p:cTn id="10" presetID="12" presetClass="entr" presetSubtype="4" fill="hold" nodeType="clickEffect">
+                                  <p:stCondLst>
+                                    <p:cond delay="0"/>
+                                  </p:stCondLst>
+                                  <p:childTnLst>
+                                    <p:set>
+                                      <p:cBhvr>
+                                        <p:cTn id="11" dur="1" fill="hold">
+                                          <p:stCondLst>
+                                            <p:cond delay="0"/>
+                                          </p:stCondLst>
+                                        </p:cTn>
+                                        <p:tgtEl>
+                                          <p:spTgt spid="3">
+                                            <p:txEl>
+                                              <p:pRg st="1" end="1"/>
+                                            </p:txEl>
+                                          </p:spTgt>
+                                        </p:tgtEl>
+                                        <p:attrNameLst>
+                                          <p:attrName>style.visibility</p:attrName>
+                                        </p:attrNameLst>
+                                      </p:cBhvr>
+                                      <p:to>
+                                        <p:strVal val="visible"/>
+                                      </p:to>
+                                    </p:set>
+                                    <p:anim calcmode="lin" valueType="num">
+                                      <p:cBhvr additive="base">
+                                        <p:cTn id="12" dur="500"/>
+                                        <p:tgtEl>
+                                          <p:spTgt spid="3">
+                                            <p:txEl>
+                                              <p:pRg st="1" end="1"/>
+                                            </p:txEl>
+                                          </p:spTgt>
+                                        </p:tgtEl>
+                                        <p:attrNameLst>
+                                          <p:attrName>ppt_y</p:attrName>
+                                        </p:attrNameLst>
+                                      </p:cBhvr>
+                                      <p:tavLst>
+                                        <p:tav tm="0">
+                                          <p:val>
+                                            <p:strVal val="#ppt_y+#ppt_h*1.125000"/>
+                                          </p:val>
+                                        </p:tav>
+                                        <p:tav tm="100000">
+                                          <p:val>
+                                            <p:strVal val="#ppt_y"/>
+                                          </p:val>
+                                        </p:tav>
+                                      </p:tavLst>
+                                    </p:anim>
+                                    <p:animEffect transition="in" filter="wipe(up)">
+                                      <p:cBhvr>
+                                        <p:cTn id="13" dur="500"/>
+                                        <p:tgtEl>
+                                          <p:spTgt spid="3">
+                                            <p:txEl>
+                                              <p:pRg st="1" end="1"/>
+                                            </p:txEl>
+                                          </p:spTgt>
+                                        </p:tgtEl>
+                                      </p:cBhvr>
+                                    </p:animEffect>
+                                  </p:childTnLst>
+                                </p:cTn>
+                              </p:par>
+                              <p:par>
+                                <p:cTn id="14" presetID="12" presetClass="entr" presetSubtype="4" fill="hold" nodeType="withEffect">
+                                  <p:stCondLst>
+                                    <p:cond delay="0"/>
+                                  </p:stCondLst>
+                                  <p:childTnLst>
+                                    <p:set>
+                                      <p:cBhvr>
+                                        <p:cTn id="15" dur="1" fill="hold">
+                                          <p:stCondLst>
+                                            <p:cond delay="0"/>
+                                          </p:stCondLst>
+                                        </p:cTn>
+                                        <p:tgtEl>
+                                          <p:spTgt spid="11"/>
+                                        </p:tgtEl>
+                                        <p:attrNameLst>
+                                          <p:attrName>style.visibility</p:attrName>
+                                        </p:attrNameLst>
+                                      </p:cBhvr>
+                                      <p:to>
+                                        <p:strVal val="visible"/>
+                                      </p:to>
+                                    </p:set>
+                                    <p:anim calcmode="lin" valueType="num">
+                                      <p:cBhvr additive="base">
+                                        <p:cTn id="16" dur="500"/>
+                                        <p:tgtEl>
+                                          <p:spTgt spid="11"/>
+                                        </p:tgtEl>
+                                        <p:attrNameLst>
+                                          <p:attrName>ppt_y</p:attrName>
+                                        </p:attrNameLst>
+                                      </p:cBhvr>
+                                      <p:tavLst>
+                                        <p:tav tm="0">
+                                          <p:val>
+                                            <p:strVal val="#ppt_y+#ppt_h*1.125000"/>
+                                          </p:val>
+                                        </p:tav>
+                                        <p:tav tm="100000">
+                                          <p:val>
+                                            <p:strVal val="#ppt_y"/>
+                                          </p:val>
+                                        </p:tav>
+                                      </p:tavLst>
+                                    </p:anim>
+                                    <p:animEffect transition="in" filter="wipe(up)">
+                                      <p:cBhvr>
+                                        <p:cTn id="17" dur="500"/>
+                                        <p:tgtEl>
+                                          <p:spTgt spid="11"/>
+                                        </p:tgtEl>
+                                      </p:cBhvr>
+                                    </p:animEffect>
+                                  </p:childTnLst>
+                                </p:cTn>
+                              </p:par>
+                              <p:par>
+                                <p:cTn id="18" presetID="12" presetClass="entr" presetSubtype="4" fill="hold" nodeType="withEffect">
+                                  <p:stCondLst>
+                                    <p:cond delay="0"/>
+                                  </p:stCondLst>
+                                  <p:childTnLst>
+                                    <p:set>
+                                      <p:cBhvr>
+                                        <p:cTn id="19" dur="1" fill="hold">
+                                          <p:stCondLst>
+                                            <p:cond delay="0"/>
+                                          </p:stCondLst>
+                                        </p:cTn>
+                                        <p:tgtEl>
+                                          <p:spTgt spid="14"/>
+                                        </p:tgtEl>
+                                        <p:attrNameLst>
+                                          <p:attrName>style.visibility</p:attrName>
+                                        </p:attrNameLst>
+                                      </p:cBhvr>
+                                      <p:to>
+                                        <p:strVal val="visible"/>
+                                      </p:to>
+                                    </p:set>
+                                    <p:anim calcmode="lin" valueType="num">
+                                      <p:cBhvr additive="base">
+                                        <p:cTn id="20" dur="500"/>
+                                        <p:tgtEl>
+                                          <p:spTgt spid="14"/>
+                                        </p:tgtEl>
+                                        <p:attrNameLst>
+                                          <p:attrName>ppt_y</p:attrName>
+                                        </p:attrNameLst>
+                                      </p:cBhvr>
+                                      <p:tavLst>
+                                        <p:tav tm="0">
+                                          <p:val>
+                                            <p:strVal val="#ppt_y+#ppt_h*1.125000"/>
+                                          </p:val>
+                                        </p:tav>
+                                        <p:tav tm="100000">
+                                          <p:val>
+                                            <p:strVal val="#ppt_y"/>
+                                          </p:val>
+                                        </p:tav>
+                                      </p:tavLst>
+                                    </p:anim>
+                                    <p:animEffect transition="in" filter="wipe(up)">
+                                      <p:cBhvr>
+                                        <p:cTn id="21" dur="500"/>
+                                        <p:tgtEl>
+                                          <p:spTgt spid="14"/>
+                                        </p:tgtEl>
+                                      </p:cBhvr>
+                                    </p:animEffect>
+                                  </p:childTnLst>
+                                </p:cTn>
+                              </p:par>
+                              <p:par>
+                                <p:cTn id="22" presetID="12" presetClass="entr" presetSubtype="4" fill="hold" nodeType="withEffect">
+                                  <p:stCondLst>
+                                    <p:cond delay="0"/>
+                                  </p:stCondLst>
+                                  <p:childTnLst>
+                                    <p:set>
+                                      <p:cBhvr>
+                                        <p:cTn id="23" dur="1" fill="hold">
+                                          <p:stCondLst>
+                                            <p:cond delay="0"/>
+                                          </p:stCondLst>
+                                        </p:cTn>
+                                        <p:tgtEl>
+                                          <p:spTgt spid="25"/>
+                                        </p:tgtEl>
+                                        <p:attrNameLst>
+                                          <p:attrName>style.visibility</p:attrName>
+                                        </p:attrNameLst>
+                                      </p:cBhvr>
+                                      <p:to>
+                                        <p:strVal val="visible"/>
+                                      </p:to>
+                                    </p:set>
+                                    <p:anim calcmode="lin" valueType="num">
+                                      <p:cBhvr additive="base">
+                                        <p:cTn id="24" dur="500"/>
+                                        <p:tgtEl>
+                                          <p:spTgt spid="25"/>
+                                        </p:tgtEl>
+                                        <p:attrNameLst>
+                                          <p:attrName>ppt_y</p:attrName>
+                                        </p:attrNameLst>
+                                      </p:cBhvr>
+                                      <p:tavLst>
+                                        <p:tav tm="0">
+                                          <p:val>
+                                            <p:strVal val="#ppt_y+#ppt_h*1.125000"/>
+                                          </p:val>
+                                        </p:tav>
+                                        <p:tav tm="100000">
+                                          <p:val>
+                                            <p:strVal val="#ppt_y"/>
+                                          </p:val>
+                                        </p:tav>
+                                      </p:tavLst>
+                                    </p:anim>
+                                    <p:animEffect transition="in" filter="wipe(up)">
+                                      <p:cBhvr>
+                                        <p:cTn id="25" dur="500"/>
+                                        <p:tgtEl>
+                                          <p:spTgt spid="25"/>
+                                        </p:tgtEl>
+                                      </p:cBhvr>
+                                    </p:animEffect>
+                                  </p:childTnLst>
+                                </p:cTn>
+                              </p:par>
+                            </p:childTnLst>
+                          </p:cTn>
+                        </p:par>
+                        <p:par>
+                          <p:cTn id="26" fill="hold">
+                            <p:stCondLst>
+                              <p:cond delay="500"/>
+                            </p:stCondLst>
+                            <p:childTnLst>
+                              <p:par>
+                                <p:cTn id="27" presetID="2" presetClass="entr" presetSubtype="4" fill="hold" nodeType="afterEffect">
+                                  <p:stCondLst>
+                                    <p:cond delay="0"/>
+                                  </p:stCondLst>
+                                  <p:childTnLst>
+                                    <p:set>
+                                      <p:cBhvr>
+                                        <p:cTn id="28" dur="1" fill="hold">
+                                          <p:stCondLst>
+                                            <p:cond delay="0"/>
+                                          </p:stCondLst>
+                                        </p:cTn>
+                                        <p:tgtEl>
+                                          <p:spTgt spid="3">
+                                            <p:txEl>
+                                              <p:pRg st="7" end="7"/>
+                                            </p:txEl>
+                                          </p:spTgt>
+                                        </p:tgtEl>
+                                        <p:attrNameLst>
+                                          <p:attrName>style.visibility</p:attrName>
+                                        </p:attrNameLst>
+                                      </p:cBhvr>
+                                      <p:to>
+                                        <p:strVal val="visible"/>
+                                      </p:to>
+                                    </p:set>
+                                    <p:anim calcmode="lin" valueType="num">
+                                      <p:cBhvr additive="base">
+                                        <p:cTn id="29" dur="500" fill="hold"/>
+                                        <p:tgtEl>
+                                          <p:spTgt spid="3">
+                                            <p:txEl>
+                                              <p:pRg st="7" end="7"/>
+                                            </p:txEl>
+                                          </p:spTgt>
+                                        </p:tgtEl>
+                                        <p:attrNameLst>
+                                          <p:attrName>ppt_x</p:attrName>
+                                        </p:attrNameLst>
+                                      </p:cBhvr>
+                                      <p:tavLst>
+                                        <p:tav tm="0">
+                                          <p:val>
+                                            <p:strVal val="#ppt_x"/>
+                                          </p:val>
+                                        </p:tav>
+                                        <p:tav tm="100000">
+                                          <p:val>
+                                            <p:strVal val="#ppt_x"/>
+                                          </p:val>
+                                        </p:tav>
+                                      </p:tavLst>
+                                    </p:anim>
+                                    <p:anim calcmode="lin" valueType="num">
+                                      <p:cBhvr additive="base">
+                                        <p:cTn id="30" dur="500" fill="hold"/>
+                                        <p:tgtEl>
+                                          <p:spTgt spid="3">
+                                            <p:txEl>
+                                              <p:pRg st="7" end="7"/>
+                                            </p:txEl>
+                                          </p:spTgt>
+                                        </p:tgtEl>
+                                        <p:attrNameLst>
+                                          <p:attrName>ppt_y</p:attrName>
+                                        </p:attrNameLst>
+                                      </p:cBhvr>
+                                      <p:tavLst>
+                                        <p:tav tm="0">
+                                          <p:val>
+                                            <p:strVal val="1+#ppt_h/2"/>
+                                          </p:val>
+                                        </p:tav>
+                                        <p:tav tm="100000">
+                                          <p:val>
+                                            <p:strVal val="#ppt_y"/>
+                                          </p:val>
+                                        </p:tav>
+                                      </p:tavLst>
+                                    </p:anim>
+                                  </p:childTnLst>
+                                </p:cTn>
+                              </p:par>
+                            </p:childTnLst>
+                          </p:cTn>
+                        </p:par>
+                      </p:childTnLst>
+                    </p:cTn>
+                  </p:par>
+                </p:childTnLst>
+              </p:cTn>
+              <p:prevCondLst>
+                <p:cond evt="onPrev" delay="0">
+                  <p:tgtEl>
+                    <p:sldTgt/>
+                  </p:tgtEl>
+                </p:cond>
+              </p:prevCondLst>
+              <p:nextCondLst>
+                <p:cond evt="onNext" delay="0">
+                  <p:tgtEl>
+                    <p:sldTgt/>
+                  </p:tgtEl>
+                </p:cond>
+              </p:nextCondLst>
+            </p:seq>
+          </p:childTnLst>
+        </p:cTn>
+      </p:par>
+    </p:tnLst>
+  </p:timing>
 </p:sld>
 </file>
 
@@ -12649,7 +15417,7 @@
         <p:cNvPr id="1" name="">
           <a:extLst>
             <a:ext uri="{FF2B5EF4-FFF2-40B4-BE49-F238E27FC236}">
-              <a16:creationId xmlns:a16="http://schemas.microsoft.com/office/drawing/2014/main" id="{E975DA51-6F69-6DCC-3408-D8DE54DFF945}"/>
+              <a16:creationId xmlns:a16="http://schemas.microsoft.com/office/drawing/2014/main" id="{D8BE6DE9-5604-5267-065F-C7B04FA3256E}"/>
             </a:ext>
           </a:extLst>
         </p:cNvPr>
@@ -12669,7 +15437,7 @@
           <p:cNvPr id="2" name="Title 1">
             <a:extLst>
               <a:ext uri="{FF2B5EF4-FFF2-40B4-BE49-F238E27FC236}">
-                <a16:creationId xmlns:a16="http://schemas.microsoft.com/office/drawing/2014/main" id="{E6CD2EA0-789F-CFA0-2CD6-178F567FFBDA}"/>
+                <a16:creationId xmlns:a16="http://schemas.microsoft.com/office/drawing/2014/main" id="{4C06466A-74F4-09F4-F537-346D6C7CE7A9}"/>
               </a:ext>
             </a:extLst>
           </p:cNvPr>
@@ -12687,7 +15455,7 @@
           <a:p>
             <a:r>
               <a:rPr lang="en-AT" dirty="0"/>
-              <a:t>Usecases</a:t>
+              <a:t>How does it work</a:t>
             </a:r>
           </a:p>
         </p:txBody>
@@ -12697,7 +15465,7 @@
           <p:cNvPr id="3" name="Content Placeholder 2">
             <a:extLst>
               <a:ext uri="{FF2B5EF4-FFF2-40B4-BE49-F238E27FC236}">
-                <a16:creationId xmlns:a16="http://schemas.microsoft.com/office/drawing/2014/main" id="{FC178D33-E7F1-F23A-7FC9-24A90C432238}"/>
+                <a16:creationId xmlns:a16="http://schemas.microsoft.com/office/drawing/2014/main" id="{28EC7F02-D29B-9C3C-5C30-A23A3798E072}"/>
               </a:ext>
             </a:extLst>
           </p:cNvPr>
@@ -12713,20 +15481,61 @@
           <a:bodyPr/>
           <a:lstStyle/>
           <a:p>
-            <a:pPr marL="0" indent="0">
-              <a:buNone/>
-            </a:pPr>
-            <a:endParaRPr lang="en-AT" dirty="0"/>
-          </a:p>
-          <a:p>
-            <a:endParaRPr lang="en-AT" dirty="0"/>
+            <a:r>
+              <a:rPr lang="en-AT" b="1" dirty="0"/>
+              <a:t>Queying</a:t>
+            </a:r>
+          </a:p>
+          <a:p>
+            <a:pPr lvl="1"/>
+            <a:r>
+              <a:rPr lang="en-AT" dirty="0"/>
+              <a:t>Client send JSON-based Query DSL request via REST API</a:t>
+            </a:r>
+          </a:p>
+          <a:p>
+            <a:pPr lvl="1"/>
+            <a:r>
+              <a:rPr lang="en-AT" dirty="0"/>
+              <a:t>Full-text match, fuzzy, bool, range, geo and aggregation queries</a:t>
+            </a:r>
           </a:p>
         </p:txBody>
       </p:sp>
+      <p:pic>
+        <p:nvPicPr>
+          <p:cNvPr id="4" name="Picture 3">
+            <a:extLst>
+              <a:ext uri="{FF2B5EF4-FFF2-40B4-BE49-F238E27FC236}">
+                <a16:creationId xmlns:a16="http://schemas.microsoft.com/office/drawing/2014/main" id="{21925FC9-D62F-CCF3-3ACF-0341D0A831BF}"/>
+              </a:ext>
+            </a:extLst>
+          </p:cNvPr>
+          <p:cNvPicPr>
+            <a:picLocks noChangeAspect="1"/>
+          </p:cNvPicPr>
+          <p:nvPr/>
+        </p:nvPicPr>
+        <p:blipFill>
+          <a:blip r:embed="rId3"/>
+          <a:stretch>
+            <a:fillRect/>
+          </a:stretch>
+        </p:blipFill>
+        <p:spPr>
+          <a:xfrm>
+            <a:off x="838200" y="3256128"/>
+            <a:ext cx="7311936" cy="2613043"/>
+          </a:xfrm>
+          <a:prstGeom prst="rect">
+            <a:avLst/>
+          </a:prstGeom>
+        </p:spPr>
+      </p:pic>
     </p:spTree>
     <p:extLst>
       <p:ext uri="{BB962C8B-B14F-4D97-AF65-F5344CB8AC3E}">
-        <p14:creationId xmlns:p14="http://schemas.microsoft.com/office/powerpoint/2010/main" val="1120557849"/>
+        <p14:creationId xmlns:p14="http://schemas.microsoft.com/office/powerpoint/2010/main" val="620670315"/>
       </p:ext>
     </p:extLst>
   </p:cSld>

</xml_diff>

<commit_message>
Added content to presentation about project
</commit_message>
<xml_diff>
--- a/Elasticsearch.pptx
+++ b/Elasticsearch.pptx
@@ -5,7 +5,7 @@
     <p:sldMasterId id="2147484165" r:id="rId1"/>
   </p:sldMasterIdLst>
   <p:notesMasterIdLst>
-    <p:notesMasterId r:id="rId18"/>
+    <p:notesMasterId r:id="rId19"/>
   </p:notesMasterIdLst>
   <p:sldIdLst>
     <p:sldId id="256" r:id="rId2"/>
@@ -23,7 +23,8 @@
     <p:sldId id="262" r:id="rId14"/>
     <p:sldId id="272" r:id="rId15"/>
     <p:sldId id="266" r:id="rId16"/>
-    <p:sldId id="267" r:id="rId17"/>
+    <p:sldId id="274" r:id="rId17"/>
+    <p:sldId id="267" r:id="rId18"/>
   </p:sldIdLst>
   <p:sldSz cx="12192000" cy="6858000"/>
   <p:notesSz cx="6858000" cy="9144000"/>
@@ -212,7 +213,7 @@
           <a:p>
             <a:fld id="{17C1BCD2-C187-B342-9D66-FD6DDE94747E}" type="datetimeFigureOut">
               <a:rPr lang="en-AT" smtClean="0"/>
-              <a:t>04.05.26</a:t>
+              <a:t>05.05.26</a:t>
             </a:fld>
             <a:endParaRPr lang="en-AT"/>
           </a:p>
@@ -1056,62 +1057,6 @@
           <a:bodyPr/>
           <a:lstStyle/>
           <a:p>
-            <a:pPr marL="0" marR="0" lvl="0" indent="0" algn="l" defTabSz="914400" rtl="0" eaLnBrk="1" fontAlgn="auto" latinLnBrk="0" hangingPunct="1">
-              <a:lnSpc>
-                <a:spcPct val="100000"/>
-              </a:lnSpc>
-              <a:spcBef>
-                <a:spcPts val="0"/>
-              </a:spcBef>
-              <a:spcAft>
-                <a:spcPts val="0"/>
-              </a:spcAft>
-              <a:buClrTx/>
-              <a:buSzTx/>
-              <a:buFontTx/>
-              <a:buNone/>
-              <a:tabLst/>
-              <a:defRPr/>
-            </a:pPr>
-            <a:r>
-              <a:rPr lang="en-GB" sz="1200" b="0" i="0" kern="1200" dirty="0">
-                <a:solidFill>
-                  <a:schemeClr val="tx1"/>
-                </a:solidFill>
-                <a:effectLst/>
-                <a:latin typeface="+mn-lt"/>
-                <a:ea typeface="+mn-ea"/>
-                <a:cs typeface="+mn-cs"/>
-              </a:rPr>
-              <a:t>Elasticsearch stores data in </a:t>
-            </a:r>
-            <a:r>
-              <a:rPr lang="en-GB" sz="1200" b="0" i="0" u="sng" kern="1200" dirty="0">
-                <a:solidFill>
-                  <a:schemeClr val="tx1"/>
-                </a:solidFill>
-                <a:effectLst/>
-                <a:latin typeface="+mn-lt"/>
-                <a:ea typeface="+mn-ea"/>
-                <a:cs typeface="+mn-cs"/>
-                <a:hlinkClick r:id="rId3"/>
-              </a:rPr>
-              <a:t>JSON </a:t>
-            </a:r>
-            <a:r>
-              <a:rPr lang="en-GB" sz="1200" b="0" i="0" kern="1200" dirty="0">
-                <a:solidFill>
-                  <a:schemeClr val="tx1"/>
-                </a:solidFill>
-                <a:effectLst/>
-                <a:latin typeface="+mn-lt"/>
-                <a:ea typeface="+mn-ea"/>
-                <a:cs typeface="+mn-cs"/>
-              </a:rPr>
-              <a:t>format and making it easy to index and search structured and unstructured data.</a:t>
-            </a:r>
-          </a:p>
-          <a:p>
             <a:endParaRPr lang="en-AT" dirty="0"/>
           </a:p>
         </p:txBody>
@@ -1159,6 +1104,177 @@
 </file>
 
 <file path=ppt/notesSlides/notesSlide13.xml><?xml version="1.0" encoding="utf-8"?>
+<p:notes xmlns:a="http://schemas.openxmlformats.org/drawingml/2006/main" xmlns:r="http://schemas.openxmlformats.org/officeDocument/2006/relationships" xmlns:p="http://schemas.openxmlformats.org/presentationml/2006/main">
+  <p:cSld>
+    <p:spTree>
+      <p:nvGrpSpPr>
+        <p:cNvPr id="1" name="">
+          <a:extLst>
+            <a:ext uri="{FF2B5EF4-FFF2-40B4-BE49-F238E27FC236}">
+              <a16:creationId xmlns:a16="http://schemas.microsoft.com/office/drawing/2014/main" id="{7EB48679-807B-DDC8-E169-0F5A6A88C73A}"/>
+            </a:ext>
+          </a:extLst>
+        </p:cNvPr>
+        <p:cNvGrpSpPr/>
+        <p:nvPr/>
+      </p:nvGrpSpPr>
+      <p:grpSpPr>
+        <a:xfrm>
+          <a:off x="0" y="0"/>
+          <a:ext cx="0" cy="0"/>
+          <a:chOff x="0" y="0"/>
+          <a:chExt cx="0" cy="0"/>
+        </a:xfrm>
+      </p:grpSpPr>
+      <p:sp>
+        <p:nvSpPr>
+          <p:cNvPr id="2" name="Slide Image Placeholder 1">
+            <a:extLst>
+              <a:ext uri="{FF2B5EF4-FFF2-40B4-BE49-F238E27FC236}">
+                <a16:creationId xmlns:a16="http://schemas.microsoft.com/office/drawing/2014/main" id="{FA20F401-BD97-E286-6D94-34C03E4D99DF}"/>
+              </a:ext>
+            </a:extLst>
+          </p:cNvPr>
+          <p:cNvSpPr>
+            <a:spLocks noGrp="1" noRot="1" noChangeAspect="1"/>
+          </p:cNvSpPr>
+          <p:nvPr>
+            <p:ph type="sldImg"/>
+          </p:nvPr>
+        </p:nvSpPr>
+        <p:spPr/>
+      </p:sp>
+      <p:sp>
+        <p:nvSpPr>
+          <p:cNvPr id="3" name="Notes Placeholder 2">
+            <a:extLst>
+              <a:ext uri="{FF2B5EF4-FFF2-40B4-BE49-F238E27FC236}">
+                <a16:creationId xmlns:a16="http://schemas.microsoft.com/office/drawing/2014/main" id="{6668C042-51F5-18E0-6546-502A503B4870}"/>
+              </a:ext>
+            </a:extLst>
+          </p:cNvPr>
+          <p:cNvSpPr>
+            <a:spLocks noGrp="1"/>
+          </p:cNvSpPr>
+          <p:nvPr>
+            <p:ph type="body" idx="1"/>
+          </p:nvPr>
+        </p:nvSpPr>
+        <p:spPr/>
+        <p:txBody>
+          <a:bodyPr/>
+          <a:lstStyle/>
+          <a:p>
+            <a:r>
+              <a:rPr lang="en-AT" dirty="0"/>
+              <a:t>Load CSV : </a:t>
+            </a:r>
+            <a:r>
+              <a:rPr lang="en-GB" sz="1200" b="0" i="0" u="none" strike="noStrike" kern="1200" dirty="0">
+                <a:solidFill>
+                  <a:schemeClr val="tx1"/>
+                </a:solidFill>
+                <a:effectLst/>
+                <a:latin typeface="+mn-lt"/>
+                <a:ea typeface="+mn-ea"/>
+                <a:cs typeface="+mn-cs"/>
+              </a:rPr>
+              <a:t>Read 6 CSV files into pandas </a:t>
+            </a:r>
+            <a:r>
+              <a:rPr lang="en-GB" sz="1200" b="0" i="0" u="none" strike="noStrike" kern="1200" dirty="0" err="1">
+                <a:solidFill>
+                  <a:schemeClr val="tx1"/>
+                </a:solidFill>
+                <a:effectLst/>
+                <a:latin typeface="+mn-lt"/>
+                <a:ea typeface="+mn-ea"/>
+                <a:cs typeface="+mn-cs"/>
+              </a:rPr>
+              <a:t>dataframes</a:t>
+            </a:r>
+            <a:endParaRPr lang="en-GB" sz="1200" b="0" i="0" u="none" strike="noStrike" kern="1200" dirty="0">
+              <a:solidFill>
+                <a:schemeClr val="tx1"/>
+              </a:solidFill>
+              <a:effectLst/>
+              <a:latin typeface="+mn-lt"/>
+              <a:ea typeface="+mn-ea"/>
+              <a:cs typeface="+mn-cs"/>
+            </a:endParaRPr>
+          </a:p>
+          <a:p>
+            <a:r>
+              <a:rPr lang="en-GB" sz="1200" b="0" i="0" u="none" strike="noStrike" kern="1200" dirty="0">
+                <a:solidFill>
+                  <a:schemeClr val="tx1"/>
+                </a:solidFill>
+                <a:effectLst/>
+                <a:latin typeface="+mn-lt"/>
+                <a:ea typeface="+mn-ea"/>
+                <a:cs typeface="+mn-cs"/>
+              </a:rPr>
+              <a:t>The mapping defines the data types of every field before any data is inserted – comparable to CREATE TABLE in </a:t>
+            </a:r>
+            <a:r>
+              <a:rPr lang="en-GB" sz="1200" b="0" i="0" u="none" strike="noStrike" kern="1200" dirty="0" err="1">
+                <a:solidFill>
+                  <a:schemeClr val="tx1"/>
+                </a:solidFill>
+                <a:effectLst/>
+                <a:latin typeface="+mn-lt"/>
+                <a:ea typeface="+mn-ea"/>
+                <a:cs typeface="+mn-cs"/>
+              </a:rPr>
+              <a:t>sql</a:t>
+            </a:r>
+            <a:endParaRPr lang="en-AT" dirty="0"/>
+          </a:p>
+        </p:txBody>
+      </p:sp>
+      <p:sp>
+        <p:nvSpPr>
+          <p:cNvPr id="4" name="Slide Number Placeholder 3">
+            <a:extLst>
+              <a:ext uri="{FF2B5EF4-FFF2-40B4-BE49-F238E27FC236}">
+                <a16:creationId xmlns:a16="http://schemas.microsoft.com/office/drawing/2014/main" id="{2D48325A-178C-AD3A-4C8D-2F7E4BFE765F}"/>
+              </a:ext>
+            </a:extLst>
+          </p:cNvPr>
+          <p:cNvSpPr>
+            <a:spLocks noGrp="1"/>
+          </p:cNvSpPr>
+          <p:nvPr>
+            <p:ph type="sldNum" sz="quarter" idx="5"/>
+          </p:nvPr>
+        </p:nvSpPr>
+        <p:spPr/>
+        <p:txBody>
+          <a:bodyPr/>
+          <a:lstStyle/>
+          <a:p>
+            <a:fld id="{C9565C50-69E9-8E49-A3AB-C69605F3BCD6}" type="slidenum">
+              <a:rPr lang="en-AT" smtClean="0"/>
+              <a:t>16</a:t>
+            </a:fld>
+            <a:endParaRPr lang="en-AT"/>
+          </a:p>
+        </p:txBody>
+      </p:sp>
+    </p:spTree>
+    <p:extLst>
+      <p:ext uri="{BB962C8B-B14F-4D97-AF65-F5344CB8AC3E}">
+        <p14:creationId xmlns:p14="http://schemas.microsoft.com/office/powerpoint/2010/main" val="808853191"/>
+      </p:ext>
+    </p:extLst>
+  </p:cSld>
+  <p:clrMapOvr>
+    <a:masterClrMapping/>
+  </p:clrMapOvr>
+</p:notes>
+</file>
+
+<file path=ppt/notesSlides/notesSlide14.xml><?xml version="1.0" encoding="utf-8"?>
 <p:notes xmlns:a="http://schemas.openxmlformats.org/drawingml/2006/main" xmlns:r="http://schemas.openxmlformats.org/officeDocument/2006/relationships" xmlns:p="http://schemas.openxmlformats.org/presentationml/2006/main">
   <p:cSld>
     <p:spTree>
@@ -1247,7 +1363,7 @@
           <a:p>
             <a:fld id="{C9565C50-69E9-8E49-A3AB-C69605F3BCD6}" type="slidenum">
               <a:rPr lang="en-AT" smtClean="0"/>
-              <a:t>16</a:t>
+              <a:t>17</a:t>
             </a:fld>
             <a:endParaRPr lang="en-AT"/>
           </a:p>
@@ -3553,7 +3669,7 @@
           <a:p>
             <a:fld id="{A591BDEC-81C3-DB48-92B3-4E74693DD55D}" type="datetimeFigureOut">
               <a:rPr lang="en-AT" smtClean="0"/>
-              <a:t>04.05.26</a:t>
+              <a:t>05.05.26</a:t>
             </a:fld>
             <a:endParaRPr lang="en-AT"/>
           </a:p>
@@ -3753,7 +3869,7 @@
           <a:p>
             <a:fld id="{A591BDEC-81C3-DB48-92B3-4E74693DD55D}" type="datetimeFigureOut">
               <a:rPr lang="en-AT" smtClean="0"/>
-              <a:t>04.05.26</a:t>
+              <a:t>05.05.26</a:t>
             </a:fld>
             <a:endParaRPr lang="en-AT"/>
           </a:p>
@@ -3963,7 +4079,7 @@
           <a:p>
             <a:fld id="{A591BDEC-81C3-DB48-92B3-4E74693DD55D}" type="datetimeFigureOut">
               <a:rPr lang="en-AT" smtClean="0"/>
-              <a:t>04.05.26</a:t>
+              <a:t>05.05.26</a:t>
             </a:fld>
             <a:endParaRPr lang="en-AT"/>
           </a:p>
@@ -4164,7 +4280,7 @@
             <a:fld id="{2C923EFC-C784-AC46-AE3C-8E1B6BCAD649}" type="datetime1">
               <a:rPr lang="en-US" smtClean="0"/>
               <a:pPr/>
-              <a:t>5/4/26</a:t>
+              <a:t>5/5/26</a:t>
             </a:fld>
             <a:endParaRPr lang="en-AT" dirty="0"/>
           </a:p>
@@ -5172,7 +5288,7 @@
           <a:p>
             <a:fld id="{A591BDEC-81C3-DB48-92B3-4E74693DD55D}" type="datetimeFigureOut">
               <a:rPr lang="en-AT" smtClean="0"/>
-              <a:t>04.05.26</a:t>
+              <a:t>05.05.26</a:t>
             </a:fld>
             <a:endParaRPr lang="en-AT"/>
           </a:p>
@@ -5869,7 +5985,7 @@
           <a:p>
             <a:fld id="{A591BDEC-81C3-DB48-92B3-4E74693DD55D}" type="datetimeFigureOut">
               <a:rPr lang="en-AT" smtClean="0"/>
-              <a:t>04.05.26</a:t>
+              <a:t>05.05.26</a:t>
             </a:fld>
             <a:endParaRPr lang="en-AT"/>
           </a:p>
@@ -6980,7 +7096,7 @@
           <a:p>
             <a:fld id="{A591BDEC-81C3-DB48-92B3-4E74693DD55D}" type="datetimeFigureOut">
               <a:rPr lang="en-AT" smtClean="0"/>
-              <a:t>04.05.26</a:t>
+              <a:t>05.05.26</a:t>
             </a:fld>
             <a:endParaRPr lang="en-AT"/>
           </a:p>
@@ -7818,7 +7934,7 @@
           <a:p>
             <a:fld id="{A591BDEC-81C3-DB48-92B3-4E74693DD55D}" type="datetimeFigureOut">
               <a:rPr lang="en-AT" smtClean="0"/>
-              <a:t>04.05.26</a:t>
+              <a:t>05.05.26</a:t>
             </a:fld>
             <a:endParaRPr lang="en-AT"/>
           </a:p>
@@ -8627,7 +8743,7 @@
           <a:p>
             <a:fld id="{A591BDEC-81C3-DB48-92B3-4E74693DD55D}" type="datetimeFigureOut">
               <a:rPr lang="en-AT" smtClean="0"/>
-              <a:t>04.05.26</a:t>
+              <a:t>05.05.26</a:t>
             </a:fld>
             <a:endParaRPr lang="en-AT"/>
           </a:p>
@@ -9636,7 +9752,7 @@
           <a:p>
             <a:fld id="{A591BDEC-81C3-DB48-92B3-4E74693DD55D}" type="datetimeFigureOut">
               <a:rPr lang="en-AT" smtClean="0"/>
-              <a:t>04.05.26</a:t>
+              <a:t>05.05.26</a:t>
             </a:fld>
             <a:endParaRPr lang="en-AT"/>
           </a:p>
@@ -10354,7 +10470,7 @@
           <a:p>
             <a:fld id="{A591BDEC-81C3-DB48-92B3-4E74693DD55D}" type="datetimeFigureOut">
               <a:rPr lang="en-AT" smtClean="0"/>
-              <a:t>04.05.26</a:t>
+              <a:t>05.05.26</a:t>
             </a:fld>
             <a:endParaRPr lang="en-AT"/>
           </a:p>
@@ -11026,7 +11142,7 @@
           <a:p>
             <a:fld id="{A591BDEC-81C3-DB48-92B3-4E74693DD55D}" type="datetimeFigureOut">
               <a:rPr lang="en-AT" smtClean="0"/>
-              <a:t>04.05.26</a:t>
+              <a:t>05.05.26</a:t>
             </a:fld>
             <a:endParaRPr lang="en-AT"/>
           </a:p>
@@ -11567,7 +11683,7 @@
           <a:p>
             <a:fld id="{343E18A4-A905-2445-944B-CEA2A38DE8BE}" type="datetime4">
               <a:rPr lang="en-AT" sz="1600"/>
-              <a:t>4. May 2026</a:t>
+              <a:t>5. May 2026</a:t>
             </a:fld>
             <a:endParaRPr lang="en-AT" sz="1600" dirty="0"/>
           </a:p>
@@ -12494,12 +12610,108 @@
           <a:bodyPr/>
           <a:lstStyle/>
           <a:p>
-            <a:pPr marL="0" indent="0">
-              <a:buNone/>
-            </a:pPr>
+            <a:r>
+              <a:rPr lang="en-AT" dirty="0"/>
+              <a:t>Dataset of the F1 World Championship 1950 – 2024 used</a:t>
+            </a:r>
+          </a:p>
+          <a:p>
+            <a:pPr lvl="1"/>
+            <a:r>
+              <a:rPr lang="en-GB" u="sng" dirty="0">
+                <a:hlinkClick r:id="rId3"/>
+              </a:rPr>
+              <a:t>https://www.kaggle.com/datasets/jtrotman/formula-1-race-data</a:t>
+            </a:r>
             <a:endParaRPr lang="en-AT" dirty="0"/>
           </a:p>
           <a:p>
+            <a:r>
+              <a:rPr lang="en-AT" dirty="0"/>
+              <a:t>Load data into Elasticsearch and query with an Python sript</a:t>
+            </a:r>
+          </a:p>
+          <a:p>
+            <a:r>
+              <a:rPr lang="en-AT" dirty="0"/>
+              <a:t>Visual data with Kibana</a:t>
+            </a:r>
+          </a:p>
+          <a:p>
+            <a:r>
+              <a:rPr lang="en-AT" dirty="0"/>
+              <a:t>Elasticsearch &amp; Kibana running in a Docker-Container</a:t>
+            </a:r>
+          </a:p>
+          <a:p>
+            <a:pPr lvl="1"/>
+            <a:r>
+              <a:rPr lang="en-AT" dirty="0"/>
+              <a:t>ES: </a:t>
+            </a:r>
+            <a:r>
+              <a:rPr lang="en-GB" u="sng" dirty="0">
+                <a:hlinkClick r:id="rId4"/>
+              </a:rPr>
+              <a:t>http://localhost:9200</a:t>
+            </a:r>
+            <a:r>
+              <a:rPr lang="en-GB" dirty="0"/>
+              <a:t> </a:t>
+            </a:r>
+          </a:p>
+          <a:p>
+            <a:pPr lvl="1"/>
+            <a:r>
+              <a:rPr lang="en-GB" dirty="0"/>
+              <a:t>Kibana: </a:t>
+            </a:r>
+            <a:r>
+              <a:rPr lang="en-GB" u="sng" dirty="0">
+                <a:hlinkClick r:id="rId5"/>
+              </a:rPr>
+              <a:t>http://localhost:5601</a:t>
+            </a:r>
+            <a:endParaRPr lang="en-AT" dirty="0"/>
+          </a:p>
+        </p:txBody>
+      </p:sp>
+      <p:sp>
+        <p:nvSpPr>
+          <p:cNvPr id="6" name="TextBox 5">
+            <a:extLst>
+              <a:ext uri="{FF2B5EF4-FFF2-40B4-BE49-F238E27FC236}">
+                <a16:creationId xmlns:a16="http://schemas.microsoft.com/office/drawing/2014/main" id="{B8533971-1FE2-7003-09C4-ED1B1D5A30C4}"/>
+              </a:ext>
+            </a:extLst>
+          </p:cNvPr>
+          <p:cNvSpPr txBox="1"/>
+          <p:nvPr/>
+        </p:nvSpPr>
+        <p:spPr>
+          <a:xfrm>
+            <a:off x="2439955" y="3799505"/>
+            <a:ext cx="6503436" cy="369332"/>
+          </a:xfrm>
+          <a:prstGeom prst="rect">
+            <a:avLst/>
+          </a:prstGeom>
+          <a:noFill/>
+        </p:spPr>
+        <p:txBody>
+          <a:bodyPr wrap="square">
+            <a:spAutoFit/>
+          </a:bodyPr>
+          <a:lstStyle/>
+          <a:p>
+            <a:r>
+              <a:rPr lang="en-GB" b="0" i="0" u="sng" dirty="0">
+                <a:effectLst/>
+                <a:latin typeface="Mona Sans VF"/>
+                <a:hlinkClick r:id="rId5"/>
+              </a:rPr>
+              <a:t>http://localhost:5601</a:t>
+            </a:r>
             <a:endParaRPr lang="en-AT" dirty="0"/>
           </a:p>
         </p:txBody>
@@ -12518,6 +12730,213 @@
 </file>
 
 <file path=ppt/slides/slide16.xml><?xml version="1.0" encoding="utf-8"?>
+<p:sld xmlns:a="http://schemas.openxmlformats.org/drawingml/2006/main" xmlns:r="http://schemas.openxmlformats.org/officeDocument/2006/relationships" xmlns:p="http://schemas.openxmlformats.org/presentationml/2006/main">
+  <p:cSld>
+    <p:spTree>
+      <p:nvGrpSpPr>
+        <p:cNvPr id="1" name="">
+          <a:extLst>
+            <a:ext uri="{FF2B5EF4-FFF2-40B4-BE49-F238E27FC236}">
+              <a16:creationId xmlns:a16="http://schemas.microsoft.com/office/drawing/2014/main" id="{A3B405F2-0145-1E9B-7881-A4E7FD301CCD}"/>
+            </a:ext>
+          </a:extLst>
+        </p:cNvPr>
+        <p:cNvGrpSpPr/>
+        <p:nvPr/>
+      </p:nvGrpSpPr>
+      <p:grpSpPr>
+        <a:xfrm>
+          <a:off x="0" y="0"/>
+          <a:ext cx="0" cy="0"/>
+          <a:chOff x="0" y="0"/>
+          <a:chExt cx="0" cy="0"/>
+        </a:xfrm>
+      </p:grpSpPr>
+      <p:sp>
+        <p:nvSpPr>
+          <p:cNvPr id="2" name="Title 1">
+            <a:extLst>
+              <a:ext uri="{FF2B5EF4-FFF2-40B4-BE49-F238E27FC236}">
+                <a16:creationId xmlns:a16="http://schemas.microsoft.com/office/drawing/2014/main" id="{45C38B5A-A436-392D-AA15-CC0FC774CA32}"/>
+              </a:ext>
+            </a:extLst>
+          </p:cNvPr>
+          <p:cNvSpPr>
+            <a:spLocks noGrp="1"/>
+          </p:cNvSpPr>
+          <p:nvPr>
+            <p:ph type="title"/>
+          </p:nvPr>
+        </p:nvSpPr>
+        <p:spPr/>
+        <p:txBody>
+          <a:bodyPr/>
+          <a:lstStyle/>
+          <a:p>
+            <a:r>
+              <a:rPr lang="en-AT" dirty="0"/>
+              <a:t>Project - </a:t>
+            </a:r>
+            <a:r>
+              <a:rPr lang="en-GB" dirty="0"/>
+              <a:t>Procedure</a:t>
+            </a:r>
+            <a:endParaRPr lang="en-AT" dirty="0"/>
+          </a:p>
+        </p:txBody>
+      </p:sp>
+      <p:sp>
+        <p:nvSpPr>
+          <p:cNvPr id="3" name="Content Placeholder 2">
+            <a:extLst>
+              <a:ext uri="{FF2B5EF4-FFF2-40B4-BE49-F238E27FC236}">
+                <a16:creationId xmlns:a16="http://schemas.microsoft.com/office/drawing/2014/main" id="{A8150E4D-987F-EBD9-2146-AB164FEAB9F7}"/>
+              </a:ext>
+            </a:extLst>
+          </p:cNvPr>
+          <p:cNvSpPr>
+            <a:spLocks noGrp="1"/>
+          </p:cNvSpPr>
+          <p:nvPr>
+            <p:ph idx="1"/>
+          </p:nvPr>
+        </p:nvSpPr>
+        <p:spPr/>
+        <p:txBody>
+          <a:bodyPr/>
+          <a:lstStyle/>
+          <a:p>
+            <a:pPr marL="0" indent="0">
+              <a:buNone/>
+            </a:pPr>
+            <a:r>
+              <a:rPr lang="en-AT" dirty="0">
+                <a:highlight>
+                  <a:srgbClr val="FED20B"/>
+                </a:highlight>
+              </a:rPr>
+              <a:t>Inserter</a:t>
+            </a:r>
+          </a:p>
+          <a:p>
+            <a:pPr marL="514350" indent="-514350">
+              <a:buFont typeface="+mj-lt"/>
+              <a:buAutoNum type="arabicPeriod"/>
+            </a:pPr>
+            <a:r>
+              <a:rPr lang="en-AT" dirty="0"/>
+              <a:t>Connect to Elasticsearch</a:t>
+            </a:r>
+          </a:p>
+          <a:p>
+            <a:pPr marL="514350" indent="-514350">
+              <a:buFont typeface="+mj-lt"/>
+              <a:buAutoNum type="arabicPeriod"/>
+            </a:pPr>
+            <a:r>
+              <a:rPr lang="en-AT" dirty="0"/>
+              <a:t>Load relevant CSV files</a:t>
+            </a:r>
+          </a:p>
+          <a:p>
+            <a:pPr marL="514350" indent="-514350">
+              <a:buFont typeface="+mj-lt"/>
+              <a:buAutoNum type="arabicPeriod"/>
+            </a:pPr>
+            <a:r>
+              <a:rPr lang="en-AT" dirty="0"/>
+              <a:t>Merge all 6 dataframes into one flat struture</a:t>
+            </a:r>
+          </a:p>
+          <a:p>
+            <a:pPr marL="514350" indent="-514350">
+              <a:buFont typeface="+mj-lt"/>
+              <a:buAutoNum type="arabicPeriod"/>
+            </a:pPr>
+            <a:r>
+              <a:rPr lang="en-AT"/>
+              <a:t>Creates one document for each race result row</a:t>
+            </a:r>
+            <a:endParaRPr lang="en-AT" dirty="0"/>
+          </a:p>
+          <a:p>
+            <a:pPr marL="514350" indent="-514350">
+              <a:buFont typeface="+mj-lt"/>
+              <a:buAutoNum type="arabicPeriod"/>
+            </a:pPr>
+            <a:r>
+              <a:rPr lang="en-GB" dirty="0"/>
+              <a:t>Create fresh index with mapping</a:t>
+            </a:r>
+          </a:p>
+          <a:p>
+            <a:pPr marL="514350" indent="-514350">
+              <a:buFont typeface="+mj-lt"/>
+              <a:buAutoNum type="arabicPeriod"/>
+            </a:pPr>
+            <a:r>
+              <a:rPr lang="en-GB" dirty="0"/>
+              <a:t>Send all documents in batches of 500</a:t>
+            </a:r>
+            <a:endParaRPr lang="en-AT" dirty="0"/>
+          </a:p>
+          <a:p>
+            <a:pPr marL="514350" indent="-514350">
+              <a:buFont typeface="+mj-lt"/>
+              <a:buAutoNum type="arabicPeriod"/>
+            </a:pPr>
+            <a:endParaRPr lang="en-AT" dirty="0">
+              <a:highlight>
+                <a:srgbClr val="FED20B"/>
+              </a:highlight>
+            </a:endParaRPr>
+          </a:p>
+        </p:txBody>
+      </p:sp>
+      <p:pic>
+        <p:nvPicPr>
+          <p:cNvPr id="4" name="Picture 3">
+            <a:extLst>
+              <a:ext uri="{FF2B5EF4-FFF2-40B4-BE49-F238E27FC236}">
+                <a16:creationId xmlns:a16="http://schemas.microsoft.com/office/drawing/2014/main" id="{D4A3BE3D-6829-90F0-C2FD-DFF5BBE7BF36}"/>
+              </a:ext>
+            </a:extLst>
+          </p:cNvPr>
+          <p:cNvPicPr>
+            <a:picLocks noChangeAspect="1"/>
+          </p:cNvPicPr>
+          <p:nvPr/>
+        </p:nvPicPr>
+        <p:blipFill>
+          <a:blip r:embed="rId3"/>
+          <a:stretch>
+            <a:fillRect/>
+          </a:stretch>
+        </p:blipFill>
+        <p:spPr>
+          <a:xfrm>
+            <a:off x="5624804" y="813610"/>
+            <a:ext cx="5814527" cy="2440665"/>
+          </a:xfrm>
+          <a:prstGeom prst="rect">
+            <a:avLst/>
+          </a:prstGeom>
+        </p:spPr>
+      </p:pic>
+    </p:spTree>
+    <p:extLst>
+      <p:ext uri="{BB962C8B-B14F-4D97-AF65-F5344CB8AC3E}">
+        <p14:creationId xmlns:p14="http://schemas.microsoft.com/office/powerpoint/2010/main" val="2637642287"/>
+      </p:ext>
+    </p:extLst>
+  </p:cSld>
+  <p:clrMapOvr>
+    <a:masterClrMapping/>
+  </p:clrMapOvr>
+</p:sld>
+</file>
+
+<file path=ppt/slides/slide17.xml><?xml version="1.0" encoding="utf-8"?>
 <p:sld xmlns:a="http://schemas.openxmlformats.org/drawingml/2006/main" xmlns:r="http://schemas.openxmlformats.org/officeDocument/2006/relationships" xmlns:p="http://schemas.openxmlformats.org/presentationml/2006/main">
   <p:cSld>
     <p:spTree>
@@ -12875,7 +13294,7 @@
         </p:blipFill>
         <p:spPr>
           <a:xfrm>
-            <a:off x="1431731" y="4472029"/>
+            <a:off x="1431731" y="4593327"/>
             <a:ext cx="3662784" cy="2020846"/>
           </a:xfrm>
           <a:prstGeom prst="rect">

</xml_diff>

<commit_message>
Added content to presentation "Agenda"
</commit_message>
<xml_diff>
--- a/Elasticsearch.pptx
+++ b/Elasticsearch.pptx
@@ -528,62 +528,6 @@
           <a:bodyPr/>
           <a:lstStyle/>
           <a:p>
-            <a:pPr marL="0" marR="0" lvl="0" indent="0" algn="l" defTabSz="914400" rtl="0" eaLnBrk="1" fontAlgn="auto" latinLnBrk="0" hangingPunct="1">
-              <a:lnSpc>
-                <a:spcPct val="100000"/>
-              </a:lnSpc>
-              <a:spcBef>
-                <a:spcPts val="0"/>
-              </a:spcBef>
-              <a:spcAft>
-                <a:spcPts val="0"/>
-              </a:spcAft>
-              <a:buClrTx/>
-              <a:buSzTx/>
-              <a:buFontTx/>
-              <a:buNone/>
-              <a:tabLst/>
-              <a:defRPr/>
-            </a:pPr>
-            <a:r>
-              <a:rPr lang="en-GB" sz="1200" b="0" i="0" kern="1200" dirty="0">
-                <a:solidFill>
-                  <a:schemeClr val="tx1"/>
-                </a:solidFill>
-                <a:effectLst/>
-                <a:latin typeface="+mn-lt"/>
-                <a:ea typeface="+mn-ea"/>
-                <a:cs typeface="+mn-cs"/>
-              </a:rPr>
-              <a:t>Elasticsearch stores data in </a:t>
-            </a:r>
-            <a:r>
-              <a:rPr lang="en-GB" sz="1200" b="0" i="0" u="sng" kern="1200" dirty="0">
-                <a:solidFill>
-                  <a:schemeClr val="tx1"/>
-                </a:solidFill>
-                <a:effectLst/>
-                <a:latin typeface="+mn-lt"/>
-                <a:ea typeface="+mn-ea"/>
-                <a:cs typeface="+mn-cs"/>
-                <a:hlinkClick r:id="rId3"/>
-              </a:rPr>
-              <a:t>JSON </a:t>
-            </a:r>
-            <a:r>
-              <a:rPr lang="en-GB" sz="1200" b="0" i="0" kern="1200" dirty="0">
-                <a:solidFill>
-                  <a:schemeClr val="tx1"/>
-                </a:solidFill>
-                <a:effectLst/>
-                <a:latin typeface="+mn-lt"/>
-                <a:ea typeface="+mn-ea"/>
-                <a:cs typeface="+mn-cs"/>
-              </a:rPr>
-              <a:t>format and making it easy to index and search structured and unstructured data.</a:t>
-            </a:r>
-          </a:p>
-          <a:p>
             <a:endParaRPr lang="en-AT" dirty="0"/>
           </a:p>
         </p:txBody>
@@ -605,7 +549,7 @@
           <a:p>
             <a:fld id="{C9565C50-69E9-8E49-A3AB-C69605F3BCD6}" type="slidenum">
               <a:rPr lang="en-AT" smtClean="0"/>
-              <a:t>3</a:t>
+              <a:t>2</a:t>
             </a:fld>
             <a:endParaRPr lang="en-AT"/>
           </a:p>
@@ -614,7 +558,7 @@
     </p:spTree>
     <p:extLst>
       <p:ext uri="{BB962C8B-B14F-4D97-AF65-F5344CB8AC3E}">
-        <p14:creationId xmlns:p14="http://schemas.microsoft.com/office/powerpoint/2010/main" val="4061353839"/>
+        <p14:creationId xmlns:p14="http://schemas.microsoft.com/office/powerpoint/2010/main" val="3049324321"/>
       </p:ext>
     </p:extLst>
   </p:cSld>
@@ -625,6 +569,229 @@
 </file>
 
 <file path=ppt/notesSlides/notesSlide10.xml><?xml version="1.0" encoding="utf-8"?>
+<p:notes xmlns:a="http://schemas.openxmlformats.org/drawingml/2006/main" xmlns:r="http://schemas.openxmlformats.org/officeDocument/2006/relationships" xmlns:p="http://schemas.openxmlformats.org/presentationml/2006/main">
+  <p:cSld>
+    <p:spTree>
+      <p:nvGrpSpPr>
+        <p:cNvPr id="1" name="">
+          <a:extLst>
+            <a:ext uri="{FF2B5EF4-FFF2-40B4-BE49-F238E27FC236}">
+              <a16:creationId xmlns:a16="http://schemas.microsoft.com/office/drawing/2014/main" id="{C2ECB3E3-77D4-EA37-7D52-31157EED6DF7}"/>
+            </a:ext>
+          </a:extLst>
+        </p:cNvPr>
+        <p:cNvGrpSpPr/>
+        <p:nvPr/>
+      </p:nvGrpSpPr>
+      <p:grpSpPr>
+        <a:xfrm>
+          <a:off x="0" y="0"/>
+          <a:ext cx="0" cy="0"/>
+          <a:chOff x="0" y="0"/>
+          <a:chExt cx="0" cy="0"/>
+        </a:xfrm>
+      </p:grpSpPr>
+      <p:sp>
+        <p:nvSpPr>
+          <p:cNvPr id="2" name="Slide Image Placeholder 1">
+            <a:extLst>
+              <a:ext uri="{FF2B5EF4-FFF2-40B4-BE49-F238E27FC236}">
+                <a16:creationId xmlns:a16="http://schemas.microsoft.com/office/drawing/2014/main" id="{1BC4FFE6-81C1-3B4A-1883-C1B13612892B}"/>
+              </a:ext>
+            </a:extLst>
+          </p:cNvPr>
+          <p:cNvSpPr>
+            <a:spLocks noGrp="1" noRot="1" noChangeAspect="1"/>
+          </p:cNvSpPr>
+          <p:nvPr>
+            <p:ph type="sldImg"/>
+          </p:nvPr>
+        </p:nvSpPr>
+        <p:spPr/>
+      </p:sp>
+      <p:sp>
+        <p:nvSpPr>
+          <p:cNvPr id="3" name="Notes Placeholder 2">
+            <a:extLst>
+              <a:ext uri="{FF2B5EF4-FFF2-40B4-BE49-F238E27FC236}">
+                <a16:creationId xmlns:a16="http://schemas.microsoft.com/office/drawing/2014/main" id="{4D93512F-B1FA-EB6F-32A1-33E9BE6AB437}"/>
+              </a:ext>
+            </a:extLst>
+          </p:cNvPr>
+          <p:cNvSpPr>
+            <a:spLocks noGrp="1"/>
+          </p:cNvSpPr>
+          <p:nvPr>
+            <p:ph type="body" idx="1"/>
+          </p:nvPr>
+        </p:nvSpPr>
+        <p:spPr/>
+        <p:txBody>
+          <a:bodyPr/>
+          <a:lstStyle/>
+          <a:p>
+            <a:r>
+              <a:rPr lang="en-GB" sz="1200" b="0" i="0" kern="1200" dirty="0">
+                <a:solidFill>
+                  <a:schemeClr val="tx1"/>
+                </a:solidFill>
+                <a:effectLst/>
+                <a:latin typeface="+mn-lt"/>
+                <a:ea typeface="+mn-ea"/>
+                <a:cs typeface="+mn-cs"/>
+              </a:rPr>
+              <a:t>The key fields worth pointing out on your slide:</a:t>
+            </a:r>
+          </a:p>
+          <a:p>
+            <a:r>
+              <a:rPr lang="en-GB" sz="1200" b="1" i="0" kern="1200" dirty="0">
+                <a:solidFill>
+                  <a:schemeClr val="tx1"/>
+                </a:solidFill>
+                <a:effectLst/>
+                <a:latin typeface="+mn-lt"/>
+                <a:ea typeface="+mn-ea"/>
+                <a:cs typeface="+mn-cs"/>
+              </a:rPr>
+              <a:t>took</a:t>
+            </a:r>
+            <a:r>
+              <a:rPr lang="en-GB" sz="1200" b="0" i="0" kern="1200" dirty="0">
+                <a:solidFill>
+                  <a:schemeClr val="tx1"/>
+                </a:solidFill>
+                <a:effectLst/>
+                <a:latin typeface="+mn-lt"/>
+                <a:ea typeface="+mn-ea"/>
+                <a:cs typeface="+mn-cs"/>
+              </a:rPr>
+              <a:t> — how many milliseconds the query took (3ms!)</a:t>
+            </a:r>
+          </a:p>
+          <a:p>
+            <a:r>
+              <a:rPr lang="en-GB" sz="1200" b="1" i="0" kern="1200" dirty="0" err="1">
+                <a:solidFill>
+                  <a:schemeClr val="tx1"/>
+                </a:solidFill>
+                <a:effectLst/>
+                <a:latin typeface="+mn-lt"/>
+                <a:ea typeface="+mn-ea"/>
+                <a:cs typeface="+mn-cs"/>
+              </a:rPr>
+              <a:t>total.value</a:t>
+            </a:r>
+            <a:r>
+              <a:rPr lang="en-GB" sz="1200" b="0" i="0" kern="1200" dirty="0">
+                <a:solidFill>
+                  <a:schemeClr val="tx1"/>
+                </a:solidFill>
+                <a:effectLst/>
+                <a:latin typeface="+mn-lt"/>
+                <a:ea typeface="+mn-ea"/>
+                <a:cs typeface="+mn-cs"/>
+              </a:rPr>
+              <a:t> — total number of matching documents (418 — remember, one per driver result)</a:t>
+            </a:r>
+          </a:p>
+          <a:p>
+            <a:r>
+              <a:rPr lang="en-GB" sz="1200" b="1" i="0" kern="1200" dirty="0">
+                <a:solidFill>
+                  <a:schemeClr val="tx1"/>
+                </a:solidFill>
+                <a:effectLst/>
+                <a:latin typeface="+mn-lt"/>
+                <a:ea typeface="+mn-ea"/>
+                <a:cs typeface="+mn-cs"/>
+              </a:rPr>
+              <a:t>_score</a:t>
+            </a:r>
+            <a:r>
+              <a:rPr lang="en-GB" sz="1200" b="0" i="0" kern="1200" dirty="0">
+                <a:solidFill>
+                  <a:schemeClr val="tx1"/>
+                </a:solidFill>
+                <a:effectLst/>
+                <a:latin typeface="+mn-lt"/>
+                <a:ea typeface="+mn-ea"/>
+                <a:cs typeface="+mn-cs"/>
+              </a:rPr>
+              <a:t> — the relevance score, higher = better match</a:t>
+            </a:r>
+          </a:p>
+          <a:p>
+            <a:r>
+              <a:rPr lang="en-GB" sz="1200" b="1" i="0" kern="1200" dirty="0">
+                <a:solidFill>
+                  <a:schemeClr val="tx1"/>
+                </a:solidFill>
+                <a:effectLst/>
+                <a:latin typeface="+mn-lt"/>
+                <a:ea typeface="+mn-ea"/>
+                <a:cs typeface="+mn-cs"/>
+              </a:rPr>
+              <a:t>_source</a:t>
+            </a:r>
+            <a:r>
+              <a:rPr lang="en-GB" sz="1200" b="0" i="0" kern="1200" dirty="0">
+                <a:solidFill>
+                  <a:schemeClr val="tx1"/>
+                </a:solidFill>
+                <a:effectLst/>
+                <a:latin typeface="+mn-lt"/>
+                <a:ea typeface="+mn-ea"/>
+                <a:cs typeface="+mn-cs"/>
+              </a:rPr>
+              <a:t> — the actual document data you indexed</a:t>
+            </a:r>
+          </a:p>
+        </p:txBody>
+      </p:sp>
+      <p:sp>
+        <p:nvSpPr>
+          <p:cNvPr id="4" name="Slide Number Placeholder 3">
+            <a:extLst>
+              <a:ext uri="{FF2B5EF4-FFF2-40B4-BE49-F238E27FC236}">
+                <a16:creationId xmlns:a16="http://schemas.microsoft.com/office/drawing/2014/main" id="{5CDAC94C-B877-45B7-4B8B-77D1C4B27D31}"/>
+              </a:ext>
+            </a:extLst>
+          </p:cNvPr>
+          <p:cNvSpPr>
+            <a:spLocks noGrp="1"/>
+          </p:cNvSpPr>
+          <p:nvPr>
+            <p:ph type="sldNum" sz="quarter" idx="5"/>
+          </p:nvPr>
+        </p:nvSpPr>
+        <p:spPr/>
+        <p:txBody>
+          <a:bodyPr/>
+          <a:lstStyle/>
+          <a:p>
+            <a:fld id="{C9565C50-69E9-8E49-A3AB-C69605F3BCD6}" type="slidenum">
+              <a:rPr lang="en-AT" smtClean="0"/>
+              <a:t>12</a:t>
+            </a:fld>
+            <a:endParaRPr lang="en-AT"/>
+          </a:p>
+        </p:txBody>
+      </p:sp>
+    </p:spTree>
+    <p:extLst>
+      <p:ext uri="{BB962C8B-B14F-4D97-AF65-F5344CB8AC3E}">
+        <p14:creationId xmlns:p14="http://schemas.microsoft.com/office/powerpoint/2010/main" val="3243757127"/>
+      </p:ext>
+    </p:extLst>
+  </p:cSld>
+  <p:clrMapOvr>
+    <a:masterClrMapping/>
+  </p:clrMapOvr>
+</p:notes>
+</file>
+
+<file path=ppt/notesSlides/notesSlide11.xml><?xml version="1.0" encoding="utf-8"?>
 <p:notes xmlns:a="http://schemas.openxmlformats.org/drawingml/2006/main" xmlns:r="http://schemas.openxmlformats.org/officeDocument/2006/relationships" xmlns:p="http://schemas.openxmlformats.org/presentationml/2006/main">
   <p:cSld>
     <p:spTree>
@@ -859,7 +1026,7 @@
 </p:notes>
 </file>
 
-<file path=ppt/notesSlides/notesSlide11.xml><?xml version="1.0" encoding="utf-8"?>
+<file path=ppt/notesSlides/notesSlide12.xml><?xml version="1.0" encoding="utf-8"?>
 <p:notes xmlns:a="http://schemas.openxmlformats.org/drawingml/2006/main" xmlns:r="http://schemas.openxmlformats.org/officeDocument/2006/relationships" xmlns:p="http://schemas.openxmlformats.org/presentationml/2006/main">
   <p:cSld>
     <p:spTree>
@@ -998,7 +1165,7 @@
 </p:notes>
 </file>
 
-<file path=ppt/notesSlides/notesSlide12.xml><?xml version="1.0" encoding="utf-8"?>
+<file path=ppt/notesSlides/notesSlide13.xml><?xml version="1.0" encoding="utf-8"?>
 <p:notes xmlns:a="http://schemas.openxmlformats.org/drawingml/2006/main" xmlns:r="http://schemas.openxmlformats.org/officeDocument/2006/relationships" xmlns:p="http://schemas.openxmlformats.org/presentationml/2006/main">
   <p:cSld>
     <p:spTree>
@@ -1106,7 +1273,7 @@
 </p:notes>
 </file>
 
-<file path=ppt/notesSlides/notesSlide13.xml><?xml version="1.0" encoding="utf-8"?>
+<file path=ppt/notesSlides/notesSlide14.xml><?xml version="1.0" encoding="utf-8"?>
 <p:notes xmlns:a="http://schemas.openxmlformats.org/drawingml/2006/main" xmlns:r="http://schemas.openxmlformats.org/officeDocument/2006/relationships" xmlns:p="http://schemas.openxmlformats.org/presentationml/2006/main">
   <p:cSld>
     <p:spTree>
@@ -1231,6 +1398,112 @@
               </a:rPr>
               <a:t>sql</a:t>
             </a:r>
+            <a:endParaRPr lang="en-GB" sz="1200" b="0" i="0" u="none" strike="noStrike" kern="1200" dirty="0">
+              <a:solidFill>
+                <a:schemeClr val="tx1"/>
+              </a:solidFill>
+              <a:effectLst/>
+              <a:latin typeface="+mn-lt"/>
+              <a:ea typeface="+mn-ea"/>
+              <a:cs typeface="+mn-cs"/>
+            </a:endParaRPr>
+          </a:p>
+          <a:p>
+            <a:endParaRPr lang="en-GB" sz="1200" b="0" i="0" u="none" strike="noStrike" kern="1200" dirty="0">
+              <a:solidFill>
+                <a:schemeClr val="tx1"/>
+              </a:solidFill>
+              <a:effectLst/>
+              <a:latin typeface="+mn-lt"/>
+              <a:ea typeface="+mn-ea"/>
+              <a:cs typeface="+mn-cs"/>
+            </a:endParaRPr>
+          </a:p>
+          <a:p>
+            <a:r>
+              <a:rPr lang="en-GB" sz="1200" b="0" i="0" u="none" strike="noStrike" kern="1200" dirty="0">
+                <a:solidFill>
+                  <a:schemeClr val="tx1"/>
+                </a:solidFill>
+                <a:effectLst/>
+                <a:latin typeface="+mn-lt"/>
+                <a:ea typeface="+mn-ea"/>
+                <a:cs typeface="+mn-cs"/>
+              </a:rPr>
+              <a:t>The relevant CSV files are loaded into pandas </a:t>
+            </a:r>
+            <a:r>
+              <a:rPr lang="en-GB" sz="1200" b="0" i="0" u="none" strike="noStrike" kern="1200" dirty="0" err="1">
+                <a:solidFill>
+                  <a:schemeClr val="tx1"/>
+                </a:solidFill>
+                <a:effectLst/>
+                <a:latin typeface="+mn-lt"/>
+                <a:ea typeface="+mn-ea"/>
+                <a:cs typeface="+mn-cs"/>
+              </a:rPr>
+              <a:t>dataframes</a:t>
+            </a:r>
+            <a:r>
+              <a:rPr lang="en-GB" sz="1200" b="0" i="0" u="none" strike="noStrike" kern="1200" dirty="0">
+                <a:solidFill>
+                  <a:schemeClr val="tx1"/>
+                </a:solidFill>
+                <a:effectLst/>
+                <a:latin typeface="+mn-lt"/>
+                <a:ea typeface="+mn-ea"/>
+                <a:cs typeface="+mn-cs"/>
+              </a:rPr>
+              <a:t>. The program then merges all </a:t>
+            </a:r>
+            <a:r>
+              <a:rPr lang="en-GB" sz="1200" b="0" i="0" u="none" strike="noStrike" kern="1200" dirty="0" err="1">
+                <a:solidFill>
+                  <a:schemeClr val="tx1"/>
+                </a:solidFill>
+                <a:effectLst/>
+                <a:latin typeface="+mn-lt"/>
+                <a:ea typeface="+mn-ea"/>
+                <a:cs typeface="+mn-cs"/>
+              </a:rPr>
+              <a:t>dataframes</a:t>
+            </a:r>
+            <a:r>
+              <a:rPr lang="en-GB" sz="1200" b="0" i="0" u="none" strike="noStrike" kern="1200" dirty="0">
+                <a:solidFill>
+                  <a:schemeClr val="tx1"/>
+                </a:solidFill>
+                <a:effectLst/>
+                <a:latin typeface="+mn-lt"/>
+                <a:ea typeface="+mn-ea"/>
+                <a:cs typeface="+mn-cs"/>
+              </a:rPr>
+              <a:t> into a single flat </a:t>
+            </a:r>
+            <a:r>
+              <a:rPr lang="en-GB" sz="1200" b="1" i="0" kern="1200" dirty="0">
+                <a:solidFill>
+                  <a:schemeClr val="tx1"/>
+                </a:solidFill>
+                <a:effectLst/>
+                <a:latin typeface="+mn-lt"/>
+                <a:ea typeface="+mn-ea"/>
+                <a:cs typeface="+mn-cs"/>
+              </a:rPr>
+              <a:t>table</a:t>
+            </a:r>
+            <a:r>
+              <a:rPr lang="en-GB" sz="1200" b="0" i="0" u="none" strike="noStrike" kern="1200" dirty="0">
+                <a:solidFill>
+                  <a:schemeClr val="tx1"/>
+                </a:solidFill>
+                <a:effectLst/>
+                <a:latin typeface="+mn-lt"/>
+                <a:ea typeface="+mn-ea"/>
+                <a:cs typeface="+mn-cs"/>
+              </a:rPr>
+              <a:t>, because Elasticsearch works best with flat documents rather than relational structures. This merged table is then iterated row by row, and for each race result row one document is created containing all additional information like points, circuit, constructor and so on. These documents are then bulk inserted into Elasticsearch.</a:t>
+            </a:r>
             <a:endParaRPr lang="en-AT" dirty="0"/>
           </a:p>
         </p:txBody>
@@ -1277,7 +1550,7 @@
 </p:notes>
 </file>
 
-<file path=ppt/notesSlides/notesSlide14.xml><?xml version="1.0" encoding="utf-8"?>
+<file path=ppt/notesSlides/notesSlide15.xml><?xml version="1.0" encoding="utf-8"?>
 <p:notes xmlns:a="http://schemas.openxmlformats.org/drawingml/2006/main" xmlns:r="http://schemas.openxmlformats.org/officeDocument/2006/relationships" xmlns:p="http://schemas.openxmlformats.org/presentationml/2006/main">
   <p:cSld>
     <p:spTree>
@@ -1448,7 +1721,7 @@
 </p:notes>
 </file>
 
-<file path=ppt/notesSlides/notesSlide15.xml><?xml version="1.0" encoding="utf-8"?>
+<file path=ppt/notesSlides/notesSlide16.xml><?xml version="1.0" encoding="utf-8"?>
 <p:notes xmlns:a="http://schemas.openxmlformats.org/drawingml/2006/main" xmlns:r="http://schemas.openxmlformats.org/officeDocument/2006/relationships" xmlns:p="http://schemas.openxmlformats.org/presentationml/2006/main">
   <p:cSld>
     <p:spTree>
@@ -1619,7 +1892,7 @@
 </p:notes>
 </file>
 
-<file path=ppt/notesSlides/notesSlide16.xml><?xml version="1.0" encoding="utf-8"?>
+<file path=ppt/notesSlides/notesSlide17.xml><?xml version="1.0" encoding="utf-8"?>
 <p:notes xmlns:a="http://schemas.openxmlformats.org/drawingml/2006/main" xmlns:r="http://schemas.openxmlformats.org/officeDocument/2006/relationships" xmlns:p="http://schemas.openxmlformats.org/presentationml/2006/main">
   <p:cSld>
     <p:spTree>
@@ -1732,6 +2005,146 @@
   <p:cSld>
     <p:spTree>
       <p:nvGrpSpPr>
+        <p:cNvPr id="1" name=""/>
+        <p:cNvGrpSpPr/>
+        <p:nvPr/>
+      </p:nvGrpSpPr>
+      <p:grpSpPr>
+        <a:xfrm>
+          <a:off x="0" y="0"/>
+          <a:ext cx="0" cy="0"/>
+          <a:chOff x="0" y="0"/>
+          <a:chExt cx="0" cy="0"/>
+        </a:xfrm>
+      </p:grpSpPr>
+      <p:sp>
+        <p:nvSpPr>
+          <p:cNvPr id="2" name="Slide Image Placeholder 1"/>
+          <p:cNvSpPr>
+            <a:spLocks noGrp="1" noRot="1" noChangeAspect="1"/>
+          </p:cNvSpPr>
+          <p:nvPr>
+            <p:ph type="sldImg"/>
+          </p:nvPr>
+        </p:nvSpPr>
+        <p:spPr/>
+      </p:sp>
+      <p:sp>
+        <p:nvSpPr>
+          <p:cNvPr id="3" name="Notes Placeholder 2"/>
+          <p:cNvSpPr>
+            <a:spLocks noGrp="1"/>
+          </p:cNvSpPr>
+          <p:nvPr>
+            <p:ph type="body" idx="1"/>
+          </p:nvPr>
+        </p:nvSpPr>
+        <p:spPr/>
+        <p:txBody>
+          <a:bodyPr/>
+          <a:lstStyle/>
+          <a:p>
+            <a:pPr marL="0" marR="0" lvl="0" indent="0" algn="l" defTabSz="914400" rtl="0" eaLnBrk="1" fontAlgn="auto" latinLnBrk="0" hangingPunct="1">
+              <a:lnSpc>
+                <a:spcPct val="100000"/>
+              </a:lnSpc>
+              <a:spcBef>
+                <a:spcPts val="0"/>
+              </a:spcBef>
+              <a:spcAft>
+                <a:spcPts val="0"/>
+              </a:spcAft>
+              <a:buClrTx/>
+              <a:buSzTx/>
+              <a:buFontTx/>
+              <a:buNone/>
+              <a:tabLst/>
+              <a:defRPr/>
+            </a:pPr>
+            <a:r>
+              <a:rPr lang="en-GB" sz="1200" b="0" i="0" kern="1200" dirty="0">
+                <a:solidFill>
+                  <a:schemeClr val="tx1"/>
+                </a:solidFill>
+                <a:effectLst/>
+                <a:latin typeface="+mn-lt"/>
+                <a:ea typeface="+mn-ea"/>
+                <a:cs typeface="+mn-cs"/>
+              </a:rPr>
+              <a:t>Elasticsearch stores data in </a:t>
+            </a:r>
+            <a:r>
+              <a:rPr lang="en-GB" sz="1200" b="0" i="0" u="sng" kern="1200" dirty="0">
+                <a:solidFill>
+                  <a:schemeClr val="tx1"/>
+                </a:solidFill>
+                <a:effectLst/>
+                <a:latin typeface="+mn-lt"/>
+                <a:ea typeface="+mn-ea"/>
+                <a:cs typeface="+mn-cs"/>
+                <a:hlinkClick r:id="rId3"/>
+              </a:rPr>
+              <a:t>JSON </a:t>
+            </a:r>
+            <a:r>
+              <a:rPr lang="en-GB" sz="1200" b="0" i="0" kern="1200" dirty="0">
+                <a:solidFill>
+                  <a:schemeClr val="tx1"/>
+                </a:solidFill>
+                <a:effectLst/>
+                <a:latin typeface="+mn-lt"/>
+                <a:ea typeface="+mn-ea"/>
+                <a:cs typeface="+mn-cs"/>
+              </a:rPr>
+              <a:t>format and making it easy to index and search structured and unstructured data.</a:t>
+            </a:r>
+          </a:p>
+          <a:p>
+            <a:endParaRPr lang="en-AT" dirty="0"/>
+          </a:p>
+        </p:txBody>
+      </p:sp>
+      <p:sp>
+        <p:nvSpPr>
+          <p:cNvPr id="4" name="Slide Number Placeholder 3"/>
+          <p:cNvSpPr>
+            <a:spLocks noGrp="1"/>
+          </p:cNvSpPr>
+          <p:nvPr>
+            <p:ph type="sldNum" sz="quarter" idx="5"/>
+          </p:nvPr>
+        </p:nvSpPr>
+        <p:spPr/>
+        <p:txBody>
+          <a:bodyPr/>
+          <a:lstStyle/>
+          <a:p>
+            <a:fld id="{C9565C50-69E9-8E49-A3AB-C69605F3BCD6}" type="slidenum">
+              <a:rPr lang="en-AT" smtClean="0"/>
+              <a:t>3</a:t>
+            </a:fld>
+            <a:endParaRPr lang="en-AT"/>
+          </a:p>
+        </p:txBody>
+      </p:sp>
+    </p:spTree>
+    <p:extLst>
+      <p:ext uri="{BB962C8B-B14F-4D97-AF65-F5344CB8AC3E}">
+        <p14:creationId xmlns:p14="http://schemas.microsoft.com/office/powerpoint/2010/main" val="4061353839"/>
+      </p:ext>
+    </p:extLst>
+  </p:cSld>
+  <p:clrMapOvr>
+    <a:masterClrMapping/>
+  </p:clrMapOvr>
+</p:notes>
+</file>
+
+<file path=ppt/notesSlides/notesSlide3.xml><?xml version="1.0" encoding="utf-8"?>
+<p:notes xmlns:a="http://schemas.openxmlformats.org/drawingml/2006/main" xmlns:r="http://schemas.openxmlformats.org/officeDocument/2006/relationships" xmlns:p="http://schemas.openxmlformats.org/presentationml/2006/main">
+  <p:cSld>
+    <p:spTree>
+      <p:nvGrpSpPr>
         <p:cNvPr id="1" name="">
           <a:extLst>
             <a:ext uri="{FF2B5EF4-FFF2-40B4-BE49-F238E27FC236}">
@@ -1919,7 +2332,7 @@
 </p:notes>
 </file>
 
-<file path=ppt/notesSlides/notesSlide3.xml><?xml version="1.0" encoding="utf-8"?>
+<file path=ppt/notesSlides/notesSlide4.xml><?xml version="1.0" encoding="utf-8"?>
 <p:notes xmlns:a="http://schemas.openxmlformats.org/drawingml/2006/main" xmlns:r="http://schemas.openxmlformats.org/officeDocument/2006/relationships" xmlns:p="http://schemas.openxmlformats.org/presentationml/2006/main">
   <p:cSld>
     <p:spTree>
@@ -2083,7 +2496,7 @@
 </p:notes>
 </file>
 
-<file path=ppt/notesSlides/notesSlide4.xml><?xml version="1.0" encoding="utf-8"?>
+<file path=ppt/notesSlides/notesSlide5.xml><?xml version="1.0" encoding="utf-8"?>
 <p:notes xmlns:a="http://schemas.openxmlformats.org/drawingml/2006/main" xmlns:r="http://schemas.openxmlformats.org/officeDocument/2006/relationships" xmlns:p="http://schemas.openxmlformats.org/presentationml/2006/main">
   <p:cSld>
     <p:spTree>
@@ -2526,7 +2939,7 @@
 </p:notes>
 </file>
 
-<file path=ppt/notesSlides/notesSlide5.xml><?xml version="1.0" encoding="utf-8"?>
+<file path=ppt/notesSlides/notesSlide6.xml><?xml version="1.0" encoding="utf-8"?>
 <p:notes xmlns:a="http://schemas.openxmlformats.org/drawingml/2006/main" xmlns:r="http://schemas.openxmlformats.org/officeDocument/2006/relationships" xmlns:p="http://schemas.openxmlformats.org/presentationml/2006/main">
   <p:cSld>
     <p:spTree>
@@ -2756,7 +3169,7 @@
 </p:notes>
 </file>
 
-<file path=ppt/notesSlides/notesSlide6.xml><?xml version="1.0" encoding="utf-8"?>
+<file path=ppt/notesSlides/notesSlide7.xml><?xml version="1.0" encoding="utf-8"?>
 <p:notes xmlns:a="http://schemas.openxmlformats.org/drawingml/2006/main" xmlns:r="http://schemas.openxmlformats.org/officeDocument/2006/relationships" xmlns:p="http://schemas.openxmlformats.org/presentationml/2006/main">
   <p:cSld>
     <p:spTree>
@@ -3129,7 +3542,7 @@
 </p:notes>
 </file>
 
-<file path=ppt/notesSlides/notesSlide7.xml><?xml version="1.0" encoding="utf-8"?>
+<file path=ppt/notesSlides/notesSlide8.xml><?xml version="1.0" encoding="utf-8"?>
 <p:notes xmlns:a="http://schemas.openxmlformats.org/drawingml/2006/main" xmlns:r="http://schemas.openxmlformats.org/officeDocument/2006/relationships" xmlns:p="http://schemas.openxmlformats.org/presentationml/2006/main">
   <p:cSld>
     <p:spTree>
@@ -3294,7 +3707,7 @@
 </p:notes>
 </file>
 
-<file path=ppt/notesSlides/notesSlide8.xml><?xml version="1.0" encoding="utf-8"?>
+<file path=ppt/notesSlides/notesSlide9.xml><?xml version="1.0" encoding="utf-8"?>
 <p:notes xmlns:a="http://schemas.openxmlformats.org/drawingml/2006/main" xmlns:r="http://schemas.openxmlformats.org/officeDocument/2006/relationships" xmlns:p="http://schemas.openxmlformats.org/presentationml/2006/main">
   <p:cSld>
     <p:spTree>
@@ -3633,229 +4046,6 @@
     <p:extLst>
       <p:ext uri="{BB962C8B-B14F-4D97-AF65-F5344CB8AC3E}">
         <p14:creationId xmlns:p14="http://schemas.microsoft.com/office/powerpoint/2010/main" val="602234647"/>
-      </p:ext>
-    </p:extLst>
-  </p:cSld>
-  <p:clrMapOvr>
-    <a:masterClrMapping/>
-  </p:clrMapOvr>
-</p:notes>
-</file>
-
-<file path=ppt/notesSlides/notesSlide9.xml><?xml version="1.0" encoding="utf-8"?>
-<p:notes xmlns:a="http://schemas.openxmlformats.org/drawingml/2006/main" xmlns:r="http://schemas.openxmlformats.org/officeDocument/2006/relationships" xmlns:p="http://schemas.openxmlformats.org/presentationml/2006/main">
-  <p:cSld>
-    <p:spTree>
-      <p:nvGrpSpPr>
-        <p:cNvPr id="1" name="">
-          <a:extLst>
-            <a:ext uri="{FF2B5EF4-FFF2-40B4-BE49-F238E27FC236}">
-              <a16:creationId xmlns:a16="http://schemas.microsoft.com/office/drawing/2014/main" id="{C2ECB3E3-77D4-EA37-7D52-31157EED6DF7}"/>
-            </a:ext>
-          </a:extLst>
-        </p:cNvPr>
-        <p:cNvGrpSpPr/>
-        <p:nvPr/>
-      </p:nvGrpSpPr>
-      <p:grpSpPr>
-        <a:xfrm>
-          <a:off x="0" y="0"/>
-          <a:ext cx="0" cy="0"/>
-          <a:chOff x="0" y="0"/>
-          <a:chExt cx="0" cy="0"/>
-        </a:xfrm>
-      </p:grpSpPr>
-      <p:sp>
-        <p:nvSpPr>
-          <p:cNvPr id="2" name="Slide Image Placeholder 1">
-            <a:extLst>
-              <a:ext uri="{FF2B5EF4-FFF2-40B4-BE49-F238E27FC236}">
-                <a16:creationId xmlns:a16="http://schemas.microsoft.com/office/drawing/2014/main" id="{1BC4FFE6-81C1-3B4A-1883-C1B13612892B}"/>
-              </a:ext>
-            </a:extLst>
-          </p:cNvPr>
-          <p:cNvSpPr>
-            <a:spLocks noGrp="1" noRot="1" noChangeAspect="1"/>
-          </p:cNvSpPr>
-          <p:nvPr>
-            <p:ph type="sldImg"/>
-          </p:nvPr>
-        </p:nvSpPr>
-        <p:spPr/>
-      </p:sp>
-      <p:sp>
-        <p:nvSpPr>
-          <p:cNvPr id="3" name="Notes Placeholder 2">
-            <a:extLst>
-              <a:ext uri="{FF2B5EF4-FFF2-40B4-BE49-F238E27FC236}">
-                <a16:creationId xmlns:a16="http://schemas.microsoft.com/office/drawing/2014/main" id="{4D93512F-B1FA-EB6F-32A1-33E9BE6AB437}"/>
-              </a:ext>
-            </a:extLst>
-          </p:cNvPr>
-          <p:cNvSpPr>
-            <a:spLocks noGrp="1"/>
-          </p:cNvSpPr>
-          <p:nvPr>
-            <p:ph type="body" idx="1"/>
-          </p:nvPr>
-        </p:nvSpPr>
-        <p:spPr/>
-        <p:txBody>
-          <a:bodyPr/>
-          <a:lstStyle/>
-          <a:p>
-            <a:r>
-              <a:rPr lang="en-GB" sz="1200" b="0" i="0" kern="1200" dirty="0">
-                <a:solidFill>
-                  <a:schemeClr val="tx1"/>
-                </a:solidFill>
-                <a:effectLst/>
-                <a:latin typeface="+mn-lt"/>
-                <a:ea typeface="+mn-ea"/>
-                <a:cs typeface="+mn-cs"/>
-              </a:rPr>
-              <a:t>The key fields worth pointing out on your slide:</a:t>
-            </a:r>
-          </a:p>
-          <a:p>
-            <a:r>
-              <a:rPr lang="en-GB" sz="1200" b="1" i="0" kern="1200" dirty="0">
-                <a:solidFill>
-                  <a:schemeClr val="tx1"/>
-                </a:solidFill>
-                <a:effectLst/>
-                <a:latin typeface="+mn-lt"/>
-                <a:ea typeface="+mn-ea"/>
-                <a:cs typeface="+mn-cs"/>
-              </a:rPr>
-              <a:t>took</a:t>
-            </a:r>
-            <a:r>
-              <a:rPr lang="en-GB" sz="1200" b="0" i="0" kern="1200" dirty="0">
-                <a:solidFill>
-                  <a:schemeClr val="tx1"/>
-                </a:solidFill>
-                <a:effectLst/>
-                <a:latin typeface="+mn-lt"/>
-                <a:ea typeface="+mn-ea"/>
-                <a:cs typeface="+mn-cs"/>
-              </a:rPr>
-              <a:t> — how many milliseconds the query took (3ms!)</a:t>
-            </a:r>
-          </a:p>
-          <a:p>
-            <a:r>
-              <a:rPr lang="en-GB" sz="1200" b="1" i="0" kern="1200" dirty="0" err="1">
-                <a:solidFill>
-                  <a:schemeClr val="tx1"/>
-                </a:solidFill>
-                <a:effectLst/>
-                <a:latin typeface="+mn-lt"/>
-                <a:ea typeface="+mn-ea"/>
-                <a:cs typeface="+mn-cs"/>
-              </a:rPr>
-              <a:t>total.value</a:t>
-            </a:r>
-            <a:r>
-              <a:rPr lang="en-GB" sz="1200" b="0" i="0" kern="1200" dirty="0">
-                <a:solidFill>
-                  <a:schemeClr val="tx1"/>
-                </a:solidFill>
-                <a:effectLst/>
-                <a:latin typeface="+mn-lt"/>
-                <a:ea typeface="+mn-ea"/>
-                <a:cs typeface="+mn-cs"/>
-              </a:rPr>
-              <a:t> — total number of matching documents (418 — remember, one per driver result)</a:t>
-            </a:r>
-          </a:p>
-          <a:p>
-            <a:r>
-              <a:rPr lang="en-GB" sz="1200" b="1" i="0" kern="1200" dirty="0">
-                <a:solidFill>
-                  <a:schemeClr val="tx1"/>
-                </a:solidFill>
-                <a:effectLst/>
-                <a:latin typeface="+mn-lt"/>
-                <a:ea typeface="+mn-ea"/>
-                <a:cs typeface="+mn-cs"/>
-              </a:rPr>
-              <a:t>_score</a:t>
-            </a:r>
-            <a:r>
-              <a:rPr lang="en-GB" sz="1200" b="0" i="0" kern="1200" dirty="0">
-                <a:solidFill>
-                  <a:schemeClr val="tx1"/>
-                </a:solidFill>
-                <a:effectLst/>
-                <a:latin typeface="+mn-lt"/>
-                <a:ea typeface="+mn-ea"/>
-                <a:cs typeface="+mn-cs"/>
-              </a:rPr>
-              <a:t> — the relevance score, higher = better match</a:t>
-            </a:r>
-          </a:p>
-          <a:p>
-            <a:r>
-              <a:rPr lang="en-GB" sz="1200" b="1" i="0" kern="1200" dirty="0">
-                <a:solidFill>
-                  <a:schemeClr val="tx1"/>
-                </a:solidFill>
-                <a:effectLst/>
-                <a:latin typeface="+mn-lt"/>
-                <a:ea typeface="+mn-ea"/>
-                <a:cs typeface="+mn-cs"/>
-              </a:rPr>
-              <a:t>_source</a:t>
-            </a:r>
-            <a:r>
-              <a:rPr lang="en-GB" sz="1200" b="0" i="0" kern="1200" dirty="0">
-                <a:solidFill>
-                  <a:schemeClr val="tx1"/>
-                </a:solidFill>
-                <a:effectLst/>
-                <a:latin typeface="+mn-lt"/>
-                <a:ea typeface="+mn-ea"/>
-                <a:cs typeface="+mn-cs"/>
-              </a:rPr>
-              <a:t> — the actual document data you indexed</a:t>
-            </a:r>
-          </a:p>
-        </p:txBody>
-      </p:sp>
-      <p:sp>
-        <p:nvSpPr>
-          <p:cNvPr id="4" name="Slide Number Placeholder 3">
-            <a:extLst>
-              <a:ext uri="{FF2B5EF4-FFF2-40B4-BE49-F238E27FC236}">
-                <a16:creationId xmlns:a16="http://schemas.microsoft.com/office/drawing/2014/main" id="{5CDAC94C-B877-45B7-4B8B-77D1C4B27D31}"/>
-              </a:ext>
-            </a:extLst>
-          </p:cNvPr>
-          <p:cNvSpPr>
-            <a:spLocks noGrp="1"/>
-          </p:cNvSpPr>
-          <p:nvPr>
-            <p:ph type="sldNum" sz="quarter" idx="5"/>
-          </p:nvPr>
-        </p:nvSpPr>
-        <p:spPr/>
-        <p:txBody>
-          <a:bodyPr/>
-          <a:lstStyle/>
-          <a:p>
-            <a:fld id="{C9565C50-69E9-8E49-A3AB-C69605F3BCD6}" type="slidenum">
-              <a:rPr lang="en-AT" smtClean="0"/>
-              <a:t>12</a:t>
-            </a:fld>
-            <a:endParaRPr lang="en-AT"/>
-          </a:p>
-        </p:txBody>
-      </p:sp>
-    </p:spTree>
-    <p:extLst>
-      <p:ext uri="{BB962C8B-B14F-4D97-AF65-F5344CB8AC3E}">
-        <p14:creationId xmlns:p14="http://schemas.microsoft.com/office/powerpoint/2010/main" val="3243757127"/>
       </p:ext>
     </p:extLst>
   </p:cSld>
@@ -12746,42 +12936,6 @@
           </a:prstGeom>
         </p:spPr>
       </p:pic>
-      <p:pic>
-        <p:nvPicPr>
-          <p:cNvPr id="7" name="Picture 6" descr="A red and black logo&#10;&#10;AI-generated content may be incorrect.">
-            <a:extLst>
-              <a:ext uri="{FF2B5EF4-FFF2-40B4-BE49-F238E27FC236}">
-                <a16:creationId xmlns:a16="http://schemas.microsoft.com/office/drawing/2014/main" id="{41B48F94-0667-6A48-31A2-F9DEA533B9C8}"/>
-              </a:ext>
-            </a:extLst>
-          </p:cNvPr>
-          <p:cNvPicPr>
-            <a:picLocks noChangeAspect="1"/>
-          </p:cNvPicPr>
-          <p:nvPr/>
-        </p:nvPicPr>
-        <p:blipFill>
-          <a:blip r:embed="rId3" cstate="print">
-            <a:extLst>
-              <a:ext uri="{28A0092B-C50C-407E-A947-70E740481C1C}">
-                <a14:useLocalDpi xmlns:a14="http://schemas.microsoft.com/office/drawing/2010/main" val="0"/>
-              </a:ext>
-            </a:extLst>
-          </a:blip>
-          <a:stretch>
-            <a:fillRect/>
-          </a:stretch>
-        </p:blipFill>
-        <p:spPr>
-          <a:xfrm>
-            <a:off x="10260516" y="6209211"/>
-            <a:ext cx="1809563" cy="491672"/>
-          </a:xfrm>
-          <a:prstGeom prst="rect">
-            <a:avLst/>
-          </a:prstGeom>
-        </p:spPr>
-      </p:pic>
     </p:spTree>
     <p:extLst>
       <p:ext uri="{BB962C8B-B14F-4D97-AF65-F5344CB8AC3E}">
@@ -13654,8 +13808,13 @@
           <a:p>
             <a:r>
               <a:rPr lang="en-AT" dirty="0"/>
-              <a:t>Load data into Elasticsearch and query with an Python sript</a:t>
-            </a:r>
+              <a:t>Load data into Elasticsearch and query with an </a:t>
+            </a:r>
+            <a:r>
+              <a:rPr lang="en-AT"/>
+              <a:t>Python script</a:t>
+            </a:r>
+            <a:endParaRPr lang="en-AT" dirty="0"/>
           </a:p>
           <a:p>
             <a:r>
@@ -13725,7 +13884,7 @@
         <p:spPr>
           <a:xfrm>
             <a:off x="712694" y="5629679"/>
-            <a:ext cx="2998694" cy="682221"/>
+            <a:ext cx="2913984" cy="662949"/>
           </a:xfrm>
           <a:prstGeom prst="rect">
             <a:avLst/>
@@ -13760,8 +13919,44 @@
         </p:blipFill>
         <p:spPr>
           <a:xfrm>
-            <a:off x="4119283" y="5340910"/>
-            <a:ext cx="1151965" cy="1151965"/>
+            <a:off x="4209770" y="5438774"/>
+            <a:ext cx="970990" cy="970990"/>
+          </a:xfrm>
+          <a:prstGeom prst="rect">
+            <a:avLst/>
+          </a:prstGeom>
+        </p:spPr>
+      </p:pic>
+      <p:pic>
+        <p:nvPicPr>
+          <p:cNvPr id="14" name="Graphic 13">
+            <a:extLst>
+              <a:ext uri="{FF2B5EF4-FFF2-40B4-BE49-F238E27FC236}">
+                <a16:creationId xmlns:a16="http://schemas.microsoft.com/office/drawing/2014/main" id="{4049D9A5-1C5A-88E2-E496-67D931A6EF7E}"/>
+              </a:ext>
+            </a:extLst>
+          </p:cNvPr>
+          <p:cNvPicPr>
+            <a:picLocks noChangeAspect="1"/>
+          </p:cNvPicPr>
+          <p:nvPr/>
+        </p:nvPicPr>
+        <p:blipFill>
+          <a:blip>
+            <a:extLst>
+              <a:ext uri="{96DAC541-7B7A-43D3-8B79-37D633B846F1}">
+                <asvg:svgBlip xmlns:asvg="http://schemas.microsoft.com/office/drawing/2016/SVG/main" r:embed="rId8"/>
+              </a:ext>
+            </a:extLst>
+          </a:blip>
+          <a:stretch>
+            <a:fillRect/>
+          </a:stretch>
+        </p:blipFill>
+        <p:spPr>
+          <a:xfrm>
+            <a:off x="5668818" y="5348287"/>
+            <a:ext cx="1066025" cy="1061477"/>
           </a:xfrm>
           <a:prstGeom prst="rect">
             <a:avLst/>
@@ -14477,26 +14672,881 @@
       </p:sp>
       <p:sp>
         <p:nvSpPr>
-          <p:cNvPr id="53" name="Content Placeholder 52">
-            <a:extLst>
-              <a:ext uri="{FF2B5EF4-FFF2-40B4-BE49-F238E27FC236}">
-                <a16:creationId xmlns:a16="http://schemas.microsoft.com/office/drawing/2014/main" id="{904DCB42-8A45-9615-EEDC-16F34F784D69}"/>
-              </a:ext>
-            </a:extLst>
-          </p:cNvPr>
-          <p:cNvSpPr>
-            <a:spLocks noGrp="1"/>
-          </p:cNvSpPr>
-          <p:nvPr>
-            <p:ph idx="1"/>
-          </p:nvPr>
-        </p:nvSpPr>
-        <p:spPr/>
+          <p:cNvPr id="5" name="Rounded Rectangle 4">
+            <a:extLst>
+              <a:ext uri="{FF2B5EF4-FFF2-40B4-BE49-F238E27FC236}">
+                <a16:creationId xmlns:a16="http://schemas.microsoft.com/office/drawing/2014/main" id="{22E1F800-4317-EA4C-447C-ECE19D3662C4}"/>
+              </a:ext>
+            </a:extLst>
+          </p:cNvPr>
+          <p:cNvSpPr/>
+          <p:nvPr/>
+        </p:nvSpPr>
+        <p:spPr>
+          <a:xfrm>
+            <a:off x="2312895" y="1770173"/>
+            <a:ext cx="5930151" cy="416859"/>
+          </a:xfrm>
+          <a:prstGeom prst="roundRect">
+            <a:avLst/>
+          </a:prstGeom>
+          <a:solidFill>
+            <a:srgbClr val="00BFB3"/>
+          </a:solidFill>
+          <a:ln>
+            <a:noFill/>
+          </a:ln>
+        </p:spPr>
+        <p:style>
+          <a:lnRef idx="2">
+            <a:schemeClr val="accent1">
+              <a:shade val="15000"/>
+            </a:schemeClr>
+          </a:lnRef>
+          <a:fillRef idx="1">
+            <a:schemeClr val="accent1"/>
+          </a:fillRef>
+          <a:effectRef idx="0">
+            <a:schemeClr val="accent1"/>
+          </a:effectRef>
+          <a:fontRef idx="minor">
+            <a:schemeClr val="lt1"/>
+          </a:fontRef>
+        </p:style>
         <p:txBody>
-          <a:bodyPr/>
+          <a:bodyPr rtlCol="0" anchor="ctr"/>
           <a:lstStyle/>
           <a:p>
-            <a:endParaRPr lang="en-AT" dirty="0"/>
+            <a:pPr algn="ctr"/>
+            <a:r>
+              <a:rPr lang="en-AT" sz="2400" dirty="0"/>
+              <a:t>What is ElasticSearch</a:t>
+            </a:r>
+          </a:p>
+        </p:txBody>
+      </p:sp>
+      <p:sp>
+        <p:nvSpPr>
+          <p:cNvPr id="6" name="Rounded Rectangle 5">
+            <a:extLst>
+              <a:ext uri="{FF2B5EF4-FFF2-40B4-BE49-F238E27FC236}">
+                <a16:creationId xmlns:a16="http://schemas.microsoft.com/office/drawing/2014/main" id="{2FFC05B3-E720-B7B7-04C9-697893327623}"/>
+              </a:ext>
+            </a:extLst>
+          </p:cNvPr>
+          <p:cNvSpPr/>
+          <p:nvPr/>
+        </p:nvSpPr>
+        <p:spPr>
+          <a:xfrm>
+            <a:off x="2312894" y="2401429"/>
+            <a:ext cx="5930151" cy="416859"/>
+          </a:xfrm>
+          <a:prstGeom prst="roundRect">
+            <a:avLst/>
+          </a:prstGeom>
+          <a:solidFill>
+            <a:srgbClr val="00BFB3"/>
+          </a:solidFill>
+          <a:ln>
+            <a:noFill/>
+          </a:ln>
+        </p:spPr>
+        <p:style>
+          <a:lnRef idx="2">
+            <a:schemeClr val="accent1">
+              <a:shade val="15000"/>
+            </a:schemeClr>
+          </a:lnRef>
+          <a:fillRef idx="1">
+            <a:schemeClr val="accent1"/>
+          </a:fillRef>
+          <a:effectRef idx="0">
+            <a:schemeClr val="accent1"/>
+          </a:effectRef>
+          <a:fontRef idx="minor">
+            <a:schemeClr val="lt1"/>
+          </a:fontRef>
+        </p:style>
+        <p:txBody>
+          <a:bodyPr rtlCol="0" anchor="ctr"/>
+          <a:lstStyle/>
+          <a:p>
+            <a:pPr algn="ctr"/>
+            <a:r>
+              <a:rPr lang="en-AT" sz="2400" dirty="0"/>
+              <a:t>Architecture</a:t>
+            </a:r>
+          </a:p>
+        </p:txBody>
+      </p:sp>
+      <p:sp>
+        <p:nvSpPr>
+          <p:cNvPr id="7" name="Rounded Rectangle 6">
+            <a:extLst>
+              <a:ext uri="{FF2B5EF4-FFF2-40B4-BE49-F238E27FC236}">
+                <a16:creationId xmlns:a16="http://schemas.microsoft.com/office/drawing/2014/main" id="{AB596FC3-64BB-07D8-E956-9503BA4C743D}"/>
+              </a:ext>
+            </a:extLst>
+          </p:cNvPr>
+          <p:cNvSpPr/>
+          <p:nvPr/>
+        </p:nvSpPr>
+        <p:spPr>
+          <a:xfrm>
+            <a:off x="2312895" y="3032685"/>
+            <a:ext cx="5930151" cy="416859"/>
+          </a:xfrm>
+          <a:prstGeom prst="roundRect">
+            <a:avLst/>
+          </a:prstGeom>
+          <a:solidFill>
+            <a:srgbClr val="00BFB3"/>
+          </a:solidFill>
+          <a:ln>
+            <a:noFill/>
+          </a:ln>
+        </p:spPr>
+        <p:style>
+          <a:lnRef idx="2">
+            <a:schemeClr val="accent1">
+              <a:shade val="15000"/>
+            </a:schemeClr>
+          </a:lnRef>
+          <a:fillRef idx="1">
+            <a:schemeClr val="accent1"/>
+          </a:fillRef>
+          <a:effectRef idx="0">
+            <a:schemeClr val="accent1"/>
+          </a:effectRef>
+          <a:fontRef idx="minor">
+            <a:schemeClr val="lt1"/>
+          </a:fontRef>
+        </p:style>
+        <p:txBody>
+          <a:bodyPr rtlCol="0" anchor="ctr"/>
+          <a:lstStyle/>
+          <a:p>
+            <a:pPr algn="ctr"/>
+            <a:r>
+              <a:rPr lang="en-AT" sz="2400" dirty="0"/>
+              <a:t>Key features</a:t>
+            </a:r>
+          </a:p>
+        </p:txBody>
+      </p:sp>
+      <p:sp>
+        <p:nvSpPr>
+          <p:cNvPr id="8" name="Rounded Rectangle 7">
+            <a:extLst>
+              <a:ext uri="{FF2B5EF4-FFF2-40B4-BE49-F238E27FC236}">
+                <a16:creationId xmlns:a16="http://schemas.microsoft.com/office/drawing/2014/main" id="{B5C9BECC-28E7-4633-8A2D-0214432A69AA}"/>
+              </a:ext>
+            </a:extLst>
+          </p:cNvPr>
+          <p:cNvSpPr/>
+          <p:nvPr/>
+        </p:nvSpPr>
+        <p:spPr>
+          <a:xfrm>
+            <a:off x="2312894" y="3688416"/>
+            <a:ext cx="5930151" cy="416859"/>
+          </a:xfrm>
+          <a:prstGeom prst="roundRect">
+            <a:avLst/>
+          </a:prstGeom>
+          <a:solidFill>
+            <a:srgbClr val="00BFB3"/>
+          </a:solidFill>
+          <a:ln>
+            <a:noFill/>
+          </a:ln>
+        </p:spPr>
+        <p:style>
+          <a:lnRef idx="2">
+            <a:schemeClr val="accent1">
+              <a:shade val="15000"/>
+            </a:schemeClr>
+          </a:lnRef>
+          <a:fillRef idx="1">
+            <a:schemeClr val="accent1"/>
+          </a:fillRef>
+          <a:effectRef idx="0">
+            <a:schemeClr val="accent1"/>
+          </a:effectRef>
+          <a:fontRef idx="minor">
+            <a:schemeClr val="lt1"/>
+          </a:fontRef>
+        </p:style>
+        <p:txBody>
+          <a:bodyPr rtlCol="0" anchor="ctr"/>
+          <a:lstStyle/>
+          <a:p>
+            <a:pPr algn="ctr"/>
+            <a:r>
+              <a:rPr lang="en-AT" sz="2400" dirty="0"/>
+              <a:t>How does it work</a:t>
+            </a:r>
+          </a:p>
+        </p:txBody>
+      </p:sp>
+      <p:sp>
+        <p:nvSpPr>
+          <p:cNvPr id="11" name="Rounded Rectangle 10">
+            <a:extLst>
+              <a:ext uri="{FF2B5EF4-FFF2-40B4-BE49-F238E27FC236}">
+                <a16:creationId xmlns:a16="http://schemas.microsoft.com/office/drawing/2014/main" id="{0B6B0778-6C1A-C82F-A08F-EBD35E8F20BF}"/>
+              </a:ext>
+            </a:extLst>
+          </p:cNvPr>
+          <p:cNvSpPr/>
+          <p:nvPr/>
+        </p:nvSpPr>
+        <p:spPr>
+          <a:xfrm>
+            <a:off x="2312895" y="4344147"/>
+            <a:ext cx="5930151" cy="416859"/>
+          </a:xfrm>
+          <a:prstGeom prst="roundRect">
+            <a:avLst/>
+          </a:prstGeom>
+          <a:solidFill>
+            <a:srgbClr val="00BFB3"/>
+          </a:solidFill>
+          <a:ln>
+            <a:noFill/>
+          </a:ln>
+        </p:spPr>
+        <p:style>
+          <a:lnRef idx="2">
+            <a:schemeClr val="accent1">
+              <a:shade val="15000"/>
+            </a:schemeClr>
+          </a:lnRef>
+          <a:fillRef idx="1">
+            <a:schemeClr val="accent1"/>
+          </a:fillRef>
+          <a:effectRef idx="0">
+            <a:schemeClr val="accent1"/>
+          </a:effectRef>
+          <a:fontRef idx="minor">
+            <a:schemeClr val="lt1"/>
+          </a:fontRef>
+        </p:style>
+        <p:txBody>
+          <a:bodyPr rtlCol="0" anchor="ctr"/>
+          <a:lstStyle/>
+          <a:p>
+            <a:pPr algn="ctr"/>
+            <a:r>
+              <a:rPr lang="en-AT" sz="2400" dirty="0"/>
+              <a:t>Query Language &amp; API</a:t>
+            </a:r>
+          </a:p>
+        </p:txBody>
+      </p:sp>
+      <p:sp>
+        <p:nvSpPr>
+          <p:cNvPr id="12" name="Rounded Rectangle 11">
+            <a:extLst>
+              <a:ext uri="{FF2B5EF4-FFF2-40B4-BE49-F238E27FC236}">
+                <a16:creationId xmlns:a16="http://schemas.microsoft.com/office/drawing/2014/main" id="{CE064E1E-84C9-2230-71F1-D564312B02E2}"/>
+              </a:ext>
+            </a:extLst>
+          </p:cNvPr>
+          <p:cNvSpPr/>
+          <p:nvPr/>
+        </p:nvSpPr>
+        <p:spPr>
+          <a:xfrm>
+            <a:off x="2312894" y="4999878"/>
+            <a:ext cx="5930151" cy="416859"/>
+          </a:xfrm>
+          <a:prstGeom prst="roundRect">
+            <a:avLst/>
+          </a:prstGeom>
+          <a:solidFill>
+            <a:srgbClr val="00BFB3"/>
+          </a:solidFill>
+          <a:ln>
+            <a:noFill/>
+          </a:ln>
+        </p:spPr>
+        <p:style>
+          <a:lnRef idx="2">
+            <a:schemeClr val="accent1">
+              <a:shade val="15000"/>
+            </a:schemeClr>
+          </a:lnRef>
+          <a:fillRef idx="1">
+            <a:schemeClr val="accent1"/>
+          </a:fillRef>
+          <a:effectRef idx="0">
+            <a:schemeClr val="accent1"/>
+          </a:effectRef>
+          <a:fontRef idx="minor">
+            <a:schemeClr val="lt1"/>
+          </a:fontRef>
+        </p:style>
+        <p:txBody>
+          <a:bodyPr rtlCol="0" anchor="ctr"/>
+          <a:lstStyle/>
+          <a:p>
+            <a:pPr algn="ctr"/>
+            <a:r>
+              <a:rPr lang="en-AT" sz="2400" dirty="0"/>
+              <a:t>Usecases</a:t>
+            </a:r>
+          </a:p>
+        </p:txBody>
+      </p:sp>
+      <p:sp>
+        <p:nvSpPr>
+          <p:cNvPr id="13" name="Rounded Rectangle 12">
+            <a:extLst>
+              <a:ext uri="{FF2B5EF4-FFF2-40B4-BE49-F238E27FC236}">
+                <a16:creationId xmlns:a16="http://schemas.microsoft.com/office/drawing/2014/main" id="{4B413FF3-404E-32CC-EF0A-B75CA2B1FE1C}"/>
+              </a:ext>
+            </a:extLst>
+          </p:cNvPr>
+          <p:cNvSpPr/>
+          <p:nvPr/>
+        </p:nvSpPr>
+        <p:spPr>
+          <a:xfrm>
+            <a:off x="2312895" y="5606659"/>
+            <a:ext cx="5930151" cy="416859"/>
+          </a:xfrm>
+          <a:prstGeom prst="roundRect">
+            <a:avLst/>
+          </a:prstGeom>
+          <a:solidFill>
+            <a:srgbClr val="00BFB3"/>
+          </a:solidFill>
+          <a:ln>
+            <a:noFill/>
+          </a:ln>
+        </p:spPr>
+        <p:style>
+          <a:lnRef idx="2">
+            <a:schemeClr val="accent1">
+              <a:shade val="15000"/>
+            </a:schemeClr>
+          </a:lnRef>
+          <a:fillRef idx="1">
+            <a:schemeClr val="accent1"/>
+          </a:fillRef>
+          <a:effectRef idx="0">
+            <a:schemeClr val="accent1"/>
+          </a:effectRef>
+          <a:fontRef idx="minor">
+            <a:schemeClr val="lt1"/>
+          </a:fontRef>
+        </p:style>
+        <p:txBody>
+          <a:bodyPr rtlCol="0" anchor="ctr"/>
+          <a:lstStyle/>
+          <a:p>
+            <a:pPr algn="ctr"/>
+            <a:r>
+              <a:rPr lang="en-AT" sz="2400" dirty="0"/>
+              <a:t>Advanteges &amp; Disadvanteges</a:t>
+            </a:r>
+          </a:p>
+        </p:txBody>
+      </p:sp>
+      <p:sp>
+        <p:nvSpPr>
+          <p:cNvPr id="14" name="Rounded Rectangle 13">
+            <a:extLst>
+              <a:ext uri="{FF2B5EF4-FFF2-40B4-BE49-F238E27FC236}">
+                <a16:creationId xmlns:a16="http://schemas.microsoft.com/office/drawing/2014/main" id="{853FF397-088C-12C0-106F-EE6F0865C193}"/>
+              </a:ext>
+            </a:extLst>
+          </p:cNvPr>
+          <p:cNvSpPr/>
+          <p:nvPr/>
+        </p:nvSpPr>
+        <p:spPr>
+          <a:xfrm>
+            <a:off x="2312894" y="6262390"/>
+            <a:ext cx="5930151" cy="416859"/>
+          </a:xfrm>
+          <a:prstGeom prst="roundRect">
+            <a:avLst/>
+          </a:prstGeom>
+          <a:solidFill>
+            <a:srgbClr val="00BFB3"/>
+          </a:solidFill>
+          <a:ln>
+            <a:noFill/>
+          </a:ln>
+        </p:spPr>
+        <p:style>
+          <a:lnRef idx="2">
+            <a:schemeClr val="accent1">
+              <a:shade val="15000"/>
+            </a:schemeClr>
+          </a:lnRef>
+          <a:fillRef idx="1">
+            <a:schemeClr val="accent1"/>
+          </a:fillRef>
+          <a:effectRef idx="0">
+            <a:schemeClr val="accent1"/>
+          </a:effectRef>
+          <a:fontRef idx="minor">
+            <a:schemeClr val="lt1"/>
+          </a:fontRef>
+        </p:style>
+        <p:txBody>
+          <a:bodyPr rtlCol="0" anchor="ctr"/>
+          <a:lstStyle/>
+          <a:p>
+            <a:pPr algn="ctr"/>
+            <a:r>
+              <a:rPr lang="en-AT" sz="2400" dirty="0"/>
+              <a:t>Project</a:t>
+            </a:r>
+          </a:p>
+        </p:txBody>
+      </p:sp>
+      <p:sp>
+        <p:nvSpPr>
+          <p:cNvPr id="15" name="Oval 14">
+            <a:extLst>
+              <a:ext uri="{FF2B5EF4-FFF2-40B4-BE49-F238E27FC236}">
+                <a16:creationId xmlns:a16="http://schemas.microsoft.com/office/drawing/2014/main" id="{357C3278-2D09-D7C6-A0DF-3F828592ED1B}"/>
+              </a:ext>
+            </a:extLst>
+          </p:cNvPr>
+          <p:cNvSpPr/>
+          <p:nvPr/>
+        </p:nvSpPr>
+        <p:spPr>
+          <a:xfrm>
+            <a:off x="1936376" y="1673625"/>
+            <a:ext cx="537882" cy="537882"/>
+          </a:xfrm>
+          <a:prstGeom prst="ellipse">
+            <a:avLst/>
+          </a:prstGeom>
+          <a:solidFill>
+            <a:srgbClr val="FED20B"/>
+          </a:solidFill>
+          <a:ln>
+            <a:noFill/>
+          </a:ln>
+        </p:spPr>
+        <p:style>
+          <a:lnRef idx="2">
+            <a:schemeClr val="accent1">
+              <a:shade val="15000"/>
+            </a:schemeClr>
+          </a:lnRef>
+          <a:fillRef idx="1">
+            <a:schemeClr val="accent1"/>
+          </a:fillRef>
+          <a:effectRef idx="0">
+            <a:schemeClr val="accent1"/>
+          </a:effectRef>
+          <a:fontRef idx="minor">
+            <a:schemeClr val="lt1"/>
+          </a:fontRef>
+        </p:style>
+        <p:txBody>
+          <a:bodyPr rtlCol="0" anchor="ctr"/>
+          <a:lstStyle/>
+          <a:p>
+            <a:pPr algn="ctr"/>
+            <a:r>
+              <a:rPr lang="en-AT" dirty="0"/>
+              <a:t>1</a:t>
+            </a:r>
+          </a:p>
+        </p:txBody>
+      </p:sp>
+      <p:sp>
+        <p:nvSpPr>
+          <p:cNvPr id="16" name="Oval 15">
+            <a:extLst>
+              <a:ext uri="{FF2B5EF4-FFF2-40B4-BE49-F238E27FC236}">
+                <a16:creationId xmlns:a16="http://schemas.microsoft.com/office/drawing/2014/main" id="{7A8C159A-ACCF-695A-8CB9-0E6F1E479BA0}"/>
+              </a:ext>
+            </a:extLst>
+          </p:cNvPr>
+          <p:cNvSpPr/>
+          <p:nvPr/>
+        </p:nvSpPr>
+        <p:spPr>
+          <a:xfrm>
+            <a:off x="1936376" y="2340917"/>
+            <a:ext cx="537882" cy="537882"/>
+          </a:xfrm>
+          <a:prstGeom prst="ellipse">
+            <a:avLst/>
+          </a:prstGeom>
+          <a:solidFill>
+            <a:srgbClr val="FED20B"/>
+          </a:solidFill>
+          <a:ln>
+            <a:noFill/>
+          </a:ln>
+        </p:spPr>
+        <p:style>
+          <a:lnRef idx="2">
+            <a:schemeClr val="accent1">
+              <a:shade val="15000"/>
+            </a:schemeClr>
+          </a:lnRef>
+          <a:fillRef idx="1">
+            <a:schemeClr val="accent1"/>
+          </a:fillRef>
+          <a:effectRef idx="0">
+            <a:schemeClr val="accent1"/>
+          </a:effectRef>
+          <a:fontRef idx="minor">
+            <a:schemeClr val="lt1"/>
+          </a:fontRef>
+        </p:style>
+        <p:txBody>
+          <a:bodyPr rtlCol="0" anchor="ctr"/>
+          <a:lstStyle/>
+          <a:p>
+            <a:pPr algn="ctr"/>
+            <a:r>
+              <a:rPr lang="en-AT" dirty="0"/>
+              <a:t>2</a:t>
+            </a:r>
+          </a:p>
+        </p:txBody>
+      </p:sp>
+      <p:sp>
+        <p:nvSpPr>
+          <p:cNvPr id="17" name="Oval 16">
+            <a:extLst>
+              <a:ext uri="{FF2B5EF4-FFF2-40B4-BE49-F238E27FC236}">
+                <a16:creationId xmlns:a16="http://schemas.microsoft.com/office/drawing/2014/main" id="{327B938E-F153-2295-9076-B7E6D6614536}"/>
+              </a:ext>
+            </a:extLst>
+          </p:cNvPr>
+          <p:cNvSpPr/>
+          <p:nvPr/>
+        </p:nvSpPr>
+        <p:spPr>
+          <a:xfrm>
+            <a:off x="1949822" y="2977607"/>
+            <a:ext cx="537882" cy="537882"/>
+          </a:xfrm>
+          <a:prstGeom prst="ellipse">
+            <a:avLst/>
+          </a:prstGeom>
+          <a:solidFill>
+            <a:srgbClr val="FED20B"/>
+          </a:solidFill>
+          <a:ln>
+            <a:noFill/>
+          </a:ln>
+        </p:spPr>
+        <p:style>
+          <a:lnRef idx="2">
+            <a:schemeClr val="accent1">
+              <a:shade val="15000"/>
+            </a:schemeClr>
+          </a:lnRef>
+          <a:fillRef idx="1">
+            <a:schemeClr val="accent1"/>
+          </a:fillRef>
+          <a:effectRef idx="0">
+            <a:schemeClr val="accent1"/>
+          </a:effectRef>
+          <a:fontRef idx="minor">
+            <a:schemeClr val="lt1"/>
+          </a:fontRef>
+        </p:style>
+        <p:txBody>
+          <a:bodyPr rtlCol="0" anchor="ctr"/>
+          <a:lstStyle/>
+          <a:p>
+            <a:pPr algn="ctr"/>
+            <a:r>
+              <a:rPr lang="en-AT" dirty="0"/>
+              <a:t>3</a:t>
+            </a:r>
+          </a:p>
+        </p:txBody>
+      </p:sp>
+      <p:sp>
+        <p:nvSpPr>
+          <p:cNvPr id="18" name="Oval 17">
+            <a:extLst>
+              <a:ext uri="{FF2B5EF4-FFF2-40B4-BE49-F238E27FC236}">
+                <a16:creationId xmlns:a16="http://schemas.microsoft.com/office/drawing/2014/main" id="{068FD66F-1A79-6701-A051-223C014A2A5D}"/>
+              </a:ext>
+            </a:extLst>
+          </p:cNvPr>
+          <p:cNvSpPr/>
+          <p:nvPr/>
+        </p:nvSpPr>
+        <p:spPr>
+          <a:xfrm>
+            <a:off x="1949822" y="3613541"/>
+            <a:ext cx="537882" cy="537882"/>
+          </a:xfrm>
+          <a:prstGeom prst="ellipse">
+            <a:avLst/>
+          </a:prstGeom>
+          <a:solidFill>
+            <a:srgbClr val="FED20B"/>
+          </a:solidFill>
+          <a:ln>
+            <a:noFill/>
+          </a:ln>
+        </p:spPr>
+        <p:style>
+          <a:lnRef idx="2">
+            <a:schemeClr val="accent1">
+              <a:shade val="15000"/>
+            </a:schemeClr>
+          </a:lnRef>
+          <a:fillRef idx="1">
+            <a:schemeClr val="accent1"/>
+          </a:fillRef>
+          <a:effectRef idx="0">
+            <a:schemeClr val="accent1"/>
+          </a:effectRef>
+          <a:fontRef idx="minor">
+            <a:schemeClr val="lt1"/>
+          </a:fontRef>
+        </p:style>
+        <p:txBody>
+          <a:bodyPr rtlCol="0" anchor="ctr"/>
+          <a:lstStyle/>
+          <a:p>
+            <a:pPr algn="ctr"/>
+            <a:r>
+              <a:rPr lang="en-AT" dirty="0"/>
+              <a:t>4</a:t>
+            </a:r>
+          </a:p>
+        </p:txBody>
+      </p:sp>
+      <p:sp>
+        <p:nvSpPr>
+          <p:cNvPr id="19" name="Oval 18">
+            <a:extLst>
+              <a:ext uri="{FF2B5EF4-FFF2-40B4-BE49-F238E27FC236}">
+                <a16:creationId xmlns:a16="http://schemas.microsoft.com/office/drawing/2014/main" id="{290A04B3-19D2-1559-43D1-DB03D1D3F721}"/>
+              </a:ext>
+            </a:extLst>
+          </p:cNvPr>
+          <p:cNvSpPr/>
+          <p:nvPr/>
+        </p:nvSpPr>
+        <p:spPr>
+          <a:xfrm>
+            <a:off x="1954304" y="4254321"/>
+            <a:ext cx="537882" cy="537882"/>
+          </a:xfrm>
+          <a:prstGeom prst="ellipse">
+            <a:avLst/>
+          </a:prstGeom>
+          <a:solidFill>
+            <a:srgbClr val="FED20B"/>
+          </a:solidFill>
+          <a:ln>
+            <a:noFill/>
+          </a:ln>
+        </p:spPr>
+        <p:style>
+          <a:lnRef idx="2">
+            <a:schemeClr val="accent1">
+              <a:shade val="15000"/>
+            </a:schemeClr>
+          </a:lnRef>
+          <a:fillRef idx="1">
+            <a:schemeClr val="accent1"/>
+          </a:fillRef>
+          <a:effectRef idx="0">
+            <a:schemeClr val="accent1"/>
+          </a:effectRef>
+          <a:fontRef idx="minor">
+            <a:schemeClr val="lt1"/>
+          </a:fontRef>
+        </p:style>
+        <p:txBody>
+          <a:bodyPr rtlCol="0" anchor="ctr"/>
+          <a:lstStyle/>
+          <a:p>
+            <a:pPr algn="ctr"/>
+            <a:r>
+              <a:rPr lang="en-AT" dirty="0"/>
+              <a:t>5</a:t>
+            </a:r>
+          </a:p>
+        </p:txBody>
+      </p:sp>
+      <p:sp>
+        <p:nvSpPr>
+          <p:cNvPr id="20" name="Oval 19">
+            <a:extLst>
+              <a:ext uri="{FF2B5EF4-FFF2-40B4-BE49-F238E27FC236}">
+                <a16:creationId xmlns:a16="http://schemas.microsoft.com/office/drawing/2014/main" id="{3B38889E-FBB5-4147-1626-5E329F7B0E89}"/>
+              </a:ext>
+            </a:extLst>
+          </p:cNvPr>
+          <p:cNvSpPr/>
+          <p:nvPr/>
+        </p:nvSpPr>
+        <p:spPr>
+          <a:xfrm>
+            <a:off x="1949822" y="4878855"/>
+            <a:ext cx="537882" cy="537882"/>
+          </a:xfrm>
+          <a:prstGeom prst="ellipse">
+            <a:avLst/>
+          </a:prstGeom>
+          <a:solidFill>
+            <a:srgbClr val="FED20B"/>
+          </a:solidFill>
+          <a:ln>
+            <a:noFill/>
+          </a:ln>
+        </p:spPr>
+        <p:style>
+          <a:lnRef idx="2">
+            <a:schemeClr val="accent1">
+              <a:shade val="15000"/>
+            </a:schemeClr>
+          </a:lnRef>
+          <a:fillRef idx="1">
+            <a:schemeClr val="accent1"/>
+          </a:fillRef>
+          <a:effectRef idx="0">
+            <a:schemeClr val="accent1"/>
+          </a:effectRef>
+          <a:fontRef idx="minor">
+            <a:schemeClr val="lt1"/>
+          </a:fontRef>
+        </p:style>
+        <p:txBody>
+          <a:bodyPr rtlCol="0" anchor="ctr"/>
+          <a:lstStyle/>
+          <a:p>
+            <a:pPr algn="ctr"/>
+            <a:r>
+              <a:rPr lang="en-AT" dirty="0"/>
+              <a:t>6</a:t>
+            </a:r>
+          </a:p>
+        </p:txBody>
+      </p:sp>
+      <p:sp>
+        <p:nvSpPr>
+          <p:cNvPr id="21" name="Oval 20">
+            <a:extLst>
+              <a:ext uri="{FF2B5EF4-FFF2-40B4-BE49-F238E27FC236}">
+                <a16:creationId xmlns:a16="http://schemas.microsoft.com/office/drawing/2014/main" id="{AFDA044F-A75C-73DA-F066-9795789113FF}"/>
+              </a:ext>
+            </a:extLst>
+          </p:cNvPr>
+          <p:cNvSpPr/>
+          <p:nvPr/>
+        </p:nvSpPr>
+        <p:spPr>
+          <a:xfrm>
+            <a:off x="1949822" y="5567074"/>
+            <a:ext cx="537882" cy="537882"/>
+          </a:xfrm>
+          <a:prstGeom prst="ellipse">
+            <a:avLst/>
+          </a:prstGeom>
+          <a:solidFill>
+            <a:srgbClr val="FED20B"/>
+          </a:solidFill>
+          <a:ln>
+            <a:noFill/>
+          </a:ln>
+        </p:spPr>
+        <p:style>
+          <a:lnRef idx="2">
+            <a:schemeClr val="accent1">
+              <a:shade val="15000"/>
+            </a:schemeClr>
+          </a:lnRef>
+          <a:fillRef idx="1">
+            <a:schemeClr val="accent1"/>
+          </a:fillRef>
+          <a:effectRef idx="0">
+            <a:schemeClr val="accent1"/>
+          </a:effectRef>
+          <a:fontRef idx="minor">
+            <a:schemeClr val="lt1"/>
+          </a:fontRef>
+        </p:style>
+        <p:txBody>
+          <a:bodyPr rtlCol="0" anchor="ctr"/>
+          <a:lstStyle/>
+          <a:p>
+            <a:pPr algn="ctr"/>
+            <a:r>
+              <a:rPr lang="en-AT" dirty="0"/>
+              <a:t>7</a:t>
+            </a:r>
+          </a:p>
+        </p:txBody>
+      </p:sp>
+      <p:sp>
+        <p:nvSpPr>
+          <p:cNvPr id="22" name="Oval 21">
+            <a:extLst>
+              <a:ext uri="{FF2B5EF4-FFF2-40B4-BE49-F238E27FC236}">
+                <a16:creationId xmlns:a16="http://schemas.microsoft.com/office/drawing/2014/main" id="{31E6CF56-E78F-50AE-F900-AB8A901F748A}"/>
+              </a:ext>
+            </a:extLst>
+          </p:cNvPr>
+          <p:cNvSpPr/>
+          <p:nvPr/>
+        </p:nvSpPr>
+        <p:spPr>
+          <a:xfrm>
+            <a:off x="1936376" y="6228016"/>
+            <a:ext cx="537882" cy="537882"/>
+          </a:xfrm>
+          <a:prstGeom prst="ellipse">
+            <a:avLst/>
+          </a:prstGeom>
+          <a:solidFill>
+            <a:srgbClr val="FED20B"/>
+          </a:solidFill>
+          <a:ln>
+            <a:noFill/>
+          </a:ln>
+        </p:spPr>
+        <p:style>
+          <a:lnRef idx="2">
+            <a:schemeClr val="accent1">
+              <a:shade val="15000"/>
+            </a:schemeClr>
+          </a:lnRef>
+          <a:fillRef idx="1">
+            <a:schemeClr val="accent1"/>
+          </a:fillRef>
+          <a:effectRef idx="0">
+            <a:schemeClr val="accent1"/>
+          </a:effectRef>
+          <a:fontRef idx="minor">
+            <a:schemeClr val="lt1"/>
+          </a:fontRef>
+        </p:style>
+        <p:txBody>
+          <a:bodyPr rtlCol="0" anchor="ctr"/>
+          <a:lstStyle/>
+          <a:p>
+            <a:pPr algn="ctr"/>
+            <a:r>
+              <a:rPr lang="en-AT" dirty="0"/>
+              <a:t>8</a:t>
+            </a:r>
           </a:p>
         </p:txBody>
       </p:sp>

</xml_diff>

<commit_message>
Architecture section in paper started
</commit_message>
<xml_diff>
--- a/Elasticsearch.pptx
+++ b/Elasticsearch.pptx
@@ -216,7 +216,7 @@
           <a:p>
             <a:fld id="{17C1BCD2-C187-B342-9D66-FD6DDE94747E}" type="datetimeFigureOut">
               <a:rPr lang="en-AT" smtClean="0"/>
-              <a:t>05.05.26</a:t>
+              <a:t>11.05.26</a:t>
             </a:fld>
             <a:endParaRPr lang="en-AT"/>
           </a:p>
@@ -4204,7 +4204,7 @@
           <a:p>
             <a:fld id="{A591BDEC-81C3-DB48-92B3-4E74693DD55D}" type="datetimeFigureOut">
               <a:rPr lang="en-AT" smtClean="0"/>
-              <a:t>05.05.26</a:t>
+              <a:t>11.05.26</a:t>
             </a:fld>
             <a:endParaRPr lang="en-AT"/>
           </a:p>
@@ -4869,7 +4869,7 @@
           <a:p>
             <a:fld id="{A591BDEC-81C3-DB48-92B3-4E74693DD55D}" type="datetimeFigureOut">
               <a:rPr lang="en-AT" smtClean="0"/>
-              <a:t>05.05.26</a:t>
+              <a:t>11.05.26</a:t>
             </a:fld>
             <a:endParaRPr lang="en-AT"/>
           </a:p>
@@ -5079,7 +5079,7 @@
           <a:p>
             <a:fld id="{A591BDEC-81C3-DB48-92B3-4E74693DD55D}" type="datetimeFigureOut">
               <a:rPr lang="en-AT" smtClean="0"/>
-              <a:t>05.05.26</a:t>
+              <a:t>11.05.26</a:t>
             </a:fld>
             <a:endParaRPr lang="en-AT"/>
           </a:p>
@@ -5280,7 +5280,7 @@
             <a:fld id="{2C923EFC-C784-AC46-AE3C-8E1B6BCAD649}" type="datetime1">
               <a:rPr lang="en-US" smtClean="0"/>
               <a:pPr/>
-              <a:t>5/5/26</a:t>
+              <a:t>5/11/26</a:t>
             </a:fld>
             <a:endParaRPr lang="en-AT" dirty="0"/>
           </a:p>
@@ -6288,7 +6288,7 @@
           <a:p>
             <a:fld id="{A591BDEC-81C3-DB48-92B3-4E74693DD55D}" type="datetimeFigureOut">
               <a:rPr lang="en-AT" smtClean="0"/>
-              <a:t>05.05.26</a:t>
+              <a:t>11.05.26</a:t>
             </a:fld>
             <a:endParaRPr lang="en-AT"/>
           </a:p>
@@ -7021,7 +7021,7 @@
           <a:p>
             <a:fld id="{A591BDEC-81C3-DB48-92B3-4E74693DD55D}" type="datetimeFigureOut">
               <a:rPr lang="en-AT" smtClean="0"/>
-              <a:t>05.05.26</a:t>
+              <a:t>11.05.26</a:t>
             </a:fld>
             <a:endParaRPr lang="en-AT"/>
           </a:p>
@@ -8168,7 +8168,7 @@
           <a:p>
             <a:fld id="{A591BDEC-81C3-DB48-92B3-4E74693DD55D}" type="datetimeFigureOut">
               <a:rPr lang="en-AT" smtClean="0"/>
-              <a:t>05.05.26</a:t>
+              <a:t>11.05.26</a:t>
             </a:fld>
             <a:endParaRPr lang="en-AT"/>
           </a:p>
@@ -9042,7 +9042,7 @@
           <a:p>
             <a:fld id="{A591BDEC-81C3-DB48-92B3-4E74693DD55D}" type="datetimeFigureOut">
               <a:rPr lang="en-AT" smtClean="0"/>
-              <a:t>05.05.26</a:t>
+              <a:t>11.05.26</a:t>
             </a:fld>
             <a:endParaRPr lang="en-AT"/>
           </a:p>
@@ -9887,7 +9887,7 @@
           <a:p>
             <a:fld id="{A591BDEC-81C3-DB48-92B3-4E74693DD55D}" type="datetimeFigureOut">
               <a:rPr lang="en-AT" smtClean="0"/>
-              <a:t>05.05.26</a:t>
+              <a:t>11.05.26</a:t>
             </a:fld>
             <a:endParaRPr lang="en-AT"/>
           </a:p>
@@ -10932,7 +10932,7 @@
           <a:p>
             <a:fld id="{A591BDEC-81C3-DB48-92B3-4E74693DD55D}" type="datetimeFigureOut">
               <a:rPr lang="en-AT" smtClean="0"/>
-              <a:t>05.05.26</a:t>
+              <a:t>11.05.26</a:t>
             </a:fld>
             <a:endParaRPr lang="en-AT"/>
           </a:p>
@@ -11686,7 +11686,7 @@
           <a:p>
             <a:fld id="{A591BDEC-81C3-DB48-92B3-4E74693DD55D}" type="datetimeFigureOut">
               <a:rPr lang="en-AT" smtClean="0"/>
-              <a:t>05.05.26</a:t>
+              <a:t>11.05.26</a:t>
             </a:fld>
             <a:endParaRPr lang="en-AT"/>
           </a:p>
@@ -12358,7 +12358,7 @@
           <a:p>
             <a:fld id="{A591BDEC-81C3-DB48-92B3-4E74693DD55D}" type="datetimeFigureOut">
               <a:rPr lang="en-AT" smtClean="0"/>
-              <a:t>05.05.26</a:t>
+              <a:t>11.05.26</a:t>
             </a:fld>
             <a:endParaRPr lang="en-AT"/>
           </a:p>
@@ -12899,7 +12899,7 @@
           <a:p>
             <a:fld id="{343E18A4-A905-2445-944B-CEA2A38DE8BE}" type="datetime4">
               <a:rPr lang="en-AT" sz="1600"/>
-              <a:t>5. May 2026</a:t>
+              <a:t>11. May 2026</a:t>
             </a:fld>
             <a:endParaRPr lang="en-AT" sz="1600" dirty="0"/>
           </a:p>
@@ -13808,13 +13808,8 @@
           <a:p>
             <a:r>
               <a:rPr lang="en-AT" dirty="0"/>
-              <a:t>Load data into Elasticsearch and query with an </a:t>
-            </a:r>
-            <a:r>
-              <a:rPr lang="en-AT"/>
-              <a:t>Python script</a:t>
-            </a:r>
-            <a:endParaRPr lang="en-AT" dirty="0"/>
+              <a:t>Load data into Elasticsearch and query with an Python script</a:t>
+            </a:r>
           </a:p>
           <a:p>
             <a:r>
@@ -17713,109 +17708,58 @@
           </p:spPr>
         </p:pic>
       </p:grpSp>
-      <p:grpSp>
-        <p:nvGrpSpPr>
-          <p:cNvPr id="14" name="Group 13">
-            <a:extLst>
-              <a:ext uri="{FF2B5EF4-FFF2-40B4-BE49-F238E27FC236}">
-                <a16:creationId xmlns:a16="http://schemas.microsoft.com/office/drawing/2014/main" id="{0148D32B-4A90-32FA-64A2-C4B15016D615}"/>
-              </a:ext>
-            </a:extLst>
-          </p:cNvPr>
-          <p:cNvGrpSpPr/>
+      <p:sp>
+        <p:nvSpPr>
+          <p:cNvPr id="12" name="Rectangle 11">
+            <a:extLst>
+              <a:ext uri="{FF2B5EF4-FFF2-40B4-BE49-F238E27FC236}">
+                <a16:creationId xmlns:a16="http://schemas.microsoft.com/office/drawing/2014/main" id="{5704C072-59A8-AEFE-45B6-284B7BBD56D5}"/>
+              </a:ext>
+            </a:extLst>
+          </p:cNvPr>
+          <p:cNvSpPr/>
           <p:nvPr/>
-        </p:nvGrpSpPr>
-        <p:grpSpPr>
+        </p:nvSpPr>
+        <p:spPr>
           <a:xfrm>
-            <a:off x="3582685" y="3072809"/>
-            <a:ext cx="3013046" cy="712381"/>
-            <a:chOff x="3540155" y="3065214"/>
-            <a:chExt cx="3013046" cy="712381"/>
+            <a:off x="3494675" y="3072809"/>
+            <a:ext cx="3355829" cy="712382"/>
           </a:xfrm>
-        </p:grpSpPr>
-        <p:sp>
-          <p:nvSpPr>
-            <p:cNvPr id="12" name="Rectangle 11">
-              <a:extLst>
-                <a:ext uri="{FF2B5EF4-FFF2-40B4-BE49-F238E27FC236}">
-                  <a16:creationId xmlns:a16="http://schemas.microsoft.com/office/drawing/2014/main" id="{5704C072-59A8-AEFE-45B6-284B7BBD56D5}"/>
-                </a:ext>
-              </a:extLst>
-            </p:cNvPr>
-            <p:cNvSpPr/>
-            <p:nvPr/>
-          </p:nvSpPr>
-          <p:spPr>
-            <a:xfrm>
-              <a:off x="3540155" y="3065214"/>
-              <a:ext cx="3013046" cy="712381"/>
-            </a:xfrm>
-            <a:prstGeom prst="rect">
-              <a:avLst/>
-            </a:prstGeom>
-            <a:solidFill>
-              <a:srgbClr val="00BFB3"/>
-            </a:solidFill>
-            <a:ln>
-              <a:noFill/>
-            </a:ln>
-          </p:spPr>
-          <p:style>
-            <a:lnRef idx="2">
-              <a:schemeClr val="accent1">
-                <a:shade val="15000"/>
-              </a:schemeClr>
-            </a:lnRef>
-            <a:fillRef idx="1">
-              <a:schemeClr val="accent1"/>
-            </a:fillRef>
-            <a:effectRef idx="0">
-              <a:schemeClr val="accent1"/>
-            </a:effectRef>
-            <a:fontRef idx="minor">
-              <a:schemeClr val="lt1"/>
-            </a:fontRef>
-          </p:style>
-          <p:txBody>
-            <a:bodyPr rtlCol="0" anchor="ctr"/>
-            <a:lstStyle/>
-            <a:p>
-              <a:pPr algn="ctr"/>
-              <a:endParaRPr lang="en-AT" dirty="0"/>
-            </a:p>
-          </p:txBody>
-        </p:sp>
-        <p:pic>
-          <p:nvPicPr>
-            <p:cNvPr id="13" name="Picture 12">
-              <a:extLst>
-                <a:ext uri="{FF2B5EF4-FFF2-40B4-BE49-F238E27FC236}">
-                  <a16:creationId xmlns:a16="http://schemas.microsoft.com/office/drawing/2014/main" id="{71152164-2EF5-EDD1-4262-7014902D7BD5}"/>
-                </a:ext>
-              </a:extLst>
-            </p:cNvPr>
-            <p:cNvPicPr>
-              <a:picLocks noChangeAspect="1"/>
-            </p:cNvPicPr>
-            <p:nvPr/>
-          </p:nvPicPr>
-          <p:blipFill>
-            <a:blip r:embed="rId4"/>
-            <a:stretch>
-              <a:fillRect/>
-            </a:stretch>
-          </p:blipFill>
-          <p:spPr>
-            <a:xfrm>
-              <a:off x="3616355" y="3160180"/>
-              <a:ext cx="2860645" cy="513805"/>
-            </a:xfrm>
-            <a:prstGeom prst="rect">
-              <a:avLst/>
-            </a:prstGeom>
-          </p:spPr>
-        </p:pic>
-      </p:grpSp>
+          <a:prstGeom prst="rect">
+            <a:avLst/>
+          </a:prstGeom>
+          <a:solidFill>
+            <a:srgbClr val="00BFB3"/>
+          </a:solidFill>
+          <a:ln>
+            <a:noFill/>
+          </a:ln>
+        </p:spPr>
+        <p:style>
+          <a:lnRef idx="2">
+            <a:schemeClr val="accent1">
+              <a:shade val="15000"/>
+            </a:schemeClr>
+          </a:lnRef>
+          <a:fillRef idx="1">
+            <a:schemeClr val="accent1"/>
+          </a:fillRef>
+          <a:effectRef idx="0">
+            <a:schemeClr val="accent1"/>
+          </a:effectRef>
+          <a:fontRef idx="minor">
+            <a:schemeClr val="lt1"/>
+          </a:fontRef>
+        </p:style>
+        <p:txBody>
+          <a:bodyPr rtlCol="0" anchor="ctr"/>
+          <a:lstStyle/>
+          <a:p>
+            <a:pPr algn="ctr"/>
+            <a:endParaRPr lang="en-AT" dirty="0"/>
+          </a:p>
+        </p:txBody>
+      </p:sp>
       <p:grpSp>
         <p:nvGrpSpPr>
           <p:cNvPr id="25" name="Group 24">
@@ -17903,7 +17847,7 @@
             <p:nvPr/>
           </p:nvPicPr>
           <p:blipFill>
-            <a:blip r:embed="rId5"/>
+            <a:blip r:embed="rId4"/>
             <a:stretch>
               <a:fillRect/>
             </a:stretch>
@@ -17919,6 +17863,36 @@
           </p:spPr>
         </p:pic>
       </p:grpSp>
+      <p:pic>
+        <p:nvPicPr>
+          <p:cNvPr id="5" name="Picture 4">
+            <a:extLst>
+              <a:ext uri="{FF2B5EF4-FFF2-40B4-BE49-F238E27FC236}">
+                <a16:creationId xmlns:a16="http://schemas.microsoft.com/office/drawing/2014/main" id="{3FBDF86E-2174-CF34-E191-82A30BE8D9C1}"/>
+              </a:ext>
+            </a:extLst>
+          </p:cNvPr>
+          <p:cNvPicPr>
+            <a:picLocks noChangeAspect="1"/>
+          </p:cNvPicPr>
+          <p:nvPr/>
+        </p:nvPicPr>
+        <p:blipFill>
+          <a:blip r:embed="rId5"/>
+          <a:stretch>
+            <a:fillRect/>
+          </a:stretch>
+        </p:blipFill>
+        <p:spPr>
+          <a:xfrm>
+            <a:off x="3549779" y="3170889"/>
+            <a:ext cx="3181489" cy="487118"/>
+          </a:xfrm>
+          <a:prstGeom prst="rect">
+            <a:avLst/>
+          </a:prstGeom>
+        </p:spPr>
+      </p:pic>
     </p:spTree>
     <p:extLst>
       <p:ext uri="{BB962C8B-B14F-4D97-AF65-F5344CB8AC3E}">
@@ -18080,198 +18054,24 @@
                                   </p:childTnLst>
                                 </p:cTn>
                               </p:par>
+                            </p:childTnLst>
+                          </p:cTn>
+                        </p:par>
+                        <p:par>
+                          <p:cTn id="14" fill="hold">
+                            <p:stCondLst>
+                              <p:cond delay="500"/>
+                            </p:stCondLst>
+                            <p:childTnLst>
                               <p:par>
-                                <p:cTn id="14" presetID="12" presetClass="entr" presetSubtype="4" fill="hold" nodeType="withEffect">
+                                <p:cTn id="15" presetID="2" presetClass="entr" presetSubtype="4" fill="hold" nodeType="afterEffect">
                                   <p:stCondLst>
                                     <p:cond delay="0"/>
                                   </p:stCondLst>
                                   <p:childTnLst>
                                     <p:set>
                                       <p:cBhvr>
-                                        <p:cTn id="15" dur="1" fill="hold">
-                                          <p:stCondLst>
-                                            <p:cond delay="0"/>
-                                          </p:stCondLst>
-                                        </p:cTn>
-                                        <p:tgtEl>
-                                          <p:spTgt spid="11"/>
-                                        </p:tgtEl>
-                                        <p:attrNameLst>
-                                          <p:attrName>style.visibility</p:attrName>
-                                        </p:attrNameLst>
-                                      </p:cBhvr>
-                                      <p:to>
-                                        <p:strVal val="visible"/>
-                                      </p:to>
-                                    </p:set>
-                                    <p:anim calcmode="lin" valueType="num">
-                                      <p:cBhvr additive="base">
-                                        <p:cTn id="16" dur="500"/>
-                                        <p:tgtEl>
-                                          <p:spTgt spid="11"/>
-                                        </p:tgtEl>
-                                        <p:attrNameLst>
-                                          <p:attrName>ppt_y</p:attrName>
-                                        </p:attrNameLst>
-                                      </p:cBhvr>
-                                      <p:tavLst>
-                                        <p:tav tm="0">
-                                          <p:val>
-                                            <p:strVal val="#ppt_y+#ppt_h*1.125000"/>
-                                          </p:val>
-                                        </p:tav>
-                                        <p:tav tm="100000">
-                                          <p:val>
-                                            <p:strVal val="#ppt_y"/>
-                                          </p:val>
-                                        </p:tav>
-                                      </p:tavLst>
-                                    </p:anim>
-                                    <p:animEffect transition="in" filter="wipe(up)">
-                                      <p:cBhvr>
-                                        <p:cTn id="17" dur="500"/>
-                                        <p:tgtEl>
-                                          <p:spTgt spid="11"/>
-                                        </p:tgtEl>
-                                      </p:cBhvr>
-                                    </p:animEffect>
-                                  </p:childTnLst>
-                                </p:cTn>
-                              </p:par>
-                              <p:par>
-                                <p:cTn id="18" presetID="12" presetClass="entr" presetSubtype="4" fill="hold" nodeType="withEffect">
-                                  <p:stCondLst>
-                                    <p:cond delay="0"/>
-                                  </p:stCondLst>
-                                  <p:childTnLst>
-                                    <p:set>
-                                      <p:cBhvr>
-                                        <p:cTn id="19" dur="1" fill="hold">
-                                          <p:stCondLst>
-                                            <p:cond delay="0"/>
-                                          </p:stCondLst>
-                                        </p:cTn>
-                                        <p:tgtEl>
-                                          <p:spTgt spid="14"/>
-                                        </p:tgtEl>
-                                        <p:attrNameLst>
-                                          <p:attrName>style.visibility</p:attrName>
-                                        </p:attrNameLst>
-                                      </p:cBhvr>
-                                      <p:to>
-                                        <p:strVal val="visible"/>
-                                      </p:to>
-                                    </p:set>
-                                    <p:anim calcmode="lin" valueType="num">
-                                      <p:cBhvr additive="base">
-                                        <p:cTn id="20" dur="500"/>
-                                        <p:tgtEl>
-                                          <p:spTgt spid="14"/>
-                                        </p:tgtEl>
-                                        <p:attrNameLst>
-                                          <p:attrName>ppt_y</p:attrName>
-                                        </p:attrNameLst>
-                                      </p:cBhvr>
-                                      <p:tavLst>
-                                        <p:tav tm="0">
-                                          <p:val>
-                                            <p:strVal val="#ppt_y+#ppt_h*1.125000"/>
-                                          </p:val>
-                                        </p:tav>
-                                        <p:tav tm="100000">
-                                          <p:val>
-                                            <p:strVal val="#ppt_y"/>
-                                          </p:val>
-                                        </p:tav>
-                                      </p:tavLst>
-                                    </p:anim>
-                                    <p:animEffect transition="in" filter="wipe(up)">
-                                      <p:cBhvr>
-                                        <p:cTn id="21" dur="500"/>
-                                        <p:tgtEl>
-                                          <p:spTgt spid="14"/>
-                                        </p:tgtEl>
-                                      </p:cBhvr>
-                                    </p:animEffect>
-                                  </p:childTnLst>
-                                </p:cTn>
-                              </p:par>
-                              <p:par>
-                                <p:cTn id="22" presetID="12" presetClass="entr" presetSubtype="4" fill="hold" nodeType="withEffect">
-                                  <p:stCondLst>
-                                    <p:cond delay="0"/>
-                                  </p:stCondLst>
-                                  <p:childTnLst>
-                                    <p:set>
-                                      <p:cBhvr>
-                                        <p:cTn id="23" dur="1" fill="hold">
-                                          <p:stCondLst>
-                                            <p:cond delay="0"/>
-                                          </p:stCondLst>
-                                        </p:cTn>
-                                        <p:tgtEl>
-                                          <p:spTgt spid="25"/>
-                                        </p:tgtEl>
-                                        <p:attrNameLst>
-                                          <p:attrName>style.visibility</p:attrName>
-                                        </p:attrNameLst>
-                                      </p:cBhvr>
-                                      <p:to>
-                                        <p:strVal val="visible"/>
-                                      </p:to>
-                                    </p:set>
-                                    <p:anim calcmode="lin" valueType="num">
-                                      <p:cBhvr additive="base">
-                                        <p:cTn id="24" dur="500"/>
-                                        <p:tgtEl>
-                                          <p:spTgt spid="25"/>
-                                        </p:tgtEl>
-                                        <p:attrNameLst>
-                                          <p:attrName>ppt_y</p:attrName>
-                                        </p:attrNameLst>
-                                      </p:cBhvr>
-                                      <p:tavLst>
-                                        <p:tav tm="0">
-                                          <p:val>
-                                            <p:strVal val="#ppt_y+#ppt_h*1.125000"/>
-                                          </p:val>
-                                        </p:tav>
-                                        <p:tav tm="100000">
-                                          <p:val>
-                                            <p:strVal val="#ppt_y"/>
-                                          </p:val>
-                                        </p:tav>
-                                      </p:tavLst>
-                                    </p:anim>
-                                    <p:animEffect transition="in" filter="wipe(up)">
-                                      <p:cBhvr>
-                                        <p:cTn id="25" dur="500"/>
-                                        <p:tgtEl>
-                                          <p:spTgt spid="25"/>
-                                        </p:tgtEl>
-                                      </p:cBhvr>
-                                    </p:animEffect>
-                                  </p:childTnLst>
-                                </p:cTn>
-                              </p:par>
-                            </p:childTnLst>
-                          </p:cTn>
-                        </p:par>
-                        <p:par>
-                          <p:cTn id="26" fill="hold">
-                            <p:stCondLst>
-                              <p:cond delay="500"/>
-                            </p:stCondLst>
-                            <p:childTnLst>
-                              <p:par>
-                                <p:cTn id="27" presetID="2" presetClass="entr" presetSubtype="4" fill="hold" nodeType="afterEffect">
-                                  <p:stCondLst>
-                                    <p:cond delay="0"/>
-                                  </p:stCondLst>
-                                  <p:childTnLst>
-                                    <p:set>
-                                      <p:cBhvr>
-                                        <p:cTn id="28" dur="1" fill="hold">
+                                        <p:cTn id="16" dur="1" fill="hold">
                                           <p:stCondLst>
                                             <p:cond delay="0"/>
                                           </p:stCondLst>
@@ -18293,7 +18093,7 @@
                                     </p:set>
                                     <p:anim calcmode="lin" valueType="num">
                                       <p:cBhvr additive="base">
-                                        <p:cTn id="29" dur="500" fill="hold"/>
+                                        <p:cTn id="17" dur="500" fill="hold"/>
                                         <p:tgtEl>
                                           <p:spTgt spid="3">
                                             <p:txEl>
@@ -18320,7 +18120,7 @@
                                     </p:anim>
                                     <p:anim calcmode="lin" valueType="num">
                                       <p:cBhvr additive="base">
-                                        <p:cTn id="30" dur="500" fill="hold"/>
+                                        <p:cTn id="18" dur="500" fill="hold"/>
                                         <p:tgtEl>
                                           <p:spTgt spid="3">
                                             <p:txEl>

</xml_diff>

<commit_message>
Fixed presentation by removing typos
</commit_message>
<xml_diff>
--- a/Elasticsearch.pptx
+++ b/Elasticsearch.pptx
@@ -216,7 +216,7 @@
           <a:p>
             <a:fld id="{17C1BCD2-C187-B342-9D66-FD6DDE94747E}" type="datetimeFigureOut">
               <a:rPr lang="en-AT" smtClean="0"/>
-              <a:t>11.05.26</a:t>
+              <a:t>15.05.26</a:t>
             </a:fld>
             <a:endParaRPr lang="en-AT"/>
           </a:p>
@@ -576,6 +576,354 @@
         <p:cNvPr id="1" name="">
           <a:extLst>
             <a:ext uri="{FF2B5EF4-FFF2-40B4-BE49-F238E27FC236}">
+              <a16:creationId xmlns:a16="http://schemas.microsoft.com/office/drawing/2014/main" id="{80C31299-0189-2C8D-89C9-3D8511124EBF}"/>
+            </a:ext>
+          </a:extLst>
+        </p:cNvPr>
+        <p:cNvGrpSpPr/>
+        <p:nvPr/>
+      </p:nvGrpSpPr>
+      <p:grpSpPr>
+        <a:xfrm>
+          <a:off x="0" y="0"/>
+          <a:ext cx="0" cy="0"/>
+          <a:chOff x="0" y="0"/>
+          <a:chExt cx="0" cy="0"/>
+        </a:xfrm>
+      </p:grpSpPr>
+      <p:sp>
+        <p:nvSpPr>
+          <p:cNvPr id="2" name="Slide Image Placeholder 1">
+            <a:extLst>
+              <a:ext uri="{FF2B5EF4-FFF2-40B4-BE49-F238E27FC236}">
+                <a16:creationId xmlns:a16="http://schemas.microsoft.com/office/drawing/2014/main" id="{15C92200-DEAD-57C0-C50B-49670743F495}"/>
+              </a:ext>
+            </a:extLst>
+          </p:cNvPr>
+          <p:cNvSpPr>
+            <a:spLocks noGrp="1" noRot="1" noChangeAspect="1"/>
+          </p:cNvSpPr>
+          <p:nvPr>
+            <p:ph type="sldImg"/>
+          </p:nvPr>
+        </p:nvSpPr>
+        <p:spPr/>
+      </p:sp>
+      <p:sp>
+        <p:nvSpPr>
+          <p:cNvPr id="3" name="Notes Placeholder 2">
+            <a:extLst>
+              <a:ext uri="{FF2B5EF4-FFF2-40B4-BE49-F238E27FC236}">
+                <a16:creationId xmlns:a16="http://schemas.microsoft.com/office/drawing/2014/main" id="{06A77AEE-0601-35AB-C699-AC10D553513D}"/>
+              </a:ext>
+            </a:extLst>
+          </p:cNvPr>
+          <p:cNvSpPr>
+            <a:spLocks noGrp="1"/>
+          </p:cNvSpPr>
+          <p:nvPr>
+            <p:ph type="body" idx="1"/>
+          </p:nvPr>
+        </p:nvSpPr>
+        <p:spPr/>
+        <p:txBody>
+          <a:bodyPr/>
+          <a:lstStyle/>
+          <a:p>
+            <a:pPr marL="0" marR="0" lvl="0" indent="0" algn="l" defTabSz="914400" rtl="0" eaLnBrk="1" fontAlgn="auto" latinLnBrk="0" hangingPunct="1">
+              <a:lnSpc>
+                <a:spcPct val="100000"/>
+              </a:lnSpc>
+              <a:spcBef>
+                <a:spcPts val="0"/>
+              </a:spcBef>
+              <a:spcAft>
+                <a:spcPts val="0"/>
+              </a:spcAft>
+              <a:buClrTx/>
+              <a:buSzTx/>
+              <a:buFontTx/>
+              <a:buNone/>
+              <a:tabLst/>
+              <a:defRPr/>
+            </a:pPr>
+            <a:r>
+              <a:rPr lang="en-GB" sz="1200" b="0" i="0" kern="1200" dirty="0">
+                <a:solidFill>
+                  <a:schemeClr val="tx1"/>
+                </a:solidFill>
+                <a:effectLst/>
+                <a:latin typeface="+mn-lt"/>
+                <a:ea typeface="+mn-ea"/>
+                <a:cs typeface="+mn-cs"/>
+              </a:rPr>
+              <a:t>GET -&gt; HTTP Methode +index name + endpoint</a:t>
+            </a:r>
+          </a:p>
+          <a:p>
+            <a:pPr marL="0" marR="0" lvl="0" indent="0" algn="l" defTabSz="914400" rtl="0" eaLnBrk="1" fontAlgn="auto" latinLnBrk="0" hangingPunct="1">
+              <a:lnSpc>
+                <a:spcPct val="100000"/>
+              </a:lnSpc>
+              <a:spcBef>
+                <a:spcPts val="0"/>
+              </a:spcBef>
+              <a:spcAft>
+                <a:spcPts val="0"/>
+              </a:spcAft>
+              <a:buClrTx/>
+              <a:buSzTx/>
+              <a:buFontTx/>
+              <a:buNone/>
+              <a:tabLst/>
+              <a:defRPr/>
+            </a:pPr>
+            <a:r>
+              <a:rPr lang="en-GB" sz="1200" b="0" i="0" kern="1200" dirty="0">
+                <a:solidFill>
+                  <a:schemeClr val="tx1"/>
+                </a:solidFill>
+                <a:effectLst/>
+                <a:latin typeface="+mn-lt"/>
+                <a:ea typeface="+mn-ea"/>
+                <a:cs typeface="+mn-cs"/>
+              </a:rPr>
+              <a:t>Query -&gt; </a:t>
+            </a:r>
+            <a:r>
+              <a:rPr lang="en-GB" sz="1200" b="0" i="0" kern="1200" dirty="0" err="1">
+                <a:solidFill>
+                  <a:schemeClr val="tx1"/>
+                </a:solidFill>
+                <a:effectLst/>
+                <a:latin typeface="+mn-lt"/>
+                <a:ea typeface="+mn-ea"/>
+                <a:cs typeface="+mn-cs"/>
+              </a:rPr>
+              <a:t>QueryDSL</a:t>
+            </a:r>
+            <a:r>
+              <a:rPr lang="en-GB" sz="1200" b="0" i="0" kern="1200" dirty="0">
+                <a:solidFill>
+                  <a:schemeClr val="tx1"/>
+                </a:solidFill>
+                <a:effectLst/>
+                <a:latin typeface="+mn-lt"/>
+                <a:ea typeface="+mn-ea"/>
+                <a:cs typeface="+mn-cs"/>
+              </a:rPr>
+              <a:t> Body</a:t>
+            </a:r>
+          </a:p>
+          <a:p>
+            <a:pPr marL="0" marR="0" lvl="0" indent="0" algn="l" defTabSz="914400" rtl="0" eaLnBrk="1" fontAlgn="auto" latinLnBrk="0" hangingPunct="1">
+              <a:lnSpc>
+                <a:spcPct val="100000"/>
+              </a:lnSpc>
+              <a:spcBef>
+                <a:spcPts val="0"/>
+              </a:spcBef>
+              <a:spcAft>
+                <a:spcPts val="0"/>
+              </a:spcAft>
+              <a:buClrTx/>
+              <a:buSzTx/>
+              <a:buFontTx/>
+              <a:buNone/>
+              <a:tabLst/>
+              <a:defRPr/>
+            </a:pPr>
+            <a:r>
+              <a:rPr lang="en-GB" sz="1200" b="0" i="0" kern="1200" dirty="0">
+                <a:solidFill>
+                  <a:schemeClr val="tx1"/>
+                </a:solidFill>
+                <a:effectLst/>
+                <a:latin typeface="+mn-lt"/>
+                <a:ea typeface="+mn-ea"/>
+                <a:cs typeface="+mn-cs"/>
+              </a:rPr>
+              <a:t>Match-&gt; </a:t>
+            </a:r>
+            <a:r>
+              <a:rPr lang="en-GB" sz="1200" b="0" i="0" u="none" strike="noStrike" kern="1200" dirty="0">
+                <a:solidFill>
+                  <a:schemeClr val="tx1"/>
+                </a:solidFill>
+                <a:effectLst/>
+                <a:latin typeface="+mn-lt"/>
+                <a:ea typeface="+mn-ea"/>
+                <a:cs typeface="+mn-cs"/>
+              </a:rPr>
+              <a:t>Query type: full-text search</a:t>
+            </a:r>
+          </a:p>
+          <a:p>
+            <a:pPr marL="0" marR="0" lvl="0" indent="0" algn="l" defTabSz="914400" rtl="0" eaLnBrk="1" fontAlgn="auto" latinLnBrk="0" hangingPunct="1">
+              <a:lnSpc>
+                <a:spcPct val="100000"/>
+              </a:lnSpc>
+              <a:spcBef>
+                <a:spcPts val="0"/>
+              </a:spcBef>
+              <a:spcAft>
+                <a:spcPts val="0"/>
+              </a:spcAft>
+              <a:buClrTx/>
+              <a:buSzTx/>
+              <a:buFontTx/>
+              <a:buNone/>
+              <a:tabLst/>
+              <a:defRPr/>
+            </a:pPr>
+            <a:r>
+              <a:rPr lang="en-GB" sz="1200" b="0" i="0" u="none" strike="noStrike" kern="1200" dirty="0">
+                <a:solidFill>
+                  <a:schemeClr val="tx1"/>
+                </a:solidFill>
+                <a:effectLst/>
+                <a:latin typeface="+mn-lt"/>
+                <a:ea typeface="+mn-ea"/>
+                <a:cs typeface="+mn-cs"/>
+              </a:rPr>
+              <a:t>field: search value</a:t>
+            </a:r>
+            <a:br>
+              <a:rPr lang="en-GB" sz="1200" b="0" i="0" u="none" strike="noStrike" kern="1200" dirty="0">
+                <a:solidFill>
+                  <a:schemeClr val="tx1"/>
+                </a:solidFill>
+                <a:effectLst/>
+                <a:latin typeface="+mn-lt"/>
+                <a:ea typeface="+mn-ea"/>
+                <a:cs typeface="+mn-cs"/>
+              </a:rPr>
+            </a:br>
+            <a:br>
+              <a:rPr lang="en-GB" sz="1200" b="0" i="0" u="none" strike="noStrike" kern="1200" dirty="0">
+                <a:solidFill>
+                  <a:schemeClr val="tx1"/>
+                </a:solidFill>
+                <a:effectLst/>
+                <a:latin typeface="+mn-lt"/>
+                <a:ea typeface="+mn-ea"/>
+                <a:cs typeface="+mn-cs"/>
+              </a:rPr>
+            </a:br>
+            <a:r>
+              <a:rPr lang="en-GB" sz="1200" b="0" i="0" u="none" strike="noStrike" kern="1200" dirty="0">
+                <a:solidFill>
+                  <a:schemeClr val="tx1"/>
+                </a:solidFill>
+                <a:effectLst/>
+                <a:latin typeface="+mn-lt"/>
+                <a:ea typeface="+mn-ea"/>
+                <a:cs typeface="+mn-cs"/>
+              </a:rPr>
+              <a:t>Query gets all documents of driver results where the </a:t>
+            </a:r>
+            <a:r>
+              <a:rPr lang="en-GB" sz="1200" b="0" i="0" u="none" strike="noStrike" kern="1200" dirty="0" err="1">
+                <a:solidFill>
+                  <a:schemeClr val="tx1"/>
+                </a:solidFill>
+                <a:effectLst/>
+                <a:latin typeface="+mn-lt"/>
+                <a:ea typeface="+mn-ea"/>
+                <a:cs typeface="+mn-cs"/>
+              </a:rPr>
+              <a:t>race_name</a:t>
+            </a:r>
+            <a:r>
+              <a:rPr lang="en-GB" sz="1200" b="0" i="0" u="none" strike="noStrike" kern="1200" dirty="0">
+                <a:solidFill>
+                  <a:schemeClr val="tx1"/>
+                </a:solidFill>
+                <a:effectLst/>
+                <a:latin typeface="+mn-lt"/>
+                <a:ea typeface="+mn-ea"/>
+                <a:cs typeface="+mn-cs"/>
+              </a:rPr>
+              <a:t> is </a:t>
+            </a:r>
+            <a:r>
+              <a:rPr lang="en-GB" sz="1200" b="0" i="0" u="none" strike="noStrike" kern="1200" dirty="0" err="1">
+                <a:solidFill>
+                  <a:schemeClr val="tx1"/>
+                </a:solidFill>
+                <a:effectLst/>
+                <a:latin typeface="+mn-lt"/>
+                <a:ea typeface="+mn-ea"/>
+                <a:cs typeface="+mn-cs"/>
+              </a:rPr>
+              <a:t>monaco</a:t>
+            </a:r>
+            <a:r>
+              <a:rPr lang="en-GB" sz="1200" b="0" i="0" u="none" strike="noStrike" kern="1200" dirty="0">
+                <a:solidFill>
+                  <a:schemeClr val="tx1"/>
+                </a:solidFill>
+                <a:effectLst/>
+                <a:latin typeface="+mn-lt"/>
+                <a:ea typeface="+mn-ea"/>
+                <a:cs typeface="+mn-cs"/>
+              </a:rPr>
+              <a:t> </a:t>
+            </a:r>
+            <a:endParaRPr lang="en-AT" dirty="0"/>
+          </a:p>
+        </p:txBody>
+      </p:sp>
+      <p:sp>
+        <p:nvSpPr>
+          <p:cNvPr id="4" name="Slide Number Placeholder 3">
+            <a:extLst>
+              <a:ext uri="{FF2B5EF4-FFF2-40B4-BE49-F238E27FC236}">
+                <a16:creationId xmlns:a16="http://schemas.microsoft.com/office/drawing/2014/main" id="{74D0EEC9-47A7-F691-D36B-5BF05A027F0F}"/>
+              </a:ext>
+            </a:extLst>
+          </p:cNvPr>
+          <p:cNvSpPr>
+            <a:spLocks noGrp="1"/>
+          </p:cNvSpPr>
+          <p:nvPr>
+            <p:ph type="sldNum" sz="quarter" idx="5"/>
+          </p:nvPr>
+        </p:nvSpPr>
+        <p:spPr/>
+        <p:txBody>
+          <a:bodyPr/>
+          <a:lstStyle/>
+          <a:p>
+            <a:fld id="{C9565C50-69E9-8E49-A3AB-C69605F3BCD6}" type="slidenum">
+              <a:rPr lang="en-AT" smtClean="0"/>
+              <a:t>11</a:t>
+            </a:fld>
+            <a:endParaRPr lang="en-AT"/>
+          </a:p>
+        </p:txBody>
+      </p:sp>
+    </p:spTree>
+    <p:extLst>
+      <p:ext uri="{BB962C8B-B14F-4D97-AF65-F5344CB8AC3E}">
+        <p14:creationId xmlns:p14="http://schemas.microsoft.com/office/powerpoint/2010/main" val="602234647"/>
+      </p:ext>
+    </p:extLst>
+  </p:cSld>
+  <p:clrMapOvr>
+    <a:masterClrMapping/>
+  </p:clrMapOvr>
+</p:notes>
+</file>
+
+<file path=ppt/notesSlides/notesSlide11.xml><?xml version="1.0" encoding="utf-8"?>
+<p:notes xmlns:a="http://schemas.openxmlformats.org/drawingml/2006/main" xmlns:r="http://schemas.openxmlformats.org/officeDocument/2006/relationships" xmlns:p="http://schemas.openxmlformats.org/presentationml/2006/main">
+  <p:cSld>
+    <p:spTree>
+      <p:nvGrpSpPr>
+        <p:cNvPr id="1" name="">
+          <a:extLst>
+            <a:ext uri="{FF2B5EF4-FFF2-40B4-BE49-F238E27FC236}">
               <a16:creationId xmlns:a16="http://schemas.microsoft.com/office/drawing/2014/main" id="{C2ECB3E3-77D4-EA37-7D52-31157EED6DF7}"/>
             </a:ext>
           </a:extLst>
@@ -791,7 +1139,7 @@
 </p:notes>
 </file>
 
-<file path=ppt/notesSlides/notesSlide11.xml><?xml version="1.0" encoding="utf-8"?>
+<file path=ppt/notesSlides/notesSlide12.xml><?xml version="1.0" encoding="utf-8"?>
 <p:notes xmlns:a="http://schemas.openxmlformats.org/drawingml/2006/main" xmlns:r="http://schemas.openxmlformats.org/officeDocument/2006/relationships" xmlns:p="http://schemas.openxmlformats.org/presentationml/2006/main">
   <p:cSld>
     <p:spTree>
@@ -1026,7 +1374,7 @@
 </p:notes>
 </file>
 
-<file path=ppt/notesSlides/notesSlide12.xml><?xml version="1.0" encoding="utf-8"?>
+<file path=ppt/notesSlides/notesSlide13.xml><?xml version="1.0" encoding="utf-8"?>
 <p:notes xmlns:a="http://schemas.openxmlformats.org/drawingml/2006/main" xmlns:r="http://schemas.openxmlformats.org/officeDocument/2006/relationships" xmlns:p="http://schemas.openxmlformats.org/presentationml/2006/main">
   <p:cSld>
     <p:spTree>
@@ -1165,7 +1513,7 @@
 </p:notes>
 </file>
 
-<file path=ppt/notesSlides/notesSlide13.xml><?xml version="1.0" encoding="utf-8"?>
+<file path=ppt/notesSlides/notesSlide14.xml><?xml version="1.0" encoding="utf-8"?>
 <p:notes xmlns:a="http://schemas.openxmlformats.org/drawingml/2006/main" xmlns:r="http://schemas.openxmlformats.org/officeDocument/2006/relationships" xmlns:p="http://schemas.openxmlformats.org/presentationml/2006/main">
   <p:cSld>
     <p:spTree>
@@ -1273,7 +1621,7 @@
 </p:notes>
 </file>
 
-<file path=ppt/notesSlides/notesSlide14.xml><?xml version="1.0" encoding="utf-8"?>
+<file path=ppt/notesSlides/notesSlide15.xml><?xml version="1.0" encoding="utf-8"?>
 <p:notes xmlns:a="http://schemas.openxmlformats.org/drawingml/2006/main" xmlns:r="http://schemas.openxmlformats.org/officeDocument/2006/relationships" xmlns:p="http://schemas.openxmlformats.org/presentationml/2006/main">
   <p:cSld>
     <p:spTree>
@@ -1550,7 +1898,7 @@
 </p:notes>
 </file>
 
-<file path=ppt/notesSlides/notesSlide15.xml><?xml version="1.0" encoding="utf-8"?>
+<file path=ppt/notesSlides/notesSlide16.xml><?xml version="1.0" encoding="utf-8"?>
 <p:notes xmlns:a="http://schemas.openxmlformats.org/drawingml/2006/main" xmlns:r="http://schemas.openxmlformats.org/officeDocument/2006/relationships" xmlns:p="http://schemas.openxmlformats.org/presentationml/2006/main">
   <p:cSld>
     <p:spTree>
@@ -1721,7 +2069,7 @@
 </p:notes>
 </file>
 
-<file path=ppt/notesSlides/notesSlide16.xml><?xml version="1.0" encoding="utf-8"?>
+<file path=ppt/notesSlides/notesSlide17.xml><?xml version="1.0" encoding="utf-8"?>
 <p:notes xmlns:a="http://schemas.openxmlformats.org/drawingml/2006/main" xmlns:r="http://schemas.openxmlformats.org/officeDocument/2006/relationships" xmlns:p="http://schemas.openxmlformats.org/presentationml/2006/main">
   <p:cSld>
     <p:spTree>
@@ -1892,7 +2240,7 @@
 </p:notes>
 </file>
 
-<file path=ppt/notesSlides/notesSlide17.xml><?xml version="1.0" encoding="utf-8"?>
+<file path=ppt/notesSlides/notesSlide18.xml><?xml version="1.0" encoding="utf-8"?>
 <p:notes xmlns:a="http://schemas.openxmlformats.org/drawingml/2006/main" xmlns:r="http://schemas.openxmlformats.org/officeDocument/2006/relationships" xmlns:p="http://schemas.openxmlformats.org/presentationml/2006/main">
   <p:cSld>
     <p:spTree>
@@ -2286,7 +2634,58 @@
               </a:rPr>
               <a:t>data processing.</a:t>
             </a:r>
-            <a:endParaRPr lang="en-AT" dirty="0"/>
+          </a:p>
+          <a:p>
+            <a:endParaRPr lang="en-GB" sz="1200" b="1" i="0" kern="1200" dirty="0">
+              <a:solidFill>
+                <a:schemeClr val="tx1"/>
+              </a:solidFill>
+              <a:effectLst/>
+              <a:latin typeface="+mn-lt"/>
+              <a:ea typeface="+mn-ea"/>
+              <a:cs typeface="+mn-cs"/>
+            </a:endParaRPr>
+          </a:p>
+          <a:p>
+            <a:r>
+              <a:rPr lang="en-GB" sz="1200" b="0" i="0" kern="1200" dirty="0" err="1">
+                <a:solidFill>
+                  <a:schemeClr val="tx1"/>
+                </a:solidFill>
+                <a:effectLst/>
+                <a:latin typeface="+mn-lt"/>
+                <a:ea typeface="+mn-ea"/>
+                <a:cs typeface="+mn-cs"/>
+              </a:rPr>
+              <a:t>Stuctured</a:t>
+            </a:r>
+            <a:r>
+              <a:rPr lang="en-GB" sz="1200" b="0" i="0" kern="1200" dirty="0">
+                <a:solidFill>
+                  <a:schemeClr val="tx1"/>
+                </a:solidFill>
+                <a:effectLst/>
+                <a:latin typeface="+mn-lt"/>
+                <a:ea typeface="+mn-ea"/>
+                <a:cs typeface="+mn-cs"/>
+              </a:rPr>
+              <a:t> Data: is data that follows fixed format an can be organized into rows</a:t>
+            </a:r>
+          </a:p>
+          <a:p>
+            <a:r>
+              <a:rPr lang="en-GB" sz="1200" b="0" i="0" kern="1200" dirty="0">
+                <a:solidFill>
+                  <a:schemeClr val="tx1"/>
+                </a:solidFill>
+                <a:effectLst/>
+                <a:latin typeface="+mn-lt"/>
+                <a:ea typeface="+mn-ea"/>
+                <a:cs typeface="+mn-cs"/>
+              </a:rPr>
+              <a:t>Unstructured data: has no fixed format or schema like email text, log files, documents ,. …</a:t>
+            </a:r>
+            <a:endParaRPr lang="en-AT" b="0" dirty="0"/>
           </a:p>
         </p:txBody>
       </p:sp>
@@ -2501,6 +2900,93 @@
   <p:cSld>
     <p:spTree>
       <p:nvGrpSpPr>
+        <p:cNvPr id="1" name=""/>
+        <p:cNvGrpSpPr/>
+        <p:nvPr/>
+      </p:nvGrpSpPr>
+      <p:grpSpPr>
+        <a:xfrm>
+          <a:off x="0" y="0"/>
+          <a:ext cx="0" cy="0"/>
+          <a:chOff x="0" y="0"/>
+          <a:chExt cx="0" cy="0"/>
+        </a:xfrm>
+      </p:grpSpPr>
+      <p:sp>
+        <p:nvSpPr>
+          <p:cNvPr id="2" name="Slide Image Placeholder 1"/>
+          <p:cNvSpPr>
+            <a:spLocks noGrp="1" noRot="1" noChangeAspect="1"/>
+          </p:cNvSpPr>
+          <p:nvPr>
+            <p:ph type="sldImg"/>
+          </p:nvPr>
+        </p:nvSpPr>
+        <p:spPr/>
+      </p:sp>
+      <p:sp>
+        <p:nvSpPr>
+          <p:cNvPr id="3" name="Notes Placeholder 2"/>
+          <p:cNvSpPr>
+            <a:spLocks noGrp="1"/>
+          </p:cNvSpPr>
+          <p:nvPr>
+            <p:ph type="body" idx="1"/>
+          </p:nvPr>
+        </p:nvSpPr>
+        <p:spPr/>
+        <p:txBody>
+          <a:bodyPr/>
+          <a:lstStyle/>
+          <a:p>
+            <a:r>
+              <a:rPr lang="en-AT" dirty="0"/>
+              <a:t>Documents are indexed across one ore more shards. Each shard is itself a fully functional index</a:t>
+            </a:r>
+          </a:p>
+        </p:txBody>
+      </p:sp>
+      <p:sp>
+        <p:nvSpPr>
+          <p:cNvPr id="4" name="Slide Number Placeholder 3"/>
+          <p:cNvSpPr>
+            <a:spLocks noGrp="1"/>
+          </p:cNvSpPr>
+          <p:nvPr>
+            <p:ph type="sldNum" sz="quarter" idx="5"/>
+          </p:nvPr>
+        </p:nvSpPr>
+        <p:spPr/>
+        <p:txBody>
+          <a:bodyPr/>
+          <a:lstStyle/>
+          <a:p>
+            <a:fld id="{C9565C50-69E9-8E49-A3AB-C69605F3BCD6}" type="slidenum">
+              <a:rPr lang="en-AT" smtClean="0"/>
+              <a:t>6</a:t>
+            </a:fld>
+            <a:endParaRPr lang="en-AT"/>
+          </a:p>
+        </p:txBody>
+      </p:sp>
+    </p:spTree>
+    <p:extLst>
+      <p:ext uri="{BB962C8B-B14F-4D97-AF65-F5344CB8AC3E}">
+        <p14:creationId xmlns:p14="http://schemas.microsoft.com/office/powerpoint/2010/main" val="3036585638"/>
+      </p:ext>
+    </p:extLst>
+  </p:cSld>
+  <p:clrMapOvr>
+    <a:masterClrMapping/>
+  </p:clrMapOvr>
+</p:notes>
+</file>
+
+<file path=ppt/notesSlides/notesSlide6.xml><?xml version="1.0" encoding="utf-8"?>
+<p:notes xmlns:a="http://schemas.openxmlformats.org/drawingml/2006/main" xmlns:r="http://schemas.openxmlformats.org/officeDocument/2006/relationships" xmlns:p="http://schemas.openxmlformats.org/presentationml/2006/main">
+  <p:cSld>
+    <p:spTree>
+      <p:nvGrpSpPr>
         <p:cNvPr id="1" name="">
           <a:extLst>
             <a:ext uri="{FF2B5EF4-FFF2-40B4-BE49-F238E27FC236}">
@@ -2939,7 +3425,7 @@
 </p:notes>
 </file>
 
-<file path=ppt/notesSlides/notesSlide6.xml><?xml version="1.0" encoding="utf-8"?>
+<file path=ppt/notesSlides/notesSlide7.xml><?xml version="1.0" encoding="utf-8"?>
 <p:notes xmlns:a="http://schemas.openxmlformats.org/drawingml/2006/main" xmlns:r="http://schemas.openxmlformats.org/officeDocument/2006/relationships" xmlns:p="http://schemas.openxmlformats.org/presentationml/2006/main">
   <p:cSld>
     <p:spTree>
@@ -3019,7 +3505,7 @@
               <a:defRPr/>
             </a:pPr>
             <a:r>
-              <a:rPr lang="en-GB" sz="1200" b="0" i="0" kern="1200" dirty="0">
+              <a:rPr lang="en-GB" sz="1200" b="0" i="0" u="none" strike="noStrike" kern="1200" dirty="0">
                 <a:solidFill>
                   <a:schemeClr val="tx1"/>
                 </a:solidFill>
@@ -3028,32 +3514,17 @@
                 <a:ea typeface="+mn-ea"/>
                 <a:cs typeface="+mn-cs"/>
               </a:rPr>
-              <a:t>Analyse then tokenize and </a:t>
-            </a:r>
-            <a:r>
-              <a:rPr lang="en-GB" sz="1200" b="0" i="0" kern="1200" dirty="0" err="1">
-                <a:solidFill>
-                  <a:schemeClr val="tx1"/>
-                </a:solidFill>
-                <a:effectLst/>
-                <a:latin typeface="+mn-lt"/>
-                <a:ea typeface="+mn-ea"/>
-                <a:cs typeface="+mn-cs"/>
-              </a:rPr>
-              <a:t>thte</a:t>
-            </a:r>
-            <a:r>
-              <a:rPr lang="en-GB" sz="1200" b="0" i="0" kern="1200" dirty="0">
-                <a:solidFill>
-                  <a:schemeClr val="tx1"/>
-                </a:solidFill>
-                <a:effectLst/>
-                <a:latin typeface="+mn-lt"/>
-                <a:ea typeface="+mn-ea"/>
-                <a:cs typeface="+mn-cs"/>
-              </a:rPr>
-              <a:t> inverted index</a:t>
-            </a:r>
+              <a:t>Data is ingested into Elasticsearch through the indexing process</a:t>
+            </a:r>
+            <a:endParaRPr lang="en-GB" sz="1200" b="0" i="0" kern="1200" dirty="0">
+              <a:solidFill>
+                <a:schemeClr val="tx1"/>
+              </a:solidFill>
+              <a:effectLst/>
+              <a:latin typeface="+mn-lt"/>
+              <a:ea typeface="+mn-ea"/>
+              <a:cs typeface="+mn-cs"/>
+            </a:endParaRPr>
           </a:p>
           <a:p>
             <a:pPr marL="0" marR="0" lvl="0" indent="0" algn="l" defTabSz="914400" rtl="0" eaLnBrk="1" fontAlgn="auto" latinLnBrk="0" hangingPunct="1">
@@ -3074,6 +3545,61 @@
               <a:defRPr/>
             </a:pPr>
             <a:r>
+              <a:rPr lang="en-GB" sz="1200" b="0" i="0" kern="1200" dirty="0">
+                <a:solidFill>
+                  <a:schemeClr val="tx1"/>
+                </a:solidFill>
+                <a:effectLst/>
+                <a:latin typeface="+mn-lt"/>
+                <a:ea typeface="+mn-ea"/>
+                <a:cs typeface="+mn-cs"/>
+              </a:rPr>
+              <a:t>Analyse then tokenize and </a:t>
+            </a:r>
+            <a:r>
+              <a:rPr lang="en-GB" sz="1200" b="0" i="0" kern="1200" dirty="0" err="1">
+                <a:solidFill>
+                  <a:schemeClr val="tx1"/>
+                </a:solidFill>
+                <a:effectLst/>
+                <a:latin typeface="+mn-lt"/>
+                <a:ea typeface="+mn-ea"/>
+                <a:cs typeface="+mn-cs"/>
+              </a:rPr>
+              <a:t>thte</a:t>
+            </a:r>
+            <a:r>
+              <a:rPr lang="en-GB" sz="1200" b="0" i="0" kern="1200" dirty="0">
+                <a:solidFill>
+                  <a:schemeClr val="tx1"/>
+                </a:solidFill>
+                <a:effectLst/>
+                <a:latin typeface="+mn-lt"/>
+                <a:ea typeface="+mn-ea"/>
+                <a:cs typeface="+mn-cs"/>
+              </a:rPr>
+              <a:t> inverted index</a:t>
+            </a:r>
+          </a:p>
+          <a:p>
+            <a:pPr marL="0" marR="0" lvl="0" indent="0" algn="l" defTabSz="914400" rtl="0" eaLnBrk="1" fontAlgn="auto" latinLnBrk="0" hangingPunct="1">
+              <a:lnSpc>
+                <a:spcPct val="100000"/>
+              </a:lnSpc>
+              <a:spcBef>
+                <a:spcPts val="0"/>
+              </a:spcBef>
+              <a:spcAft>
+                <a:spcPts val="0"/>
+              </a:spcAft>
+              <a:buClrTx/>
+              <a:buSzTx/>
+              <a:buFontTx/>
+              <a:buNone/>
+              <a:tabLst/>
+              <a:defRPr/>
+            </a:pPr>
+            <a:r>
               <a:rPr lang="en-GB" sz="1200" b="0" i="0" kern="1200" dirty="0" err="1">
                 <a:solidFill>
                   <a:schemeClr val="tx1"/>
@@ -3169,7 +3695,7 @@
 </p:notes>
 </file>
 
-<file path=ppt/notesSlides/notesSlide7.xml><?xml version="1.0" encoding="utf-8"?>
+<file path=ppt/notesSlides/notesSlide8.xml><?xml version="1.0" encoding="utf-8"?>
 <p:notes xmlns:a="http://schemas.openxmlformats.org/drawingml/2006/main" xmlns:r="http://schemas.openxmlformats.org/officeDocument/2006/relationships" xmlns:p="http://schemas.openxmlformats.org/presentationml/2006/main">
   <p:cSld>
     <p:spTree>
@@ -3542,7 +4068,7 @@
 </p:notes>
 </file>
 
-<file path=ppt/notesSlides/notesSlide8.xml><?xml version="1.0" encoding="utf-8"?>
+<file path=ppt/notesSlides/notesSlide9.xml><?xml version="1.0" encoding="utf-8"?>
 <p:notes xmlns:a="http://schemas.openxmlformats.org/drawingml/2006/main" xmlns:r="http://schemas.openxmlformats.org/officeDocument/2006/relationships" xmlns:p="http://schemas.openxmlformats.org/presentationml/2006/main">
   <p:cSld>
     <p:spTree>
@@ -3698,354 +4224,6 @@
     <p:extLst>
       <p:ext uri="{BB962C8B-B14F-4D97-AF65-F5344CB8AC3E}">
         <p14:creationId xmlns:p14="http://schemas.microsoft.com/office/powerpoint/2010/main" val="3738663906"/>
-      </p:ext>
-    </p:extLst>
-  </p:cSld>
-  <p:clrMapOvr>
-    <a:masterClrMapping/>
-  </p:clrMapOvr>
-</p:notes>
-</file>
-
-<file path=ppt/notesSlides/notesSlide9.xml><?xml version="1.0" encoding="utf-8"?>
-<p:notes xmlns:a="http://schemas.openxmlformats.org/drawingml/2006/main" xmlns:r="http://schemas.openxmlformats.org/officeDocument/2006/relationships" xmlns:p="http://schemas.openxmlformats.org/presentationml/2006/main">
-  <p:cSld>
-    <p:spTree>
-      <p:nvGrpSpPr>
-        <p:cNvPr id="1" name="">
-          <a:extLst>
-            <a:ext uri="{FF2B5EF4-FFF2-40B4-BE49-F238E27FC236}">
-              <a16:creationId xmlns:a16="http://schemas.microsoft.com/office/drawing/2014/main" id="{80C31299-0189-2C8D-89C9-3D8511124EBF}"/>
-            </a:ext>
-          </a:extLst>
-        </p:cNvPr>
-        <p:cNvGrpSpPr/>
-        <p:nvPr/>
-      </p:nvGrpSpPr>
-      <p:grpSpPr>
-        <a:xfrm>
-          <a:off x="0" y="0"/>
-          <a:ext cx="0" cy="0"/>
-          <a:chOff x="0" y="0"/>
-          <a:chExt cx="0" cy="0"/>
-        </a:xfrm>
-      </p:grpSpPr>
-      <p:sp>
-        <p:nvSpPr>
-          <p:cNvPr id="2" name="Slide Image Placeholder 1">
-            <a:extLst>
-              <a:ext uri="{FF2B5EF4-FFF2-40B4-BE49-F238E27FC236}">
-                <a16:creationId xmlns:a16="http://schemas.microsoft.com/office/drawing/2014/main" id="{15C92200-DEAD-57C0-C50B-49670743F495}"/>
-              </a:ext>
-            </a:extLst>
-          </p:cNvPr>
-          <p:cNvSpPr>
-            <a:spLocks noGrp="1" noRot="1" noChangeAspect="1"/>
-          </p:cNvSpPr>
-          <p:nvPr>
-            <p:ph type="sldImg"/>
-          </p:nvPr>
-        </p:nvSpPr>
-        <p:spPr/>
-      </p:sp>
-      <p:sp>
-        <p:nvSpPr>
-          <p:cNvPr id="3" name="Notes Placeholder 2">
-            <a:extLst>
-              <a:ext uri="{FF2B5EF4-FFF2-40B4-BE49-F238E27FC236}">
-                <a16:creationId xmlns:a16="http://schemas.microsoft.com/office/drawing/2014/main" id="{06A77AEE-0601-35AB-C699-AC10D553513D}"/>
-              </a:ext>
-            </a:extLst>
-          </p:cNvPr>
-          <p:cNvSpPr>
-            <a:spLocks noGrp="1"/>
-          </p:cNvSpPr>
-          <p:nvPr>
-            <p:ph type="body" idx="1"/>
-          </p:nvPr>
-        </p:nvSpPr>
-        <p:spPr/>
-        <p:txBody>
-          <a:bodyPr/>
-          <a:lstStyle/>
-          <a:p>
-            <a:pPr marL="0" marR="0" lvl="0" indent="0" algn="l" defTabSz="914400" rtl="0" eaLnBrk="1" fontAlgn="auto" latinLnBrk="0" hangingPunct="1">
-              <a:lnSpc>
-                <a:spcPct val="100000"/>
-              </a:lnSpc>
-              <a:spcBef>
-                <a:spcPts val="0"/>
-              </a:spcBef>
-              <a:spcAft>
-                <a:spcPts val="0"/>
-              </a:spcAft>
-              <a:buClrTx/>
-              <a:buSzTx/>
-              <a:buFontTx/>
-              <a:buNone/>
-              <a:tabLst/>
-              <a:defRPr/>
-            </a:pPr>
-            <a:r>
-              <a:rPr lang="en-GB" sz="1200" b="0" i="0" kern="1200" dirty="0">
-                <a:solidFill>
-                  <a:schemeClr val="tx1"/>
-                </a:solidFill>
-                <a:effectLst/>
-                <a:latin typeface="+mn-lt"/>
-                <a:ea typeface="+mn-ea"/>
-                <a:cs typeface="+mn-cs"/>
-              </a:rPr>
-              <a:t>GET -&gt; HTTP Methode +index name + endpoint</a:t>
-            </a:r>
-          </a:p>
-          <a:p>
-            <a:pPr marL="0" marR="0" lvl="0" indent="0" algn="l" defTabSz="914400" rtl="0" eaLnBrk="1" fontAlgn="auto" latinLnBrk="0" hangingPunct="1">
-              <a:lnSpc>
-                <a:spcPct val="100000"/>
-              </a:lnSpc>
-              <a:spcBef>
-                <a:spcPts val="0"/>
-              </a:spcBef>
-              <a:spcAft>
-                <a:spcPts val="0"/>
-              </a:spcAft>
-              <a:buClrTx/>
-              <a:buSzTx/>
-              <a:buFontTx/>
-              <a:buNone/>
-              <a:tabLst/>
-              <a:defRPr/>
-            </a:pPr>
-            <a:r>
-              <a:rPr lang="en-GB" sz="1200" b="0" i="0" kern="1200" dirty="0">
-                <a:solidFill>
-                  <a:schemeClr val="tx1"/>
-                </a:solidFill>
-                <a:effectLst/>
-                <a:latin typeface="+mn-lt"/>
-                <a:ea typeface="+mn-ea"/>
-                <a:cs typeface="+mn-cs"/>
-              </a:rPr>
-              <a:t>Query -&gt; </a:t>
-            </a:r>
-            <a:r>
-              <a:rPr lang="en-GB" sz="1200" b="0" i="0" kern="1200" dirty="0" err="1">
-                <a:solidFill>
-                  <a:schemeClr val="tx1"/>
-                </a:solidFill>
-                <a:effectLst/>
-                <a:latin typeface="+mn-lt"/>
-                <a:ea typeface="+mn-ea"/>
-                <a:cs typeface="+mn-cs"/>
-              </a:rPr>
-              <a:t>QueryDSL</a:t>
-            </a:r>
-            <a:r>
-              <a:rPr lang="en-GB" sz="1200" b="0" i="0" kern="1200" dirty="0">
-                <a:solidFill>
-                  <a:schemeClr val="tx1"/>
-                </a:solidFill>
-                <a:effectLst/>
-                <a:latin typeface="+mn-lt"/>
-                <a:ea typeface="+mn-ea"/>
-                <a:cs typeface="+mn-cs"/>
-              </a:rPr>
-              <a:t> Body</a:t>
-            </a:r>
-          </a:p>
-          <a:p>
-            <a:pPr marL="0" marR="0" lvl="0" indent="0" algn="l" defTabSz="914400" rtl="0" eaLnBrk="1" fontAlgn="auto" latinLnBrk="0" hangingPunct="1">
-              <a:lnSpc>
-                <a:spcPct val="100000"/>
-              </a:lnSpc>
-              <a:spcBef>
-                <a:spcPts val="0"/>
-              </a:spcBef>
-              <a:spcAft>
-                <a:spcPts val="0"/>
-              </a:spcAft>
-              <a:buClrTx/>
-              <a:buSzTx/>
-              <a:buFontTx/>
-              <a:buNone/>
-              <a:tabLst/>
-              <a:defRPr/>
-            </a:pPr>
-            <a:r>
-              <a:rPr lang="en-GB" sz="1200" b="0" i="0" kern="1200" dirty="0">
-                <a:solidFill>
-                  <a:schemeClr val="tx1"/>
-                </a:solidFill>
-                <a:effectLst/>
-                <a:latin typeface="+mn-lt"/>
-                <a:ea typeface="+mn-ea"/>
-                <a:cs typeface="+mn-cs"/>
-              </a:rPr>
-              <a:t>Match-&gt; </a:t>
-            </a:r>
-            <a:r>
-              <a:rPr lang="en-GB" sz="1200" b="0" i="0" u="none" strike="noStrike" kern="1200" dirty="0">
-                <a:solidFill>
-                  <a:schemeClr val="tx1"/>
-                </a:solidFill>
-                <a:effectLst/>
-                <a:latin typeface="+mn-lt"/>
-                <a:ea typeface="+mn-ea"/>
-                <a:cs typeface="+mn-cs"/>
-              </a:rPr>
-              <a:t>Query type: full-text search</a:t>
-            </a:r>
-          </a:p>
-          <a:p>
-            <a:pPr marL="0" marR="0" lvl="0" indent="0" algn="l" defTabSz="914400" rtl="0" eaLnBrk="1" fontAlgn="auto" latinLnBrk="0" hangingPunct="1">
-              <a:lnSpc>
-                <a:spcPct val="100000"/>
-              </a:lnSpc>
-              <a:spcBef>
-                <a:spcPts val="0"/>
-              </a:spcBef>
-              <a:spcAft>
-                <a:spcPts val="0"/>
-              </a:spcAft>
-              <a:buClrTx/>
-              <a:buSzTx/>
-              <a:buFontTx/>
-              <a:buNone/>
-              <a:tabLst/>
-              <a:defRPr/>
-            </a:pPr>
-            <a:r>
-              <a:rPr lang="en-GB" sz="1200" b="0" i="0" u="none" strike="noStrike" kern="1200" dirty="0">
-                <a:solidFill>
-                  <a:schemeClr val="tx1"/>
-                </a:solidFill>
-                <a:effectLst/>
-                <a:latin typeface="+mn-lt"/>
-                <a:ea typeface="+mn-ea"/>
-                <a:cs typeface="+mn-cs"/>
-              </a:rPr>
-              <a:t>field: search value</a:t>
-            </a:r>
-            <a:br>
-              <a:rPr lang="en-GB" sz="1200" b="0" i="0" u="none" strike="noStrike" kern="1200" dirty="0">
-                <a:solidFill>
-                  <a:schemeClr val="tx1"/>
-                </a:solidFill>
-                <a:effectLst/>
-                <a:latin typeface="+mn-lt"/>
-                <a:ea typeface="+mn-ea"/>
-                <a:cs typeface="+mn-cs"/>
-              </a:rPr>
-            </a:br>
-            <a:br>
-              <a:rPr lang="en-GB" sz="1200" b="0" i="0" u="none" strike="noStrike" kern="1200" dirty="0">
-                <a:solidFill>
-                  <a:schemeClr val="tx1"/>
-                </a:solidFill>
-                <a:effectLst/>
-                <a:latin typeface="+mn-lt"/>
-                <a:ea typeface="+mn-ea"/>
-                <a:cs typeface="+mn-cs"/>
-              </a:rPr>
-            </a:br>
-            <a:r>
-              <a:rPr lang="en-GB" sz="1200" b="0" i="0" u="none" strike="noStrike" kern="1200" dirty="0">
-                <a:solidFill>
-                  <a:schemeClr val="tx1"/>
-                </a:solidFill>
-                <a:effectLst/>
-                <a:latin typeface="+mn-lt"/>
-                <a:ea typeface="+mn-ea"/>
-                <a:cs typeface="+mn-cs"/>
-              </a:rPr>
-              <a:t>Query get all documents of driver results where the </a:t>
-            </a:r>
-            <a:r>
-              <a:rPr lang="en-GB" sz="1200" b="0" i="0" u="none" strike="noStrike" kern="1200" dirty="0" err="1">
-                <a:solidFill>
-                  <a:schemeClr val="tx1"/>
-                </a:solidFill>
-                <a:effectLst/>
-                <a:latin typeface="+mn-lt"/>
-                <a:ea typeface="+mn-ea"/>
-                <a:cs typeface="+mn-cs"/>
-              </a:rPr>
-              <a:t>race_name</a:t>
-            </a:r>
-            <a:r>
-              <a:rPr lang="en-GB" sz="1200" b="0" i="0" u="none" strike="noStrike" kern="1200" dirty="0">
-                <a:solidFill>
-                  <a:schemeClr val="tx1"/>
-                </a:solidFill>
-                <a:effectLst/>
-                <a:latin typeface="+mn-lt"/>
-                <a:ea typeface="+mn-ea"/>
-                <a:cs typeface="+mn-cs"/>
-              </a:rPr>
-              <a:t> is </a:t>
-            </a:r>
-            <a:r>
-              <a:rPr lang="en-GB" sz="1200" b="0" i="0" u="none" strike="noStrike" kern="1200" dirty="0" err="1">
-                <a:solidFill>
-                  <a:schemeClr val="tx1"/>
-                </a:solidFill>
-                <a:effectLst/>
-                <a:latin typeface="+mn-lt"/>
-                <a:ea typeface="+mn-ea"/>
-                <a:cs typeface="+mn-cs"/>
-              </a:rPr>
-              <a:t>monaco</a:t>
-            </a:r>
-            <a:r>
-              <a:rPr lang="en-GB" sz="1200" b="0" i="0" u="none" strike="noStrike" kern="1200" dirty="0">
-                <a:solidFill>
-                  <a:schemeClr val="tx1"/>
-                </a:solidFill>
-                <a:effectLst/>
-                <a:latin typeface="+mn-lt"/>
-                <a:ea typeface="+mn-ea"/>
-                <a:cs typeface="+mn-cs"/>
-              </a:rPr>
-              <a:t> </a:t>
-            </a:r>
-            <a:endParaRPr lang="en-AT" dirty="0"/>
-          </a:p>
-        </p:txBody>
-      </p:sp>
-      <p:sp>
-        <p:nvSpPr>
-          <p:cNvPr id="4" name="Slide Number Placeholder 3">
-            <a:extLst>
-              <a:ext uri="{FF2B5EF4-FFF2-40B4-BE49-F238E27FC236}">
-                <a16:creationId xmlns:a16="http://schemas.microsoft.com/office/drawing/2014/main" id="{74D0EEC9-47A7-F691-D36B-5BF05A027F0F}"/>
-              </a:ext>
-            </a:extLst>
-          </p:cNvPr>
-          <p:cNvSpPr>
-            <a:spLocks noGrp="1"/>
-          </p:cNvSpPr>
-          <p:nvPr>
-            <p:ph type="sldNum" sz="quarter" idx="5"/>
-          </p:nvPr>
-        </p:nvSpPr>
-        <p:spPr/>
-        <p:txBody>
-          <a:bodyPr/>
-          <a:lstStyle/>
-          <a:p>
-            <a:fld id="{C9565C50-69E9-8E49-A3AB-C69605F3BCD6}" type="slidenum">
-              <a:rPr lang="en-AT" smtClean="0"/>
-              <a:t>11</a:t>
-            </a:fld>
-            <a:endParaRPr lang="en-AT"/>
-          </a:p>
-        </p:txBody>
-      </p:sp>
-    </p:spTree>
-    <p:extLst>
-      <p:ext uri="{BB962C8B-B14F-4D97-AF65-F5344CB8AC3E}">
-        <p14:creationId xmlns:p14="http://schemas.microsoft.com/office/powerpoint/2010/main" val="602234647"/>
       </p:ext>
     </p:extLst>
   </p:cSld>
@@ -4204,7 +4382,7 @@
           <a:p>
             <a:fld id="{A591BDEC-81C3-DB48-92B3-4E74693DD55D}" type="datetimeFigureOut">
               <a:rPr lang="en-AT" smtClean="0"/>
-              <a:t>11.05.26</a:t>
+              <a:t>15.05.26</a:t>
             </a:fld>
             <a:endParaRPr lang="en-AT"/>
           </a:p>
@@ -4869,7 +5047,7 @@
           <a:p>
             <a:fld id="{A591BDEC-81C3-DB48-92B3-4E74693DD55D}" type="datetimeFigureOut">
               <a:rPr lang="en-AT" smtClean="0"/>
-              <a:t>11.05.26</a:t>
+              <a:t>15.05.26</a:t>
             </a:fld>
             <a:endParaRPr lang="en-AT"/>
           </a:p>
@@ -5079,7 +5257,7 @@
           <a:p>
             <a:fld id="{A591BDEC-81C3-DB48-92B3-4E74693DD55D}" type="datetimeFigureOut">
               <a:rPr lang="en-AT" smtClean="0"/>
-              <a:t>11.05.26</a:t>
+              <a:t>15.05.26</a:t>
             </a:fld>
             <a:endParaRPr lang="en-AT"/>
           </a:p>
@@ -5280,7 +5458,7 @@
             <a:fld id="{2C923EFC-C784-AC46-AE3C-8E1B6BCAD649}" type="datetime1">
               <a:rPr lang="en-US" smtClean="0"/>
               <a:pPr/>
-              <a:t>5/11/26</a:t>
+              <a:t>5/15/26</a:t>
             </a:fld>
             <a:endParaRPr lang="en-AT" dirty="0"/>
           </a:p>
@@ -6288,7 +6466,7 @@
           <a:p>
             <a:fld id="{A591BDEC-81C3-DB48-92B3-4E74693DD55D}" type="datetimeFigureOut">
               <a:rPr lang="en-AT" smtClean="0"/>
-              <a:t>11.05.26</a:t>
+              <a:t>15.05.26</a:t>
             </a:fld>
             <a:endParaRPr lang="en-AT"/>
           </a:p>
@@ -7021,7 +7199,7 @@
           <a:p>
             <a:fld id="{A591BDEC-81C3-DB48-92B3-4E74693DD55D}" type="datetimeFigureOut">
               <a:rPr lang="en-AT" smtClean="0"/>
-              <a:t>11.05.26</a:t>
+              <a:t>15.05.26</a:t>
             </a:fld>
             <a:endParaRPr lang="en-AT"/>
           </a:p>
@@ -8168,7 +8346,7 @@
           <a:p>
             <a:fld id="{A591BDEC-81C3-DB48-92B3-4E74693DD55D}" type="datetimeFigureOut">
               <a:rPr lang="en-AT" smtClean="0"/>
-              <a:t>11.05.26</a:t>
+              <a:t>15.05.26</a:t>
             </a:fld>
             <a:endParaRPr lang="en-AT"/>
           </a:p>
@@ -9042,7 +9220,7 @@
           <a:p>
             <a:fld id="{A591BDEC-81C3-DB48-92B3-4E74693DD55D}" type="datetimeFigureOut">
               <a:rPr lang="en-AT" smtClean="0"/>
-              <a:t>11.05.26</a:t>
+              <a:t>15.05.26</a:t>
             </a:fld>
             <a:endParaRPr lang="en-AT"/>
           </a:p>
@@ -9887,7 +10065,7 @@
           <a:p>
             <a:fld id="{A591BDEC-81C3-DB48-92B3-4E74693DD55D}" type="datetimeFigureOut">
               <a:rPr lang="en-AT" smtClean="0"/>
-              <a:t>11.05.26</a:t>
+              <a:t>15.05.26</a:t>
             </a:fld>
             <a:endParaRPr lang="en-AT"/>
           </a:p>
@@ -10932,7 +11110,7 @@
           <a:p>
             <a:fld id="{A591BDEC-81C3-DB48-92B3-4E74693DD55D}" type="datetimeFigureOut">
               <a:rPr lang="en-AT" smtClean="0"/>
-              <a:t>11.05.26</a:t>
+              <a:t>15.05.26</a:t>
             </a:fld>
             <a:endParaRPr lang="en-AT"/>
           </a:p>
@@ -11686,7 +11864,7 @@
           <a:p>
             <a:fld id="{A591BDEC-81C3-DB48-92B3-4E74693DD55D}" type="datetimeFigureOut">
               <a:rPr lang="en-AT" smtClean="0"/>
-              <a:t>11.05.26</a:t>
+              <a:t>15.05.26</a:t>
             </a:fld>
             <a:endParaRPr lang="en-AT"/>
           </a:p>
@@ -12358,7 +12536,7 @@
           <a:p>
             <a:fld id="{A591BDEC-81C3-DB48-92B3-4E74693DD55D}" type="datetimeFigureOut">
               <a:rPr lang="en-AT" smtClean="0"/>
-              <a:t>11.05.26</a:t>
+              <a:t>15.05.26</a:t>
             </a:fld>
             <a:endParaRPr lang="en-AT"/>
           </a:p>
@@ -12899,7 +13077,7 @@
           <a:p>
             <a:fld id="{343E18A4-A905-2445-944B-CEA2A38DE8BE}" type="datetime4">
               <a:rPr lang="en-AT" sz="1600"/>
-              <a:t>11. May 2026</a:t>
+              <a:t>15. May 2026</a:t>
             </a:fld>
             <a:endParaRPr lang="en-AT" sz="1600" dirty="0"/>
           </a:p>
@@ -13673,7 +13851,7 @@
             </a:pPr>
             <a:r>
               <a:rPr lang="en-AT" dirty="0"/>
-              <a:t>Complexe Setup</a:t>
+              <a:t>Complex Setup</a:t>
             </a:r>
           </a:p>
           <a:p>
@@ -14437,22 +14615,9 @@
           </a:p>
           <a:p>
             <a:r>
-              <a:rPr lang="de-AT" dirty="0"/>
-              <a:t>Dashboard </a:t>
-            </a:r>
-            <a:r>
-              <a:rPr lang="de-AT" dirty="0" err="1"/>
-              <a:t>for</a:t>
-            </a:r>
-            <a:r>
-              <a:rPr lang="de-AT" dirty="0"/>
-              <a:t> </a:t>
-            </a:r>
-            <a:r>
-              <a:rPr lang="de-AT" dirty="0" err="1"/>
-              <a:t>visualization</a:t>
-            </a:r>
-            <a:endParaRPr lang="de-AT" dirty="0"/>
+              <a:rPr lang="en-GB" noProof="1"/>
+              <a:t>Dashboard for visualization</a:t>
+            </a:r>
           </a:p>
           <a:p>
             <a:pPr marL="514350" indent="-514350">
@@ -17323,7 +17488,7 @@
           <p:nvPr/>
         </p:nvPicPr>
         <p:blipFill>
-          <a:blip r:embed="rId2"/>
+          <a:blip r:embed="rId3"/>
           <a:stretch>
             <a:fillRect/>
           </a:stretch>
@@ -17425,7 +17590,7 @@
           <a:p>
             <a:r>
               <a:rPr lang="en-AT" dirty="0"/>
-              <a:t>Distributed and Scalable</a:t>
+              <a:t>Distributed and Scaleable</a:t>
             </a:r>
           </a:p>
           <a:p>

</xml_diff>

<commit_message>
fix typos in f1_dataset_inserter.py and reorganized presentation
</commit_message>
<xml_diff>
--- a/Elasticsearch.pptx
+++ b/Elasticsearch.pptx
@@ -3148,6 +3148,42 @@
               <a:defRPr/>
             </a:pPr>
             <a:r>
+              <a:rPr lang="en-GB" sz="1800" b="0" i="0" u="none" strike="noStrike" kern="1200" dirty="0">
+                <a:solidFill>
+                  <a:schemeClr val="tx1"/>
+                </a:solidFill>
+                <a:effectLst/>
+                <a:latin typeface="+mn-lt"/>
+                <a:ea typeface="+mn-ea"/>
+                <a:cs typeface="+mn-cs"/>
+              </a:rPr>
+              <a:t>Support real time indexing and </a:t>
+            </a:r>
+            <a:r>
+              <a:rPr lang="en-GB" sz="1800" b="0" i="0" u="none" strike="noStrike" kern="1200" dirty="0" err="1">
+                <a:solidFill>
+                  <a:schemeClr val="tx1"/>
+                </a:solidFill>
+                <a:effectLst/>
+                <a:latin typeface="+mn-lt"/>
+                <a:ea typeface="+mn-ea"/>
+                <a:cs typeface="+mn-cs"/>
+              </a:rPr>
+              <a:t>quering</a:t>
+            </a:r>
+            <a:r>
+              <a:rPr lang="en-GB" sz="1800" b="0" i="0" u="none" strike="noStrike" kern="1200" dirty="0">
+                <a:solidFill>
+                  <a:schemeClr val="tx1"/>
+                </a:solidFill>
+                <a:effectLst/>
+                <a:latin typeface="+mn-lt"/>
+                <a:ea typeface="+mn-ea"/>
+                <a:cs typeface="+mn-cs"/>
+              </a:rPr>
+              <a:t>, making it suitable for use cases that require up-to-date insights from continuously changing </a:t>
+            </a:r>
+            <a:r>
               <a:rPr lang="en-GB" sz="1200" b="0" i="0" u="none" strike="noStrike" kern="1200" dirty="0">
                 <a:solidFill>
                   <a:schemeClr val="tx1"/>
@@ -3157,31 +3193,7 @@
                 <a:ea typeface="+mn-ea"/>
                 <a:cs typeface="+mn-cs"/>
               </a:rPr>
-              <a:t>Support real time indexing and </a:t>
-            </a:r>
-            <a:r>
-              <a:rPr lang="en-GB" sz="1200" b="0" i="0" u="none" strike="noStrike" kern="1200" dirty="0" err="1">
-                <a:solidFill>
-                  <a:schemeClr val="tx1"/>
-                </a:solidFill>
-                <a:effectLst/>
-                <a:latin typeface="+mn-lt"/>
-                <a:ea typeface="+mn-ea"/>
-                <a:cs typeface="+mn-cs"/>
-              </a:rPr>
-              <a:t>quering</a:t>
-            </a:r>
-            <a:r>
-              <a:rPr lang="en-GB" sz="1200" b="0" i="0" u="none" strike="noStrike" kern="1200" dirty="0">
-                <a:solidFill>
-                  <a:schemeClr val="tx1"/>
-                </a:solidFill>
-                <a:effectLst/>
-                <a:latin typeface="+mn-lt"/>
-                <a:ea typeface="+mn-ea"/>
-                <a:cs typeface="+mn-cs"/>
-              </a:rPr>
-              <a:t>, making it suitable for use cases that require up-to-date insights from continuously changing data</a:t>
+              <a:t>data</a:t>
             </a:r>
           </a:p>
           <a:p>
@@ -13128,7 +13140,7 @@
 </file>
 
 <file path=ppt/slides/slide10.xml><?xml version="1.0" encoding="utf-8"?>
-<p:sld xmlns:a="http://schemas.openxmlformats.org/drawingml/2006/main" xmlns:r="http://schemas.openxmlformats.org/officeDocument/2006/relationships" xmlns:p="http://schemas.openxmlformats.org/presentationml/2006/main">
+<p:sld xmlns:a="http://schemas.openxmlformats.org/drawingml/2006/main" xmlns:r="http://schemas.openxmlformats.org/officeDocument/2006/relationships" xmlns:p="http://schemas.openxmlformats.org/presentationml/2006/main" show="0">
   <p:cSld>
     <p:spTree>
       <p:nvGrpSpPr>
@@ -13433,8 +13445,38 @@
         </p:blipFill>
         <p:spPr>
           <a:xfrm>
-            <a:off x="1010388" y="4267051"/>
-            <a:ext cx="3221369" cy="2400832"/>
+            <a:off x="254610" y="4500317"/>
+            <a:ext cx="2525914" cy="1882521"/>
+          </a:xfrm>
+          <a:prstGeom prst="rect">
+            <a:avLst/>
+          </a:prstGeom>
+        </p:spPr>
+      </p:pic>
+      <p:pic>
+        <p:nvPicPr>
+          <p:cNvPr id="4" name="Picture 3">
+            <a:extLst>
+              <a:ext uri="{FF2B5EF4-FFF2-40B4-BE49-F238E27FC236}">
+                <a16:creationId xmlns:a16="http://schemas.microsoft.com/office/drawing/2014/main" id="{8BAF6F75-D8EB-5097-4DA9-51FD066A5729}"/>
+              </a:ext>
+            </a:extLst>
+          </p:cNvPr>
+          <p:cNvPicPr>
+            <a:picLocks noChangeAspect="1"/>
+          </p:cNvPicPr>
+          <p:nvPr/>
+        </p:nvPicPr>
+        <p:blipFill>
+          <a:blip r:embed="rId4"/>
+          <a:stretch>
+            <a:fillRect/>
+          </a:stretch>
+        </p:blipFill>
+        <p:spPr>
+          <a:xfrm>
+            <a:off x="3183157" y="4410968"/>
+            <a:ext cx="5825686" cy="2081907"/>
           </a:xfrm>
           <a:prstGeom prst="rect">
             <a:avLst/>
@@ -18345,7 +18387,7 @@
 </file>
 
 <file path=ppt/slides/slide9.xml><?xml version="1.0" encoding="utf-8"?>
-<p:sld xmlns:a="http://schemas.openxmlformats.org/drawingml/2006/main" xmlns:r="http://schemas.openxmlformats.org/officeDocument/2006/relationships" xmlns:p="http://schemas.openxmlformats.org/presentationml/2006/main">
+<p:sld xmlns:a="http://schemas.openxmlformats.org/drawingml/2006/main" xmlns:r="http://schemas.openxmlformats.org/officeDocument/2006/relationships" xmlns:p="http://schemas.openxmlformats.org/presentationml/2006/main" show="0">
   <p:cSld>
     <p:spTree>
       <p:nvGrpSpPr>

</xml_diff>

<commit_message>
added content to Elasticsearch presentation
</commit_message>
<xml_diff>
--- a/Elasticsearch.pptx
+++ b/Elasticsearch.pptx
@@ -870,6 +870,256 @@
               </a:rPr>
               <a:t> </a:t>
             </a:r>
+          </a:p>
+          <a:p>
+            <a:pPr marL="0" marR="0" lvl="0" indent="0" algn="l" defTabSz="914400" rtl="0" eaLnBrk="1" fontAlgn="auto" latinLnBrk="0" hangingPunct="1">
+              <a:lnSpc>
+                <a:spcPct val="100000"/>
+              </a:lnSpc>
+              <a:spcBef>
+                <a:spcPts val="0"/>
+              </a:spcBef>
+              <a:spcAft>
+                <a:spcPts val="0"/>
+              </a:spcAft>
+              <a:buClrTx/>
+              <a:buSzTx/>
+              <a:buFontTx/>
+              <a:buNone/>
+              <a:tabLst/>
+              <a:defRPr/>
+            </a:pPr>
+            <a:br>
+              <a:rPr lang="en-GB" sz="1200" b="0" i="0" u="none" strike="noStrike" kern="1200" dirty="0">
+                <a:solidFill>
+                  <a:schemeClr val="tx1"/>
+                </a:solidFill>
+                <a:effectLst/>
+                <a:latin typeface="+mn-lt"/>
+                <a:ea typeface="+mn-ea"/>
+                <a:cs typeface="+mn-cs"/>
+              </a:rPr>
+            </a:br>
+            <a:r>
+              <a:rPr lang="en-GB" sz="1200" b="1" i="0" kern="1200" dirty="0">
+                <a:solidFill>
+                  <a:schemeClr val="tx1"/>
+                </a:solidFill>
+                <a:effectLst/>
+                <a:latin typeface="+mn-lt"/>
+                <a:ea typeface="+mn-ea"/>
+                <a:cs typeface="+mn-cs"/>
+              </a:rPr>
+              <a:t>Match</a:t>
+            </a:r>
+            <a:r>
+              <a:rPr lang="en-GB" sz="1200" b="0" i="0" u="none" strike="noStrike" kern="1200" dirty="0">
+                <a:solidFill>
+                  <a:schemeClr val="tx1"/>
+                </a:solidFill>
+                <a:effectLst/>
+                <a:latin typeface="+mn-lt"/>
+                <a:ea typeface="+mn-ea"/>
+                <a:cs typeface="+mn-cs"/>
+              </a:rPr>
+              <a:t> - full-text search, finds "Monaco Grand Prix" by typing "</a:t>
+            </a:r>
+            <a:r>
+              <a:rPr lang="en-GB" sz="1200" b="0" i="0" u="none" strike="noStrike" kern="1200" dirty="0" err="1">
+                <a:solidFill>
+                  <a:schemeClr val="tx1"/>
+                </a:solidFill>
+                <a:effectLst/>
+                <a:latin typeface="+mn-lt"/>
+                <a:ea typeface="+mn-ea"/>
+                <a:cs typeface="+mn-cs"/>
+              </a:rPr>
+              <a:t>monaco</a:t>
+            </a:r>
+            <a:r>
+              <a:rPr lang="en-GB" sz="1200" b="0" i="0" u="none" strike="noStrike" kern="1200" dirty="0">
+                <a:solidFill>
+                  <a:schemeClr val="tx1"/>
+                </a:solidFill>
+                <a:effectLst/>
+                <a:latin typeface="+mn-lt"/>
+                <a:ea typeface="+mn-ea"/>
+                <a:cs typeface="+mn-cs"/>
+              </a:rPr>
+              <a:t>”</a:t>
+            </a:r>
+          </a:p>
+          <a:p>
+            <a:pPr marL="0" marR="0" lvl="0" indent="0" algn="l" defTabSz="914400" rtl="0" eaLnBrk="1" fontAlgn="auto" latinLnBrk="0" hangingPunct="1">
+              <a:lnSpc>
+                <a:spcPct val="100000"/>
+              </a:lnSpc>
+              <a:spcBef>
+                <a:spcPts val="0"/>
+              </a:spcBef>
+              <a:spcAft>
+                <a:spcPts val="0"/>
+              </a:spcAft>
+              <a:buClrTx/>
+              <a:buSzTx/>
+              <a:buFontTx/>
+              <a:buNone/>
+              <a:tabLst/>
+              <a:defRPr/>
+            </a:pPr>
+            <a:r>
+              <a:rPr lang="en-GB" sz="1200" b="1" i="0" kern="1200" dirty="0">
+                <a:solidFill>
+                  <a:schemeClr val="tx1"/>
+                </a:solidFill>
+                <a:effectLst/>
+                <a:latin typeface="+mn-lt"/>
+                <a:ea typeface="+mn-ea"/>
+                <a:cs typeface="+mn-cs"/>
+              </a:rPr>
+              <a:t>Fuzzy</a:t>
+            </a:r>
+            <a:r>
+              <a:rPr lang="en-GB" sz="1200" b="0" i="0" u="none" strike="noStrike" kern="1200" dirty="0">
+                <a:solidFill>
+                  <a:schemeClr val="tx1"/>
+                </a:solidFill>
+                <a:effectLst/>
+                <a:latin typeface="+mn-lt"/>
+                <a:ea typeface="+mn-ea"/>
+                <a:cs typeface="+mn-cs"/>
+              </a:rPr>
+              <a:t> - tolerates typos, "</a:t>
+            </a:r>
+            <a:r>
+              <a:rPr lang="en-GB" sz="1200" b="0" i="0" u="none" strike="noStrike" kern="1200" dirty="0" err="1">
+                <a:solidFill>
+                  <a:schemeClr val="tx1"/>
+                </a:solidFill>
+                <a:effectLst/>
+                <a:latin typeface="+mn-lt"/>
+                <a:ea typeface="+mn-ea"/>
+                <a:cs typeface="+mn-cs"/>
+              </a:rPr>
+              <a:t>Hamilten</a:t>
+            </a:r>
+            <a:r>
+              <a:rPr lang="en-GB" sz="1200" b="0" i="0" u="none" strike="noStrike" kern="1200" dirty="0">
+                <a:solidFill>
+                  <a:schemeClr val="tx1"/>
+                </a:solidFill>
+                <a:effectLst/>
+                <a:latin typeface="+mn-lt"/>
+                <a:ea typeface="+mn-ea"/>
+                <a:cs typeface="+mn-cs"/>
+              </a:rPr>
+              <a:t>" still finds "Hamilton”</a:t>
+            </a:r>
+          </a:p>
+          <a:p>
+            <a:pPr marL="0" marR="0" lvl="0" indent="0" algn="l" defTabSz="914400" rtl="0" eaLnBrk="1" fontAlgn="auto" latinLnBrk="0" hangingPunct="1">
+              <a:lnSpc>
+                <a:spcPct val="100000"/>
+              </a:lnSpc>
+              <a:spcBef>
+                <a:spcPts val="0"/>
+              </a:spcBef>
+              <a:spcAft>
+                <a:spcPts val="0"/>
+              </a:spcAft>
+              <a:buClrTx/>
+              <a:buSzTx/>
+              <a:buFontTx/>
+              <a:buNone/>
+              <a:tabLst/>
+              <a:defRPr/>
+            </a:pPr>
+            <a:r>
+              <a:rPr lang="en-GB" sz="1200" b="1" i="0" kern="1200" dirty="0">
+                <a:solidFill>
+                  <a:schemeClr val="tx1"/>
+                </a:solidFill>
+                <a:effectLst/>
+                <a:latin typeface="+mn-lt"/>
+                <a:ea typeface="+mn-ea"/>
+                <a:cs typeface="+mn-cs"/>
+              </a:rPr>
+              <a:t>Bool</a:t>
+            </a:r>
+            <a:r>
+              <a:rPr lang="en-GB" sz="1200" b="0" i="0" u="none" strike="noStrike" kern="1200" dirty="0">
+                <a:solidFill>
+                  <a:schemeClr val="tx1"/>
+                </a:solidFill>
+                <a:effectLst/>
+                <a:latin typeface="+mn-lt"/>
+                <a:ea typeface="+mn-ea"/>
+                <a:cs typeface="+mn-cs"/>
+              </a:rPr>
+              <a:t> - combines conditions, like SQL WHERE with AND/OR</a:t>
+            </a:r>
+          </a:p>
+          <a:p>
+            <a:pPr marL="0" marR="0" lvl="0" indent="0" algn="l" defTabSz="914400" rtl="0" eaLnBrk="1" fontAlgn="auto" latinLnBrk="0" hangingPunct="1">
+              <a:lnSpc>
+                <a:spcPct val="100000"/>
+              </a:lnSpc>
+              <a:spcBef>
+                <a:spcPts val="0"/>
+              </a:spcBef>
+              <a:spcAft>
+                <a:spcPts val="0"/>
+              </a:spcAft>
+              <a:buClrTx/>
+              <a:buSzTx/>
+              <a:buFontTx/>
+              <a:buNone/>
+              <a:tabLst/>
+              <a:defRPr/>
+            </a:pPr>
+            <a:r>
+              <a:rPr lang="en-GB" sz="1200" b="1" i="0" kern="1200" dirty="0">
+                <a:solidFill>
+                  <a:schemeClr val="tx1"/>
+                </a:solidFill>
+                <a:effectLst/>
+                <a:latin typeface="+mn-lt"/>
+                <a:ea typeface="+mn-ea"/>
+                <a:cs typeface="+mn-cs"/>
+              </a:rPr>
+              <a:t>Aggregation</a:t>
+            </a:r>
+            <a:r>
+              <a:rPr lang="en-GB" sz="1200" b="0" i="0" u="none" strike="noStrike" kern="1200" dirty="0">
+                <a:solidFill>
+                  <a:schemeClr val="tx1"/>
+                </a:solidFill>
+                <a:effectLst/>
+                <a:latin typeface="+mn-lt"/>
+                <a:ea typeface="+mn-ea"/>
+                <a:cs typeface="+mn-cs"/>
+              </a:rPr>
+              <a:t> - group and count, like SQL GROUP BY</a:t>
+            </a:r>
+          </a:p>
+          <a:p>
+            <a:pPr marL="0" marR="0" lvl="0" indent="0" algn="l" defTabSz="914400" rtl="0" eaLnBrk="1" fontAlgn="auto" latinLnBrk="0" hangingPunct="1">
+              <a:lnSpc>
+                <a:spcPct val="100000"/>
+              </a:lnSpc>
+              <a:spcBef>
+                <a:spcPts val="0"/>
+              </a:spcBef>
+              <a:spcAft>
+                <a:spcPts val="0"/>
+              </a:spcAft>
+              <a:buClrTx/>
+              <a:buSzTx/>
+              <a:buFontTx/>
+              <a:buNone/>
+              <a:tabLst/>
+              <a:defRPr/>
+            </a:pPr>
             <a:endParaRPr lang="en-AT" dirty="0"/>
           </a:p>
         </p:txBody>
@@ -1329,6 +1579,358 @@
               <a:rPr lang="en-AT" dirty="0"/>
               <a:t>geo_point fields allow proximity quer  ies, radius filters and map-based visualizations — used in booking platforms, logistics and asset tracking</a:t>
             </a:r>
+          </a:p>
+          <a:p>
+            <a:pPr lvl="1"/>
+            <a:r>
+              <a:rPr lang="en-GB" sz="1200" b="0" i="0" u="none" strike="noStrike" kern="1200" dirty="0">
+                <a:solidFill>
+                  <a:schemeClr val="tx1"/>
+                </a:solidFill>
+                <a:effectLst/>
+                <a:latin typeface="+mn-lt"/>
+                <a:ea typeface="+mn-ea"/>
+                <a:cs typeface="+mn-cs"/>
+              </a:rPr>
+              <a:t>Geospatial Search </a:t>
+            </a:r>
+            <a:r>
+              <a:rPr lang="en-GB" sz="1200" b="0" i="0" u="none" strike="noStrike" kern="1200" dirty="0" err="1">
+                <a:solidFill>
+                  <a:schemeClr val="tx1"/>
+                </a:solidFill>
+                <a:effectLst/>
+                <a:latin typeface="+mn-lt"/>
+                <a:ea typeface="+mn-ea"/>
+                <a:cs typeface="+mn-cs"/>
+              </a:rPr>
+              <a:t>ermöglicht</a:t>
+            </a:r>
+            <a:r>
+              <a:rPr lang="en-GB" sz="1200" b="0" i="0" u="none" strike="noStrike" kern="1200" dirty="0">
+                <a:solidFill>
+                  <a:schemeClr val="tx1"/>
+                </a:solidFill>
+                <a:effectLst/>
+                <a:latin typeface="+mn-lt"/>
+                <a:ea typeface="+mn-ea"/>
+                <a:cs typeface="+mn-cs"/>
+              </a:rPr>
+              <a:t> die </a:t>
+            </a:r>
+            <a:r>
+              <a:rPr lang="en-GB" sz="1200" b="0" i="0" u="none" strike="noStrike" kern="1200" dirty="0" err="1">
+                <a:solidFill>
+                  <a:schemeClr val="tx1"/>
+                </a:solidFill>
+                <a:effectLst/>
+                <a:latin typeface="+mn-lt"/>
+                <a:ea typeface="+mn-ea"/>
+                <a:cs typeface="+mn-cs"/>
+              </a:rPr>
+              <a:t>Suche</a:t>
+            </a:r>
+            <a:r>
+              <a:rPr lang="en-GB" sz="1200" b="0" i="0" u="none" strike="noStrike" kern="1200" dirty="0">
+                <a:solidFill>
+                  <a:schemeClr val="tx1"/>
+                </a:solidFill>
+                <a:effectLst/>
+                <a:latin typeface="+mn-lt"/>
+                <a:ea typeface="+mn-ea"/>
+                <a:cs typeface="+mn-cs"/>
+              </a:rPr>
+              <a:t> und </a:t>
+            </a:r>
+            <a:r>
+              <a:rPr lang="en-GB" sz="1200" b="0" i="0" u="none" strike="noStrike" kern="1200" dirty="0" err="1">
+                <a:solidFill>
+                  <a:schemeClr val="tx1"/>
+                </a:solidFill>
+                <a:effectLst/>
+                <a:latin typeface="+mn-lt"/>
+                <a:ea typeface="+mn-ea"/>
+                <a:cs typeface="+mn-cs"/>
+              </a:rPr>
+              <a:t>Filterung</a:t>
+            </a:r>
+            <a:r>
+              <a:rPr lang="en-GB" sz="1200" b="0" i="0" u="none" strike="noStrike" kern="1200" dirty="0">
+                <a:solidFill>
+                  <a:schemeClr val="tx1"/>
+                </a:solidFill>
+                <a:effectLst/>
+                <a:latin typeface="+mn-lt"/>
+                <a:ea typeface="+mn-ea"/>
+                <a:cs typeface="+mn-cs"/>
+              </a:rPr>
+              <a:t> von </a:t>
+            </a:r>
+            <a:r>
+              <a:rPr lang="en-GB" sz="1200" b="0" i="0" u="none" strike="noStrike" kern="1200" dirty="0" err="1">
+                <a:solidFill>
+                  <a:schemeClr val="tx1"/>
+                </a:solidFill>
+                <a:effectLst/>
+                <a:latin typeface="+mn-lt"/>
+                <a:ea typeface="+mn-ea"/>
+                <a:cs typeface="+mn-cs"/>
+              </a:rPr>
+              <a:t>Daten</a:t>
+            </a:r>
+            <a:r>
+              <a:rPr lang="en-GB" sz="1200" b="0" i="0" u="none" strike="noStrike" kern="1200" dirty="0">
+                <a:solidFill>
+                  <a:schemeClr val="tx1"/>
+                </a:solidFill>
+                <a:effectLst/>
+                <a:latin typeface="+mn-lt"/>
+                <a:ea typeface="+mn-ea"/>
+                <a:cs typeface="+mn-cs"/>
+              </a:rPr>
+              <a:t> </a:t>
+            </a:r>
+            <a:r>
+              <a:rPr lang="en-GB" sz="1200" b="0" i="0" u="none" strike="noStrike" kern="1200" dirty="0" err="1">
+                <a:solidFill>
+                  <a:schemeClr val="tx1"/>
+                </a:solidFill>
+                <a:effectLst/>
+                <a:latin typeface="+mn-lt"/>
+                <a:ea typeface="+mn-ea"/>
+                <a:cs typeface="+mn-cs"/>
+              </a:rPr>
+              <a:t>anhand</a:t>
+            </a:r>
+            <a:r>
+              <a:rPr lang="en-GB" sz="1200" b="0" i="0" u="none" strike="noStrike" kern="1200" dirty="0">
+                <a:solidFill>
+                  <a:schemeClr val="tx1"/>
+                </a:solidFill>
+                <a:effectLst/>
+                <a:latin typeface="+mn-lt"/>
+                <a:ea typeface="+mn-ea"/>
+                <a:cs typeface="+mn-cs"/>
+              </a:rPr>
+              <a:t> </a:t>
+            </a:r>
+            <a:r>
+              <a:rPr lang="en-GB" sz="1200" b="0" i="0" u="none" strike="noStrike" kern="1200" dirty="0" err="1">
+                <a:solidFill>
+                  <a:schemeClr val="tx1"/>
+                </a:solidFill>
+                <a:effectLst/>
+                <a:latin typeface="+mn-lt"/>
+                <a:ea typeface="+mn-ea"/>
+                <a:cs typeface="+mn-cs"/>
+              </a:rPr>
+              <a:t>geografischer</a:t>
+            </a:r>
+            <a:r>
+              <a:rPr lang="en-GB" sz="1200" b="0" i="0" u="none" strike="noStrike" kern="1200" dirty="0">
+                <a:solidFill>
+                  <a:schemeClr val="tx1"/>
+                </a:solidFill>
+                <a:effectLst/>
+                <a:latin typeface="+mn-lt"/>
+                <a:ea typeface="+mn-ea"/>
+                <a:cs typeface="+mn-cs"/>
+              </a:rPr>
+              <a:t> </a:t>
+            </a:r>
+            <a:r>
+              <a:rPr lang="en-GB" sz="1200" b="0" i="0" u="none" strike="noStrike" kern="1200" dirty="0" err="1">
+                <a:solidFill>
+                  <a:schemeClr val="tx1"/>
+                </a:solidFill>
+                <a:effectLst/>
+                <a:latin typeface="+mn-lt"/>
+                <a:ea typeface="+mn-ea"/>
+                <a:cs typeface="+mn-cs"/>
+              </a:rPr>
+              <a:t>Koordinaten</a:t>
+            </a:r>
+            <a:r>
+              <a:rPr lang="en-GB" sz="1200" b="0" i="0" u="none" strike="noStrike" kern="1200" dirty="0">
+                <a:solidFill>
+                  <a:schemeClr val="tx1"/>
+                </a:solidFill>
+                <a:effectLst/>
+                <a:latin typeface="+mn-lt"/>
+                <a:ea typeface="+mn-ea"/>
+                <a:cs typeface="+mn-cs"/>
+              </a:rPr>
+              <a:t>, </a:t>
+            </a:r>
+            <a:r>
+              <a:rPr lang="en-GB" sz="1200" b="0" i="0" u="none" strike="noStrike" kern="1200" dirty="0" err="1">
+                <a:solidFill>
+                  <a:schemeClr val="tx1"/>
+                </a:solidFill>
+                <a:effectLst/>
+                <a:latin typeface="+mn-lt"/>
+                <a:ea typeface="+mn-ea"/>
+                <a:cs typeface="+mn-cs"/>
+              </a:rPr>
+              <a:t>wie</a:t>
+            </a:r>
+            <a:r>
+              <a:rPr lang="en-GB" sz="1200" b="0" i="0" u="none" strike="noStrike" kern="1200" dirty="0">
+                <a:solidFill>
+                  <a:schemeClr val="tx1"/>
+                </a:solidFill>
+                <a:effectLst/>
+                <a:latin typeface="+mn-lt"/>
+                <a:ea typeface="+mn-ea"/>
+                <a:cs typeface="+mn-cs"/>
+              </a:rPr>
+              <a:t> </a:t>
+            </a:r>
+            <a:r>
+              <a:rPr lang="en-GB" sz="1200" b="0" i="0" u="none" strike="noStrike" kern="1200" dirty="0" err="1">
+                <a:solidFill>
+                  <a:schemeClr val="tx1"/>
+                </a:solidFill>
+                <a:effectLst/>
+                <a:latin typeface="+mn-lt"/>
+                <a:ea typeface="+mn-ea"/>
+                <a:cs typeface="+mn-cs"/>
+              </a:rPr>
+              <a:t>zum</a:t>
+            </a:r>
+            <a:r>
+              <a:rPr lang="en-GB" sz="1200" b="0" i="0" u="none" strike="noStrike" kern="1200" dirty="0">
+                <a:solidFill>
+                  <a:schemeClr val="tx1"/>
+                </a:solidFill>
+                <a:effectLst/>
+                <a:latin typeface="+mn-lt"/>
+                <a:ea typeface="+mn-ea"/>
+                <a:cs typeface="+mn-cs"/>
+              </a:rPr>
+              <a:t> </a:t>
+            </a:r>
+            <a:r>
+              <a:rPr lang="en-GB" sz="1200" b="0" i="0" u="none" strike="noStrike" kern="1200" dirty="0" err="1">
+                <a:solidFill>
+                  <a:schemeClr val="tx1"/>
+                </a:solidFill>
+                <a:effectLst/>
+                <a:latin typeface="+mn-lt"/>
+                <a:ea typeface="+mn-ea"/>
+                <a:cs typeface="+mn-cs"/>
+              </a:rPr>
+              <a:t>Beispiel</a:t>
+            </a:r>
+            <a:r>
+              <a:rPr lang="en-GB" sz="1200" b="0" i="0" u="none" strike="noStrike" kern="1200" dirty="0">
+                <a:solidFill>
+                  <a:schemeClr val="tx1"/>
+                </a:solidFill>
+                <a:effectLst/>
+                <a:latin typeface="+mn-lt"/>
+                <a:ea typeface="+mn-ea"/>
+                <a:cs typeface="+mn-cs"/>
+              </a:rPr>
+              <a:t> das </a:t>
+            </a:r>
+            <a:r>
+              <a:rPr lang="en-GB" sz="1200" b="0" i="0" u="none" strike="noStrike" kern="1200" dirty="0" err="1">
+                <a:solidFill>
+                  <a:schemeClr val="tx1"/>
+                </a:solidFill>
+                <a:effectLst/>
+                <a:latin typeface="+mn-lt"/>
+                <a:ea typeface="+mn-ea"/>
+                <a:cs typeface="+mn-cs"/>
+              </a:rPr>
+              <a:t>Anzeigen</a:t>
+            </a:r>
+            <a:r>
+              <a:rPr lang="en-GB" sz="1200" b="0" i="0" u="none" strike="noStrike" kern="1200" dirty="0">
+                <a:solidFill>
+                  <a:schemeClr val="tx1"/>
+                </a:solidFill>
+                <a:effectLst/>
+                <a:latin typeface="+mn-lt"/>
+                <a:ea typeface="+mn-ea"/>
+                <a:cs typeface="+mn-cs"/>
+              </a:rPr>
+              <a:t> </a:t>
+            </a:r>
+            <a:r>
+              <a:rPr lang="en-GB" sz="1200" b="0" i="0" u="none" strike="noStrike" kern="1200" dirty="0" err="1">
+                <a:solidFill>
+                  <a:schemeClr val="tx1"/>
+                </a:solidFill>
+                <a:effectLst/>
+                <a:latin typeface="+mn-lt"/>
+                <a:ea typeface="+mn-ea"/>
+                <a:cs typeface="+mn-cs"/>
+              </a:rPr>
+              <a:t>aller</a:t>
+            </a:r>
+            <a:r>
+              <a:rPr lang="en-GB" sz="1200" b="0" i="0" u="none" strike="noStrike" kern="1200" dirty="0">
+                <a:solidFill>
+                  <a:schemeClr val="tx1"/>
+                </a:solidFill>
+                <a:effectLst/>
+                <a:latin typeface="+mn-lt"/>
+                <a:ea typeface="+mn-ea"/>
+                <a:cs typeface="+mn-cs"/>
+              </a:rPr>
+              <a:t> F1-Strecken auf </a:t>
+            </a:r>
+            <a:r>
+              <a:rPr lang="en-GB" sz="1200" b="0" i="0" u="none" strike="noStrike" kern="1200" dirty="0" err="1">
+                <a:solidFill>
+                  <a:schemeClr val="tx1"/>
+                </a:solidFill>
+                <a:effectLst/>
+                <a:latin typeface="+mn-lt"/>
+                <a:ea typeface="+mn-ea"/>
+                <a:cs typeface="+mn-cs"/>
+              </a:rPr>
+              <a:t>einer</a:t>
+            </a:r>
+            <a:r>
+              <a:rPr lang="en-GB" sz="1200" b="0" i="0" u="none" strike="noStrike" kern="1200" dirty="0">
+                <a:solidFill>
+                  <a:schemeClr val="tx1"/>
+                </a:solidFill>
+                <a:effectLst/>
+                <a:latin typeface="+mn-lt"/>
+                <a:ea typeface="+mn-ea"/>
+                <a:cs typeface="+mn-cs"/>
+              </a:rPr>
+              <a:t> </a:t>
+            </a:r>
+            <a:r>
+              <a:rPr lang="en-GB" sz="1200" b="0" i="0" u="none" strike="noStrike" kern="1200" dirty="0" err="1">
+                <a:solidFill>
+                  <a:schemeClr val="tx1"/>
+                </a:solidFill>
+                <a:effectLst/>
+                <a:latin typeface="+mn-lt"/>
+                <a:ea typeface="+mn-ea"/>
+                <a:cs typeface="+mn-cs"/>
+              </a:rPr>
+              <a:t>Weltkarte</a:t>
+            </a:r>
+            <a:r>
+              <a:rPr lang="en-GB" sz="1200" b="0" i="0" u="none" strike="noStrike" kern="1200" dirty="0">
+                <a:solidFill>
+                  <a:schemeClr val="tx1"/>
+                </a:solidFill>
+                <a:effectLst/>
+                <a:latin typeface="+mn-lt"/>
+                <a:ea typeface="+mn-ea"/>
+                <a:cs typeface="+mn-cs"/>
+              </a:rPr>
+              <a:t>.</a:t>
+            </a:r>
+            <a:endParaRPr lang="en-AT" dirty="0"/>
           </a:p>
         </p:txBody>
       </p:sp>

</xml_diff>

<commit_message>
hide slide in presentation
</commit_message>
<xml_diff>
--- a/Elasticsearch.pptx
+++ b/Elasticsearch.pptx
@@ -216,7 +216,7 @@
           <a:p>
             <a:fld id="{17C1BCD2-C187-B342-9D66-FD6DDE94747E}" type="datetimeFigureOut">
               <a:rPr lang="en-AT" smtClean="0"/>
-              <a:t>15.05.26</a:t>
+              <a:t>16.05.26</a:t>
             </a:fld>
             <a:endParaRPr lang="en-AT"/>
           </a:p>
@@ -4996,7 +4996,7 @@
           <a:p>
             <a:fld id="{A591BDEC-81C3-DB48-92B3-4E74693DD55D}" type="datetimeFigureOut">
               <a:rPr lang="en-AT" smtClean="0"/>
-              <a:t>15.05.26</a:t>
+              <a:t>16.05.26</a:t>
             </a:fld>
             <a:endParaRPr lang="en-AT"/>
           </a:p>
@@ -5661,7 +5661,7 @@
           <a:p>
             <a:fld id="{A591BDEC-81C3-DB48-92B3-4E74693DD55D}" type="datetimeFigureOut">
               <a:rPr lang="en-AT" smtClean="0"/>
-              <a:t>15.05.26</a:t>
+              <a:t>16.05.26</a:t>
             </a:fld>
             <a:endParaRPr lang="en-AT"/>
           </a:p>
@@ -5871,7 +5871,7 @@
           <a:p>
             <a:fld id="{A591BDEC-81C3-DB48-92B3-4E74693DD55D}" type="datetimeFigureOut">
               <a:rPr lang="en-AT" smtClean="0"/>
-              <a:t>15.05.26</a:t>
+              <a:t>16.05.26</a:t>
             </a:fld>
             <a:endParaRPr lang="en-AT"/>
           </a:p>
@@ -6072,7 +6072,7 @@
             <a:fld id="{2C923EFC-C784-AC46-AE3C-8E1B6BCAD649}" type="datetime1">
               <a:rPr lang="en-US" smtClean="0"/>
               <a:pPr/>
-              <a:t>5/15/26</a:t>
+              <a:t>5/16/26</a:t>
             </a:fld>
             <a:endParaRPr lang="en-AT" dirty="0"/>
           </a:p>
@@ -7080,7 +7080,7 @@
           <a:p>
             <a:fld id="{A591BDEC-81C3-DB48-92B3-4E74693DD55D}" type="datetimeFigureOut">
               <a:rPr lang="en-AT" smtClean="0"/>
-              <a:t>15.05.26</a:t>
+              <a:t>16.05.26</a:t>
             </a:fld>
             <a:endParaRPr lang="en-AT"/>
           </a:p>
@@ -7813,7 +7813,7 @@
           <a:p>
             <a:fld id="{A591BDEC-81C3-DB48-92B3-4E74693DD55D}" type="datetimeFigureOut">
               <a:rPr lang="en-AT" smtClean="0"/>
-              <a:t>15.05.26</a:t>
+              <a:t>16.05.26</a:t>
             </a:fld>
             <a:endParaRPr lang="en-AT"/>
           </a:p>
@@ -8960,7 +8960,7 @@
           <a:p>
             <a:fld id="{A591BDEC-81C3-DB48-92B3-4E74693DD55D}" type="datetimeFigureOut">
               <a:rPr lang="en-AT" smtClean="0"/>
-              <a:t>15.05.26</a:t>
+              <a:t>16.05.26</a:t>
             </a:fld>
             <a:endParaRPr lang="en-AT"/>
           </a:p>
@@ -9834,7 +9834,7 @@
           <a:p>
             <a:fld id="{A591BDEC-81C3-DB48-92B3-4E74693DD55D}" type="datetimeFigureOut">
               <a:rPr lang="en-AT" smtClean="0"/>
-              <a:t>15.05.26</a:t>
+              <a:t>16.05.26</a:t>
             </a:fld>
             <a:endParaRPr lang="en-AT"/>
           </a:p>
@@ -10679,7 +10679,7 @@
           <a:p>
             <a:fld id="{A591BDEC-81C3-DB48-92B3-4E74693DD55D}" type="datetimeFigureOut">
               <a:rPr lang="en-AT" smtClean="0"/>
-              <a:t>15.05.26</a:t>
+              <a:t>16.05.26</a:t>
             </a:fld>
             <a:endParaRPr lang="en-AT"/>
           </a:p>
@@ -11724,7 +11724,7 @@
           <a:p>
             <a:fld id="{A591BDEC-81C3-DB48-92B3-4E74693DD55D}" type="datetimeFigureOut">
               <a:rPr lang="en-AT" smtClean="0"/>
-              <a:t>15.05.26</a:t>
+              <a:t>16.05.26</a:t>
             </a:fld>
             <a:endParaRPr lang="en-AT"/>
           </a:p>
@@ -12478,7 +12478,7 @@
           <a:p>
             <a:fld id="{A591BDEC-81C3-DB48-92B3-4E74693DD55D}" type="datetimeFigureOut">
               <a:rPr lang="en-AT" smtClean="0"/>
-              <a:t>15.05.26</a:t>
+              <a:t>16.05.26</a:t>
             </a:fld>
             <a:endParaRPr lang="en-AT"/>
           </a:p>
@@ -13150,7 +13150,7 @@
           <a:p>
             <a:fld id="{A591BDEC-81C3-DB48-92B3-4E74693DD55D}" type="datetimeFigureOut">
               <a:rPr lang="en-AT" smtClean="0"/>
-              <a:t>15.05.26</a:t>
+              <a:t>16.05.26</a:t>
             </a:fld>
             <a:endParaRPr lang="en-AT"/>
           </a:p>
@@ -13691,7 +13691,7 @@
           <a:p>
             <a:fld id="{343E18A4-A905-2445-944B-CEA2A38DE8BE}" type="datetime4">
               <a:rPr lang="en-AT" sz="1600"/>
-              <a:t>15. May 2026</a:t>
+              <a:t>16. May 2026</a:t>
             </a:fld>
             <a:endParaRPr lang="en-AT" sz="1600" dirty="0"/>
           </a:p>
@@ -14794,7 +14794,7 @@
 </file>
 
 <file path=ppt/slides/slide16.xml><?xml version="1.0" encoding="utf-8"?>
-<p:sld xmlns:a="http://schemas.openxmlformats.org/drawingml/2006/main" xmlns:r="http://schemas.openxmlformats.org/officeDocument/2006/relationships" xmlns:p="http://schemas.openxmlformats.org/presentationml/2006/main">
+<p:sld xmlns:a="http://schemas.openxmlformats.org/drawingml/2006/main" xmlns:r="http://schemas.openxmlformats.org/officeDocument/2006/relationships" xmlns:p="http://schemas.openxmlformats.org/presentationml/2006/main" show="0">
   <p:cSld>
     <p:spTree>
       <p:nvGrpSpPr>
@@ -15000,7 +15000,7 @@
 </file>
 
 <file path=ppt/slides/slide17.xml><?xml version="1.0" encoding="utf-8"?>
-<p:sld xmlns:a="http://schemas.openxmlformats.org/drawingml/2006/main" xmlns:r="http://schemas.openxmlformats.org/officeDocument/2006/relationships" xmlns:p="http://schemas.openxmlformats.org/presentationml/2006/main">
+<p:sld xmlns:a="http://schemas.openxmlformats.org/drawingml/2006/main" xmlns:r="http://schemas.openxmlformats.org/officeDocument/2006/relationships" xmlns:p="http://schemas.openxmlformats.org/presentationml/2006/main" show="0">
   <p:cSld>
     <p:spTree>
       <p:nvGrpSpPr>
@@ -15164,7 +15164,7 @@
 </file>
 
 <file path=ppt/slides/slide18.xml><?xml version="1.0" encoding="utf-8"?>
-<p:sld xmlns:a="http://schemas.openxmlformats.org/drawingml/2006/main" xmlns:r="http://schemas.openxmlformats.org/officeDocument/2006/relationships" xmlns:p="http://schemas.openxmlformats.org/presentationml/2006/main">
+<p:sld xmlns:a="http://schemas.openxmlformats.org/drawingml/2006/main" xmlns:r="http://schemas.openxmlformats.org/officeDocument/2006/relationships" xmlns:p="http://schemas.openxmlformats.org/presentationml/2006/main" show="0">
   <p:cSld>
     <p:spTree>
       <p:nvGrpSpPr>

</xml_diff>

<commit_message>
changes on slide in presentation
</commit_message>
<xml_diff>
--- a/Elasticsearch.pptx
+++ b/Elasticsearch.pptx
@@ -216,7 +216,7 @@
           <a:p>
             <a:fld id="{17C1BCD2-C187-B342-9D66-FD6DDE94747E}" type="datetimeFigureOut">
               <a:rPr lang="en-AT" smtClean="0"/>
-              <a:t>16.05.26</a:t>
+              <a:t>17.05.26</a:t>
             </a:fld>
             <a:endParaRPr lang="en-AT"/>
           </a:p>
@@ -4996,7 +4996,7 @@
           <a:p>
             <a:fld id="{A591BDEC-81C3-DB48-92B3-4E74693DD55D}" type="datetimeFigureOut">
               <a:rPr lang="en-AT" smtClean="0"/>
-              <a:t>16.05.26</a:t>
+              <a:t>17.05.26</a:t>
             </a:fld>
             <a:endParaRPr lang="en-AT"/>
           </a:p>
@@ -5661,7 +5661,7 @@
           <a:p>
             <a:fld id="{A591BDEC-81C3-DB48-92B3-4E74693DD55D}" type="datetimeFigureOut">
               <a:rPr lang="en-AT" smtClean="0"/>
-              <a:t>16.05.26</a:t>
+              <a:t>17.05.26</a:t>
             </a:fld>
             <a:endParaRPr lang="en-AT"/>
           </a:p>
@@ -5871,7 +5871,7 @@
           <a:p>
             <a:fld id="{A591BDEC-81C3-DB48-92B3-4E74693DD55D}" type="datetimeFigureOut">
               <a:rPr lang="en-AT" smtClean="0"/>
-              <a:t>16.05.26</a:t>
+              <a:t>17.05.26</a:t>
             </a:fld>
             <a:endParaRPr lang="en-AT"/>
           </a:p>
@@ -6072,7 +6072,7 @@
             <a:fld id="{2C923EFC-C784-AC46-AE3C-8E1B6BCAD649}" type="datetime1">
               <a:rPr lang="en-US" smtClean="0"/>
               <a:pPr/>
-              <a:t>5/16/26</a:t>
+              <a:t>5/17/26</a:t>
             </a:fld>
             <a:endParaRPr lang="en-AT" dirty="0"/>
           </a:p>
@@ -7080,7 +7080,7 @@
           <a:p>
             <a:fld id="{A591BDEC-81C3-DB48-92B3-4E74693DD55D}" type="datetimeFigureOut">
               <a:rPr lang="en-AT" smtClean="0"/>
-              <a:t>16.05.26</a:t>
+              <a:t>17.05.26</a:t>
             </a:fld>
             <a:endParaRPr lang="en-AT"/>
           </a:p>
@@ -7813,7 +7813,7 @@
           <a:p>
             <a:fld id="{A591BDEC-81C3-DB48-92B3-4E74693DD55D}" type="datetimeFigureOut">
               <a:rPr lang="en-AT" smtClean="0"/>
-              <a:t>16.05.26</a:t>
+              <a:t>17.05.26</a:t>
             </a:fld>
             <a:endParaRPr lang="en-AT"/>
           </a:p>
@@ -8960,7 +8960,7 @@
           <a:p>
             <a:fld id="{A591BDEC-81C3-DB48-92B3-4E74693DD55D}" type="datetimeFigureOut">
               <a:rPr lang="en-AT" smtClean="0"/>
-              <a:t>16.05.26</a:t>
+              <a:t>17.05.26</a:t>
             </a:fld>
             <a:endParaRPr lang="en-AT"/>
           </a:p>
@@ -9834,7 +9834,7 @@
           <a:p>
             <a:fld id="{A591BDEC-81C3-DB48-92B3-4E74693DD55D}" type="datetimeFigureOut">
               <a:rPr lang="en-AT" smtClean="0"/>
-              <a:t>16.05.26</a:t>
+              <a:t>17.05.26</a:t>
             </a:fld>
             <a:endParaRPr lang="en-AT"/>
           </a:p>
@@ -10679,7 +10679,7 @@
           <a:p>
             <a:fld id="{A591BDEC-81C3-DB48-92B3-4E74693DD55D}" type="datetimeFigureOut">
               <a:rPr lang="en-AT" smtClean="0"/>
-              <a:t>16.05.26</a:t>
+              <a:t>17.05.26</a:t>
             </a:fld>
             <a:endParaRPr lang="en-AT"/>
           </a:p>
@@ -11724,7 +11724,7 @@
           <a:p>
             <a:fld id="{A591BDEC-81C3-DB48-92B3-4E74693DD55D}" type="datetimeFigureOut">
               <a:rPr lang="en-AT" smtClean="0"/>
-              <a:t>16.05.26</a:t>
+              <a:t>17.05.26</a:t>
             </a:fld>
             <a:endParaRPr lang="en-AT"/>
           </a:p>
@@ -12478,7 +12478,7 @@
           <a:p>
             <a:fld id="{A591BDEC-81C3-DB48-92B3-4E74693DD55D}" type="datetimeFigureOut">
               <a:rPr lang="en-AT" smtClean="0"/>
-              <a:t>16.05.26</a:t>
+              <a:t>17.05.26</a:t>
             </a:fld>
             <a:endParaRPr lang="en-AT"/>
           </a:p>
@@ -13150,7 +13150,7 @@
           <a:p>
             <a:fld id="{A591BDEC-81C3-DB48-92B3-4E74693DD55D}" type="datetimeFigureOut">
               <a:rPr lang="en-AT" smtClean="0"/>
-              <a:t>16.05.26</a:t>
+              <a:t>17.05.26</a:t>
             </a:fld>
             <a:endParaRPr lang="en-AT"/>
           </a:p>
@@ -13691,7 +13691,7 @@
           <a:p>
             <a:fld id="{343E18A4-A905-2445-944B-CEA2A38DE8BE}" type="datetime4">
               <a:rPr lang="en-AT" sz="1600"/>
-              <a:t>16. May 2026</a:t>
+              <a:t>17. May 2026</a:t>
             </a:fld>
             <a:endParaRPr lang="en-AT" sz="1600" dirty="0"/>
           </a:p>
@@ -16588,9 +16588,10 @@
           </a:p>
           <a:p>
             <a:r>
-              <a:rPr lang="en-AT" dirty="0"/>
-              <a:t>Open-source, distributed search and analytics engine</a:t>
-            </a:r>
+              <a:rPr lang="en-AT"/>
+              <a:t>Open-source</a:t>
+            </a:r>
+            <a:endParaRPr lang="en-AT" dirty="0"/>
           </a:p>
           <a:p>
             <a:r>

</xml_diff>

<commit_message>
changes f1_queries.py and updated Elasticsearch presentation
</commit_message>
<xml_diff>
--- a/Elasticsearch.pptx
+++ b/Elasticsearch.pptx
@@ -216,7 +216,7 @@
           <a:p>
             <a:fld id="{17C1BCD2-C187-B342-9D66-FD6DDE94747E}" type="datetimeFigureOut">
               <a:rPr lang="en-AT" smtClean="0"/>
-              <a:t>17.05.26</a:t>
+              <a:t>18.05.26</a:t>
             </a:fld>
             <a:endParaRPr lang="en-AT"/>
           </a:p>
@@ -1595,7 +1595,7 @@
               <a:t>Geospatial Search </a:t>
             </a:r>
             <a:r>
-              <a:rPr lang="en-GB" sz="1200" b="0" i="0" u="none" strike="noStrike" kern="1200" dirty="0" err="1">
+              <a:rPr lang="en-GB" sz="1200" b="0" i="0" u="none" strike="noStrike" kern="1200">
                 <a:solidFill>
                   <a:schemeClr val="tx1"/>
                 </a:solidFill>
@@ -1604,7 +1604,7 @@
                 <a:ea typeface="+mn-ea"/>
                 <a:cs typeface="+mn-cs"/>
               </a:rPr>
-              <a:t>ermöglicht</a:t>
+              <a:t>GEODATEN SUCHE ermöglicht</a:t>
             </a:r>
             <a:r>
               <a:rPr lang="en-GB" sz="1200" b="0" i="0" u="none" strike="noStrike" kern="1200" dirty="0">
@@ -4996,7 +4996,7 @@
           <a:p>
             <a:fld id="{A591BDEC-81C3-DB48-92B3-4E74693DD55D}" type="datetimeFigureOut">
               <a:rPr lang="en-AT" smtClean="0"/>
-              <a:t>17.05.26</a:t>
+              <a:t>18.05.26</a:t>
             </a:fld>
             <a:endParaRPr lang="en-AT"/>
           </a:p>
@@ -5661,7 +5661,7 @@
           <a:p>
             <a:fld id="{A591BDEC-81C3-DB48-92B3-4E74693DD55D}" type="datetimeFigureOut">
               <a:rPr lang="en-AT" smtClean="0"/>
-              <a:t>17.05.26</a:t>
+              <a:t>18.05.26</a:t>
             </a:fld>
             <a:endParaRPr lang="en-AT"/>
           </a:p>
@@ -5871,7 +5871,7 @@
           <a:p>
             <a:fld id="{A591BDEC-81C3-DB48-92B3-4E74693DD55D}" type="datetimeFigureOut">
               <a:rPr lang="en-AT" smtClean="0"/>
-              <a:t>17.05.26</a:t>
+              <a:t>18.05.26</a:t>
             </a:fld>
             <a:endParaRPr lang="en-AT"/>
           </a:p>
@@ -6072,7 +6072,7 @@
             <a:fld id="{2C923EFC-C784-AC46-AE3C-8E1B6BCAD649}" type="datetime1">
               <a:rPr lang="en-US" smtClean="0"/>
               <a:pPr/>
-              <a:t>5/17/26</a:t>
+              <a:t>5/18/26</a:t>
             </a:fld>
             <a:endParaRPr lang="en-AT" dirty="0"/>
           </a:p>
@@ -7080,7 +7080,7 @@
           <a:p>
             <a:fld id="{A591BDEC-81C3-DB48-92B3-4E74693DD55D}" type="datetimeFigureOut">
               <a:rPr lang="en-AT" smtClean="0"/>
-              <a:t>17.05.26</a:t>
+              <a:t>18.05.26</a:t>
             </a:fld>
             <a:endParaRPr lang="en-AT"/>
           </a:p>
@@ -7813,7 +7813,7 @@
           <a:p>
             <a:fld id="{A591BDEC-81C3-DB48-92B3-4E74693DD55D}" type="datetimeFigureOut">
               <a:rPr lang="en-AT" smtClean="0"/>
-              <a:t>17.05.26</a:t>
+              <a:t>18.05.26</a:t>
             </a:fld>
             <a:endParaRPr lang="en-AT"/>
           </a:p>
@@ -8960,7 +8960,7 @@
           <a:p>
             <a:fld id="{A591BDEC-81C3-DB48-92B3-4E74693DD55D}" type="datetimeFigureOut">
               <a:rPr lang="en-AT" smtClean="0"/>
-              <a:t>17.05.26</a:t>
+              <a:t>18.05.26</a:t>
             </a:fld>
             <a:endParaRPr lang="en-AT"/>
           </a:p>
@@ -9834,7 +9834,7 @@
           <a:p>
             <a:fld id="{A591BDEC-81C3-DB48-92B3-4E74693DD55D}" type="datetimeFigureOut">
               <a:rPr lang="en-AT" smtClean="0"/>
-              <a:t>17.05.26</a:t>
+              <a:t>18.05.26</a:t>
             </a:fld>
             <a:endParaRPr lang="en-AT"/>
           </a:p>
@@ -10679,7 +10679,7 @@
           <a:p>
             <a:fld id="{A591BDEC-81C3-DB48-92B3-4E74693DD55D}" type="datetimeFigureOut">
               <a:rPr lang="en-AT" smtClean="0"/>
-              <a:t>17.05.26</a:t>
+              <a:t>18.05.26</a:t>
             </a:fld>
             <a:endParaRPr lang="en-AT"/>
           </a:p>
@@ -11724,7 +11724,7 @@
           <a:p>
             <a:fld id="{A591BDEC-81C3-DB48-92B3-4E74693DD55D}" type="datetimeFigureOut">
               <a:rPr lang="en-AT" smtClean="0"/>
-              <a:t>17.05.26</a:t>
+              <a:t>18.05.26</a:t>
             </a:fld>
             <a:endParaRPr lang="en-AT"/>
           </a:p>
@@ -12478,7 +12478,7 @@
           <a:p>
             <a:fld id="{A591BDEC-81C3-DB48-92B3-4E74693DD55D}" type="datetimeFigureOut">
               <a:rPr lang="en-AT" smtClean="0"/>
-              <a:t>17.05.26</a:t>
+              <a:t>18.05.26</a:t>
             </a:fld>
             <a:endParaRPr lang="en-AT"/>
           </a:p>
@@ -13150,7 +13150,7 @@
           <a:p>
             <a:fld id="{A591BDEC-81C3-DB48-92B3-4E74693DD55D}" type="datetimeFigureOut">
               <a:rPr lang="en-AT" smtClean="0"/>
-              <a:t>17.05.26</a:t>
+              <a:t>18.05.26</a:t>
             </a:fld>
             <a:endParaRPr lang="en-AT"/>
           </a:p>
@@ -13691,7 +13691,7 @@
           <a:p>
             <a:fld id="{343E18A4-A905-2445-944B-CEA2A38DE8BE}" type="datetime4">
               <a:rPr lang="en-AT" sz="1600"/>
-              <a:t>17. May 2026</a:t>
+              <a:t>18. May 2026</a:t>
             </a:fld>
             <a:endParaRPr lang="en-AT" sz="1600" dirty="0"/>
           </a:p>

</xml_diff>

<commit_message>
some changes in pptx
</commit_message>
<xml_diff>
--- a/Elasticsearch.pptx
+++ b/Elasticsearch.pptx
@@ -1592,10 +1592,10 @@
                 <a:ea typeface="+mn-ea"/>
                 <a:cs typeface="+mn-cs"/>
               </a:rPr>
-              <a:t>Geospatial Search </a:t>
-            </a:r>
-            <a:r>
-              <a:rPr lang="en-GB" sz="1200" b="0" i="0" u="none" strike="noStrike" kern="1200">
+              <a:t>Geospatial Search GEODATEN SUCHE </a:t>
+            </a:r>
+            <a:r>
+              <a:rPr lang="en-GB" sz="1200" b="0" i="0" u="none" strike="noStrike" kern="1200" dirty="0" err="1">
                 <a:solidFill>
                   <a:schemeClr val="tx1"/>
                 </a:solidFill>
@@ -1604,7 +1604,7 @@
                 <a:ea typeface="+mn-ea"/>
                 <a:cs typeface="+mn-cs"/>
               </a:rPr>
-              <a:t>GEODATEN SUCHE ermöglicht</a:t>
+              <a:t>ermöglicht</a:t>
             </a:r>
             <a:r>
               <a:rPr lang="en-GB" sz="1200" b="0" i="0" u="none" strike="noStrike" kern="1200" dirty="0">

</xml_diff>